<commit_message>
Refine Going presentation narrative and verify README documentation
</commit_message>
<xml_diff>
--- a/docs/presentation/going-class-presentation.pptx
+++ b/docs/presentation/going-class-presentation.pptx
@@ -2,22 +2,22 @@
 <file path=ppt/presentation.xml><?xml version="1.0" encoding="utf-8"?>
 <p:presentation xmlns:p="http://schemas.openxmlformats.org/presentationml/2006/main">
   <p:sldMasterIdLst>
-    <p:sldMasterId xmlns:r="http://schemas.openxmlformats.org/officeDocument/2006/relationships" id="2147483648" r:id="Rf714e164d70c4b38"/>
+    <p:sldMasterId xmlns:r="http://schemas.openxmlformats.org/officeDocument/2006/relationships" id="2147483648" r:id="Re30fe4e888844e16"/>
   </p:sldMasterIdLst>
   <p:notesMasterIdLst>
-    <p:notesMasterId xmlns:r="http://schemas.openxmlformats.org/officeDocument/2006/relationships" r:id="R30505cfb5f034e75"/>
+    <p:notesMasterId xmlns:r="http://schemas.openxmlformats.org/officeDocument/2006/relationships" r:id="R542fb7d48bda40be"/>
   </p:notesMasterIdLst>
   <p:sldIdLst>
-    <p:sldId xmlns:r="http://schemas.openxmlformats.org/officeDocument/2006/relationships" id="256" r:id="R1b17437b5efa427a"/>
-    <p:sldId xmlns:r="http://schemas.openxmlformats.org/officeDocument/2006/relationships" id="257" r:id="Re28a40272b254ce3"/>
-    <p:sldId xmlns:r="http://schemas.openxmlformats.org/officeDocument/2006/relationships" id="258" r:id="R52b25ebeca8343d8"/>
-    <p:sldId xmlns:r="http://schemas.openxmlformats.org/officeDocument/2006/relationships" id="259" r:id="R3d41daf9852f42c2"/>
-    <p:sldId xmlns:r="http://schemas.openxmlformats.org/officeDocument/2006/relationships" id="260" r:id="Rbc1e3d891c094bb6"/>
-    <p:sldId xmlns:r="http://schemas.openxmlformats.org/officeDocument/2006/relationships" id="261" r:id="Rd88514760bd74f60"/>
-    <p:sldId xmlns:r="http://schemas.openxmlformats.org/officeDocument/2006/relationships" id="262" r:id="Rf670e793d0194774"/>
-    <p:sldId xmlns:r="http://schemas.openxmlformats.org/officeDocument/2006/relationships" id="263" r:id="Rac5418f7ac2a49ee"/>
-    <p:sldId xmlns:r="http://schemas.openxmlformats.org/officeDocument/2006/relationships" id="264" r:id="Ra97fa64a64a046b6"/>
-    <p:sldId xmlns:r="http://schemas.openxmlformats.org/officeDocument/2006/relationships" id="265" r:id="R5f41b9857390433e"/>
+    <p:sldId xmlns:r="http://schemas.openxmlformats.org/officeDocument/2006/relationships" id="256" r:id="R45730f85d51048b8"/>
+    <p:sldId xmlns:r="http://schemas.openxmlformats.org/officeDocument/2006/relationships" id="257" r:id="R81d7e7850959412b"/>
+    <p:sldId xmlns:r="http://schemas.openxmlformats.org/officeDocument/2006/relationships" id="258" r:id="R2bc66fc8f954423a"/>
+    <p:sldId xmlns:r="http://schemas.openxmlformats.org/officeDocument/2006/relationships" id="259" r:id="Rac7273d7ec9f4474"/>
+    <p:sldId xmlns:r="http://schemas.openxmlformats.org/officeDocument/2006/relationships" id="260" r:id="Reebdcff3f74d4e9f"/>
+    <p:sldId xmlns:r="http://schemas.openxmlformats.org/officeDocument/2006/relationships" id="261" r:id="Rea0fe35bc94c405e"/>
+    <p:sldId xmlns:r="http://schemas.openxmlformats.org/officeDocument/2006/relationships" id="262" r:id="R6a9e230289e3416c"/>
+    <p:sldId xmlns:r="http://schemas.openxmlformats.org/officeDocument/2006/relationships" id="263" r:id="R0bb2364071d24766"/>
+    <p:sldId xmlns:r="http://schemas.openxmlformats.org/officeDocument/2006/relationships" id="264" r:id="R04336f080d7a4bf3"/>
+    <p:sldId xmlns:r="http://schemas.openxmlformats.org/officeDocument/2006/relationships" id="265" r:id="R7ff84a08e6414f86"/>
   </p:sldIdLst>
   <p:sldSz cx="12192000" cy="6858000"/>
   <p:notesSz cx="6858000" cy="9144000"/>
@@ -451,12 +451,27 @@
           <a:lstStyle xmlns:a="http://schemas.openxmlformats.org/drawingml/2006/main"/>
           <a:p xmlns:a="http://schemas.openxmlformats.org/drawingml/2006/main">
             <a:r>
-              <a:t>[목표 시간 30초]</a:t>
-            </a:r>
-          </a:p>
-          <a:p xmlns:a="http://schemas.openxmlformats.org/drawingml/2006/main">
-            <a:r>
-              <a:t>안녕하세요. 이번에 만든 여행 준비 서비스, 고잉을 소개하겠습니다. 여행을 준비하다 보면 항공권이나 숙소는 이미 예약했는데, 막상 필요한 정보를 찾으려고 하면 메일함과 지도, 메모를 다시 오가게 됩니다. 고잉은 이렇게 흩어진 정보를 한 여행 안에 모으고, 가고 싶은 장소를 실제 일정으로 연결해 보자는 생각에서 시작했습니다. 오늘은 어떤 문제를 해결하려고 했는지, 실제 화면은 어떻게 동작하는지, 그리고 만들면서 어떤 부분을 고쳤는지 순서대로 말씀드리겠습니다.</a:t>
+              <a:t>[목표 30초 / 행동: 표지를 보며 서비스 이름을 또렷하게 말합니다.]</a:t>
+            </a:r>
+          </a:p>
+          <a:p xmlns:a="http://schemas.openxmlformats.org/drawingml/2006/main">
+            <a:r>
+              <a:t/>
+            </a:r>
+          </a:p>
+          <a:p xmlns:a="http://schemas.openxmlformats.org/drawingml/2006/main">
+            <a:r>
+              <a:t>안녕하세요. 제가 만든 여행 준비 서비스, 고잉을 소개하겠습니다.</a:t>
+            </a:r>
+          </a:p>
+          <a:p xmlns:a="http://schemas.openxmlformats.org/drawingml/2006/main">
+            <a:r>
+              <a:t/>
+            </a:r>
+          </a:p>
+          <a:p xmlns:a="http://schemas.openxmlformats.org/drawingml/2006/main">
+            <a:r>
+              <a:t>여행을 예약하고 나서도 메일함과 지도, 메모를 계속 오가게 되는데요. 그 과정을 한곳에서 이어서 할 수 있으면 좋겠다는 생각으로 만들었습니다. 예약 정리부터 장소 선택, 일정 편집까지 실제 화면과 함께 보여드리겠습니다.</a:t>
             </a:r>
           </a:p>
           <a:p xmlns:a="http://schemas.openxmlformats.org/drawingml/2006/main">
@@ -541,12 +556,37 @@
           <a:lstStyle xmlns:a="http://schemas.openxmlformats.org/drawingml/2006/main"/>
           <a:p xmlns:a="http://schemas.openxmlformats.org/drawingml/2006/main">
             <a:r>
-              <a:t>[목표 시간 50초]</a:t>
-            </a:r>
-          </a:p>
-          <a:p xmlns:a="http://schemas.openxmlformats.org/drawingml/2006/main">
-            <a:r>
-              <a:t>현재는 초대한 소수 사용자가 접속하는 비공개 베타로 배포했습니다. 여행과 예약 관리, 장소 탐색, 일정 생성과 편집까지 한 흐름으로 연결했습니다. 최근 전체 회귀 시험은 Python 1,039개와 JavaScript 124개가 통과했고, 외부 환경이 필요한 시험 15개는 건너뛴 상태로 따로 기록했습니다. 그렇다고 추천 품질까지 검증됐다는 뜻은 아닙니다. 100개 도시를 선택할 수 있지만 도시마다 확보한 장소 자료는 다르고, 실제 사용자의 만족도는 아직 측정하지 않았습니다. 무료 환경에서는 검색과 화면을 불러오는 데 시간이 걸리는 점도 남아 있습니다. 앞으로는 기능을 더 늘리기보다 반복 입력과 대기 시간을 줄이고, 친구들이 실제로 어디서 막히는지 확인하려고 합니다. 이상으로 발표를 마치겠습니다. 감사합니다.</a:t>
+              <a:t>[목표 50초 / 행동: 마지막 문장을 천천히 말하고 마칩니다.]</a:t>
+            </a:r>
+          </a:p>
+          <a:p xmlns:a="http://schemas.openxmlformats.org/drawingml/2006/main">
+            <a:r>
+              <a:t/>
+            </a:r>
+          </a:p>
+          <a:p xmlns:a="http://schemas.openxmlformats.org/drawingml/2006/main">
+            <a:r>
+              <a:t>현재는 초대한 소수 사용자가 접속하는 비공개 베타입니다. 예약을 정리하고, 장소를 살펴보고, 일정에 연결하는 흐름까지 만들었습니다.</a:t>
+            </a:r>
+          </a:p>
+          <a:p xmlns:a="http://schemas.openxmlformats.org/drawingml/2006/main">
+            <a:r>
+              <a:t/>
+            </a:r>
+          </a:p>
+          <a:p xmlns:a="http://schemas.openxmlformats.org/drawingml/2006/main">
+            <a:r>
+              <a:t>이번에 배운 점은 AI 답변을 만드는 것만큼, 그 답변의 근거와 실패했을 때의 처리가 중요하다는 것입니다. 자동 시험은 통과했지만 실제 사용자 만족도는 아직 측정하지 않았습니다. 백 개 도시를 선택할 수 있다는 것도 모든 도시의 추천 품질을 검증했다는 뜻은 아닙니다.</a:t>
+            </a:r>
+          </a:p>
+          <a:p xmlns:a="http://schemas.openxmlformats.org/drawingml/2006/main">
+            <a:r>
+              <a:t/>
+            </a:r>
+          </a:p>
+          <a:p xmlns:a="http://schemas.openxmlformats.org/drawingml/2006/main">
+            <a:r>
+              <a:t>다음에는 검색 대기 시간을 줄이고, 친구들이 사용하다 멈추는 부분을 먼저 확인하려고 합니다. 기능을 더 넣기 전에 지금 있는 흐름을 편하게 만드는 것이 다음 목표입니다. 감사합니다.</a:t>
             </a:r>
           </a:p>
           <a:p xmlns:a="http://schemas.openxmlformats.org/drawingml/2006/main">
@@ -631,12 +671,27 @@
           <a:lstStyle xmlns:a="http://schemas.openxmlformats.org/drawingml/2006/main"/>
           <a:p xmlns:a="http://schemas.openxmlformats.org/drawingml/2006/main">
             <a:r>
-              <a:t>[목표 시간 45초]</a:t>
-            </a:r>
-          </a:p>
-          <a:p xmlns:a="http://schemas.openxmlformats.org/drawingml/2006/main">
-            <a:r>
-              <a:t>예를 들어 체크아웃 시간이 궁금하면 숙소 확인 메일을 다시 찾아야 합니다. 식당을 고를 때는 지도에서 위치를 보고, 예약이 필요한지 다른 사이트를 확인하고, 정해 둔 일정과 겹치지는 않는지 또 비교해야 합니다. 하나씩 보면 어려운 일은 아닌데, 여행을 준비하는 동안 계속 반복됩니다. 그래서 처음에는 예약 메일을 읽고 질문에 답해 주는 기능부터 만들었습니다. 이후에 실제로 써 보면서, 예약을 정리하는 것만으로는 여행 준비가 끝나지 않는다는 생각이 들었습니다. 그래서 장소 탐색과 일정 편집까지 같은 여행 안에서 이어지도록 기능을 확장했습니다.</a:t>
+              <a:t>[목표 45초 / 행동: 두 질문을 읽고 잠깐 쉽니다.]</a:t>
+            </a:r>
+          </a:p>
+          <a:p xmlns:a="http://schemas.openxmlformats.org/drawingml/2006/main">
+            <a:r>
+              <a:t/>
+            </a:r>
+          </a:p>
+          <a:p xmlns:a="http://schemas.openxmlformats.org/drawingml/2006/main">
+            <a:r>
+              <a:t>여행 준비할 때 이런 일이 있습니다. 숙소 체크아웃 시간이 궁금해서 확인 메일을 다시 찾고, 식당 하나를 고르려고 지도와 예약 사이트를 번갈아 보게 됩니다. 마지막에는 그 식당에 들렀다가 다음 예약에 늦지 않을지도 계산해야 하고요.</a:t>
+            </a:r>
+          </a:p>
+          <a:p xmlns:a="http://schemas.openxmlformats.org/drawingml/2006/main">
+            <a:r>
+              <a:t/>
+            </a:r>
+          </a:p>
+          <a:p xmlns:a="http://schemas.openxmlformats.org/drawingml/2006/main">
+            <a:r>
+              <a:t>문제는 정보가 없다는 것보다, 이미 있는 정보를 제가 계속 다시 정리해야 한다는 점이었습니다. 그래서 처음에는 메일을 읽고 질문에 답하는 기능을 만들었습니다. 여기에 장소 탐색과 일정 편집을 연결해서, 정리한 정보를 다음 단계에서도 그대로 쓸 수 있게 확장했습니다.</a:t>
             </a:r>
           </a:p>
           <a:p xmlns:a="http://schemas.openxmlformats.org/drawingml/2006/main">
@@ -721,12 +776,27 @@
           <a:lstStyle xmlns:a="http://schemas.openxmlformats.org/drawingml/2006/main"/>
           <a:p xmlns:a="http://schemas.openxmlformats.org/drawingml/2006/main">
             <a:r>
-              <a:t>[목표 시간 45초]</a:t>
-            </a:r>
-          </a:p>
-          <a:p xmlns:a="http://schemas.openxmlformats.org/drawingml/2006/main">
-            <a:r>
-              <a:t>이 화면이 지금의 홈입니다. 여행을 만들 때는 우선 도시와 날짜를 입력합니다. 그다음에는 예약 메일을 올리거나, 가고 싶은 곳을 찾거나, 하루 일정을 만들 수 있습니다. 상단에는 선택한 여행과 기간을 계속 보여 줍니다. 기능이 늘면서 입력해야 할 항목도 많아졌는데, 같은 도시와 날짜를 화면마다 반복해서 입력하는 게 가장 번거로웠습니다. 그래서 여행에 이미 있는 정보는 다음 화면에서 그대로 이어받게 바꿨습니다. 숙소가 아직 정해지지 않았어도 여행과 장소 탐색을 시작할 수 있고, 필요한 조건만 나중에 추가할 수 있습니다.</a:t>
+              <a:t>[목표 45초 / 행동: 도시·기간과 세 가지 시작 버튼을 가리킵니다.]</a:t>
+            </a:r>
+          </a:p>
+          <a:p xmlns:a="http://schemas.openxmlformats.org/drawingml/2006/main">
+            <a:r>
+              <a:t/>
+            </a:r>
+          </a:p>
+          <a:p xmlns:a="http://schemas.openxmlformats.org/drawingml/2006/main">
+            <a:r>
+              <a:t>이게 현재 홈 화면입니다. 먼저 여행할 도시와 날짜를 입력합니다. 그러면 여기에서 예약 메일을 올리거나, 장소를 찾거나, 일정을 만들 수 있습니다.</a:t>
+            </a:r>
+          </a:p>
+          <a:p xmlns:a="http://schemas.openxmlformats.org/drawingml/2006/main">
+            <a:r>
+              <a:t/>
+            </a:r>
+          </a:p>
+          <a:p xmlns:a="http://schemas.openxmlformats.org/drawingml/2006/main">
+            <a:r>
+              <a:t>기능을 추가하면서 오히려 사용이 번거로워진 적도 있었는데요. 화면마다 같은 도시와 날짜를 입력하게 되거나, 숙소가 없으면 다음 단계가 막히는 식이었습니다. 그래서 여행에 입력한 정보는 다른 화면에서도 이어받도록 바꿨습니다. 숙소는 나중에 추가해도 되고, 자세한 조건도 필요할 때만 설정합니다. 기능 수보다 처음 들어온 사람이 어디를 눌러야 할지 보이는 게 더 중요하다고 생각했습니다.</a:t>
             </a:r>
           </a:p>
           <a:p xmlns:a="http://schemas.openxmlformats.org/drawingml/2006/main">
@@ -821,12 +891,7 @@
           <a:lstStyle xmlns:a="http://schemas.openxmlformats.org/drawingml/2006/main"/>
           <a:p xmlns:a="http://schemas.openxmlformats.org/drawingml/2006/main">
             <a:r>
-              <a:t>[목표 시간 60초]</a:t>
-            </a:r>
-          </a:p>
-          <a:p xmlns:a="http://schemas.openxmlformats.org/drawingml/2006/main">
-            <a:r>
-              <a:t>메일은 텍스트나 eml 파일로 올릴 수 있습니다. 운영에서는 OpenAI의 gpt-5-mini로 예약 정보를 구조화하고, text-embedding-3-small로 검색에 필요한 벡터를 만듭니다. 중요한 건 AI가 뽑은 값을 바로 정답으로 취급하지 않는다는 점입니다. 한 메일에 예약이 여러 개 있으면 각각 저장하고, 왕복 항공편은 출발과 귀국 구간을 나눕니다. 사용자가 시간을 고치면 원문에서 추출한 값과 교정한 값을 따로 보관합니다. 그래서 나중에 다시 분석하더라도 사용자가 수정한 내용이 조용히 사라지지 않습니다. 화면의 메일과 예약은 발표를 위해 만든 예시 데이터입니다. 이 촬영에서는 비용 없는 기본 분석을 사용했고, 운영 AI 분석의 실행 여부는 별도 검증 기록으로 구분했습니다.</a:t>
+              <a:t>[목표 55초 / 행동: 추출 결과와 사용자 교정의 차이를 설명합니다.]</a:t>
             </a:r>
           </a:p>
           <a:p xmlns:a="http://schemas.openxmlformats.org/drawingml/2006/main">
@@ -836,6 +901,36 @@
           </a:p>
           <a:p xmlns:a="http://schemas.openxmlformats.org/drawingml/2006/main">
             <a:r>
+              <a:t>예약 메일을 올리면 날짜와 시간, 장소 같은 정보를 예약 항목으로 정리합니다. 운영에서는 오픈에이아이의 지피티 파이브 미니를 사용하고, 검색용 임베딩은 별도 모델로 만듭니다.</a:t>
+            </a:r>
+          </a:p>
+          <a:p xmlns:a="http://schemas.openxmlformats.org/drawingml/2006/main">
+            <a:r>
+              <a:t/>
+            </a:r>
+          </a:p>
+          <a:p xmlns:a="http://schemas.openxmlformats.org/drawingml/2006/main">
+            <a:r>
+              <a:t>여기서 신경 쓴 부분은 추출한 결과를 바로 정답으로 확정하지 않는 것입니다. 한 메일에 예약이 여러 개 있으면 나눠 저장하고, 사용자가 고친 값은 원문에서 읽은 값과 따로 보관합니다. 다시 분석하다가 실패해도 기존 예약은 남아 있어야 하고요.</a:t>
+            </a:r>
+          </a:p>
+          <a:p xmlns:a="http://schemas.openxmlformats.org/drawingml/2006/main">
+            <a:r>
+              <a:t/>
+            </a:r>
+          </a:p>
+          <a:p xmlns:a="http://schemas.openxmlformats.org/drawingml/2006/main">
+            <a:r>
+              <a:t>지금 보이는 화면은 가상 메일을 기본 분석한 예시입니다. 운영 AI 호출 검증은 별도로 기록했습니다. 결과를 보고 직접 고칠 수 있게 한 것이 이 화면의 핵심입니다.</a:t>
+            </a:r>
+          </a:p>
+          <a:p xmlns:a="http://schemas.openxmlformats.org/drawingml/2006/main">
+            <a:r>
+              <a:t/>
+            </a:r>
+          </a:p>
+          <a:p xmlns:a="http://schemas.openxmlformats.org/drawingml/2006/main">
+            <a:r>
               <a:t>[근거·검증 범위 / 낭독하지 않음]</a:t>
             </a:r>
           </a:p>
@@ -852,6 +947,11 @@
           <a:p xmlns:a="http://schemas.openxmlformats.org/drawingml/2006/main">
             <a:r>
               <a:t>화면은 현재 코드와 합성 계정·메일·예약으로 촬영. 실제 운영 개인 자료를 공개하지 않음.</a:t>
+            </a:r>
+          </a:p>
+          <a:p xmlns:a="http://schemas.openxmlformats.org/drawingml/2006/main">
+            <a:r>
+              <a:t>정확한 모델명: gpt-5-mini, text-embedding-3-small.</a:t>
             </a:r>
           </a:p>
         </p:txBody>
@@ -921,12 +1021,37 @@
           <a:lstStyle xmlns:a="http://schemas.openxmlformats.org/drawingml/2006/main"/>
           <a:p xmlns:a="http://schemas.openxmlformats.org/drawingml/2006/main">
             <a:r>
-              <a:t>[목표 시간 60초]</a:t>
-            </a:r>
-          </a:p>
-          <a:p xmlns:a="http://schemas.openxmlformats.org/drawingml/2006/main">
-            <a:r>
-              <a:t>예약을 모았으면 자연어로 질문할 수 있습니다. 예를 들어 둘째 날에 어떤 예약이 있는지 물으면, 해당 날짜를 계산하고 저장된 예약을 조회해서 답합니다. 여기서 실제로 문제가 한 번 있었습니다. 처음에는 날짜 질문도 의미가 비슷한 문서를 몇 개 찾는 방식으로 처리했는데, 그러면 하루 예약이 여덟 개 있어도 일부가 검색 결과 밖으로 빠질 수 있습니다. 그래서 하루 전체를 묻는 질문은 SQL 날짜 범위 조회로 바꿨습니다. 사용자가 직접 넣은 예약도 같이 포함합니다. 환불 규정처럼 원문의 설명이 필요한 질문은 검색한 근거를 사용하고, 답변 아래에서 어느 메일을 참고했는지 확인할 수 있게 했습니다. 근거가 없는 내용은 추측해서 채우지 않는 것이 기본 원칙입니다.</a:t>
+              <a:t>[목표 60초 / 행동: 왼쪽 결과와 오른쪽 원문 보기를 가리킵니다.]</a:t>
+            </a:r>
+          </a:p>
+          <a:p xmlns:a="http://schemas.openxmlformats.org/drawingml/2006/main">
+            <a:r>
+              <a:t/>
+            </a:r>
+          </a:p>
+          <a:p xmlns:a="http://schemas.openxmlformats.org/drawingml/2006/main">
+            <a:r>
+              <a:t>이제 “둘째 날 예약을 전부 알려줘”라고 물어볼 수 있습니다. 왼쪽은 답변이고, 오른쪽은 그 답변의 근거입니다. 메일에서 가져온 내용과 직접 입력한 예약을 구분해서 볼 수 있습니다.</a:t>
+            </a:r>
+          </a:p>
+          <a:p xmlns:a="http://schemas.openxmlformats.org/drawingml/2006/main">
+            <a:r>
+              <a:t/>
+            </a:r>
+          </a:p>
+          <a:p xmlns:a="http://schemas.openxmlformats.org/drawingml/2006/main">
+            <a:r>
+              <a:t>이 질문은 단순히 AI에게 잘 답해 달라고 해서는 부족했습니다. 의미가 비슷한 문서를 몇 개만 검색하면, 같은 날 예약이 여덟 개여도 일부가 빠질 수 있기 때문입니다. 그래서 하루 전체를 묻는 질문은 데이터베이스에서 그 날짜의 예약을 모두 조회하게 했습니다.</a:t>
+            </a:r>
+          </a:p>
+          <a:p xmlns:a="http://schemas.openxmlformats.org/drawingml/2006/main">
+            <a:r>
+              <a:t/>
+            </a:r>
+          </a:p>
+          <a:p xmlns:a="http://schemas.openxmlformats.org/drawingml/2006/main">
+            <a:r>
+              <a:t>반대로 환불 규정처럼 본문의 설명을 찾아야 하는 질문에는 검색을 사용합니다. 질문의 성격에 맞춰 방법을 나누고, 사용자가 원문까지 확인할 수 있도록 했습니다.</a:t>
             </a:r>
           </a:p>
           <a:p xmlns:a="http://schemas.openxmlformats.org/drawingml/2006/main">
@@ -1021,12 +1146,37 @@
           <a:lstStyle xmlns:a="http://schemas.openxmlformats.org/drawingml/2006/main"/>
           <a:p xmlns:a="http://schemas.openxmlformats.org/drawingml/2006/main">
             <a:r>
-              <a:t>[목표 시간 55초]</a:t>
-            </a:r>
-          </a:p>
-          <a:p xmlns:a="http://schemas.openxmlformats.org/drawingml/2006/main">
-            <a:r>
-              <a:t>장소 탐색은 현지 분위기의 식당을 찾는 경우와, 그 도시의 대표 명소를 가고 싶은 경우를 나눴습니다. 음식점이나 카페 같은 장소 종류는 별도로 고를 수 있습니다. 카드에서는 사진과 추천 이유, 확인해야 할 정보를 보고, 상세 화면에서 주소와 출처를 확인합니다. 사진은 권한과 지점을 확인한 자료가 있는 곳에만 표시합니다. 숙소가 등록되고 위치까지 확인되면 숙소를 기준으로 거리 조건을 적용할 수 있습니다. 다만 직선거리와 실제 도보시간은 다른 값으로 다룹니다. 현재 운영에서는 무료 공개지도 검색과 저장된 자료를 함께 사용하고, 정확한 도보 경로처럼 별도 공급자가 필요한 기능은 아직 제한이 있습니다.</a:t>
+              <a:t>[목표 55초 / 행동: 사진과 방문 전 확인 필요 문구를 가리킵니다.]</a:t>
+            </a:r>
+          </a:p>
+          <a:p xmlns:a="http://schemas.openxmlformats.org/drawingml/2006/main">
+            <a:r>
+              <a:t/>
+            </a:r>
+          </a:p>
+          <a:p xmlns:a="http://schemas.openxmlformats.org/drawingml/2006/main">
+            <a:r>
+              <a:t>예약을 정리한 다음에는 가고 싶은 장소를 찾습니다. 현지 분위기의 식당을 찾는 경우와, 유명한 명소를 보고 싶은 경우를 나눴습니다. 음식점이나 카페 같은 분류는 따로 고를 수 있습니다.</a:t>
+            </a:r>
+          </a:p>
+          <a:p xmlns:a="http://schemas.openxmlformats.org/drawingml/2006/main">
+            <a:r>
+              <a:t/>
+            </a:r>
+          </a:p>
+          <a:p xmlns:a="http://schemas.openxmlformats.org/drawingml/2006/main">
+            <a:r>
+              <a:t>이 화면은 마드리드의 실제 식당 자료입니다. 지점과 이용 권한을 확인한 사진이 있으면 실내나 음식 사진도 보여줍니다. 상세 정보를 보고 최대 세 곳을 비교할 수 있고, 숙소 위치가 확인되면 거리 조건도 적용할 수 있습니다.</a:t>
+            </a:r>
+          </a:p>
+          <a:p xmlns:a="http://schemas.openxmlformats.org/drawingml/2006/main">
+            <a:r>
+              <a:t/>
+            </a:r>
+          </a:p>
+          <a:p xmlns:a="http://schemas.openxmlformats.org/drawingml/2006/main">
+            <a:r>
+              <a:t>다만 사진이 있다고 그날 예약할 수 있다는 뜻은 아닙니다. 영업이나 인원 조건을 확인하지 못한 곳은 확인 필요로 남깁니다. 직선거리와 실제 도보시간도 구분해서 보여주도록 했습니다.</a:t>
             </a:r>
           </a:p>
           <a:p xmlns:a="http://schemas.openxmlformats.org/drawingml/2006/main">
@@ -1136,12 +1286,37 @@
           <a:lstStyle xmlns:a="http://schemas.openxmlformats.org/drawingml/2006/main"/>
           <a:p xmlns:a="http://schemas.openxmlformats.org/drawingml/2006/main">
             <a:r>
-              <a:t>[목표 시간 50초]</a:t>
-            </a:r>
-          </a:p>
-          <a:p xmlns:a="http://schemas.openxmlformats.org/drawingml/2006/main">
-            <a:r>
-              <a:t>처음 구상한 차별점은 현지 언어 리뷰가 많고 한국어 리뷰는 적은 장소를 찾는 것이었습니다. 그런데 여기에는 조심해야 할 부분이 있습니다. 일본어 리뷰가 많다고 해서 작성자가 모두 일본에 사는 주민이라고 말할 수는 없습니다. 수집한 일부 리뷰를 전체 리뷰의 비율처럼 보여 줘도 안 됩니다. 그래서 원문을 확보했는지, 언어를 판별할 수 있었는지, 언제까지 몇 건을 관측했는지를 따로 관리하도록 만들었습니다. 언어를 모르겠는 리뷰도 분모에서 숨기지 않습니다. 이 분석 도구와 계산 로직은 구현했지만, 실제 수집과 이용 범위, 언어 품질 검증을 통과하기 전까지 엄격한 리뷰 기반 추천은 꺼 두었습니다. 지금 화면에 없는 근거를 만들어 보여 주지는 않습니다.</a:t>
+              <a:t>[목표 50초 / 행동: 엄격 리뷰 추천이 OFF인 이유를 말합니다.]</a:t>
+            </a:r>
+          </a:p>
+          <a:p xmlns:a="http://schemas.openxmlformats.org/drawingml/2006/main">
+            <a:r>
+              <a:t/>
+            </a:r>
+          </a:p>
+          <a:p xmlns:a="http://schemas.openxmlformats.org/drawingml/2006/main">
+            <a:r>
+              <a:t>처음에 특히 만들고 싶었던 건, 현지 언어 리뷰가 많고 한국어 리뷰는 적은 장소를 찾는 기능이었습니다.</a:t>
+            </a:r>
+          </a:p>
+          <a:p xmlns:a="http://schemas.openxmlformats.org/drawingml/2006/main">
+            <a:r>
+              <a:t/>
+            </a:r>
+          </a:p>
+          <a:p xmlns:a="http://schemas.openxmlformats.org/drawingml/2006/main">
+            <a:r>
+              <a:t>그런데 일본어 리뷰가 많다고 작성자가 모두 일본 주민이라고 할 수는 없더라고요. 일부 리뷰만 가져와서 전체 리뷰의 비율처럼 보여주는 것도 정확하지 않습니다. 그래서 관측한 기간과 건수, 언어를 판단하지 못한 리뷰를 따로 기록하도록 만들었습니다.</a:t>
+            </a:r>
+          </a:p>
+          <a:p xmlns:a="http://schemas.openxmlformats.org/drawingml/2006/main">
+            <a:r>
+              <a:t/>
+            </a:r>
+          </a:p>
+          <a:p xmlns:a="http://schemas.openxmlformats.org/drawingml/2006/main">
+            <a:r>
+              <a:t>계산 로직과 평가 도구는 구현했지만, 실제 데이터의 이용 범위와 언어 판별 품질을 확인하기 전까지 엄격한 리뷰 추천은 꺼 두었습니다. 아직 확인하지 못한 내용을 추천 근거처럼 보여주지 않는 것이 기준입니다.</a:t>
             </a:r>
           </a:p>
           <a:p xmlns:a="http://schemas.openxmlformats.org/drawingml/2006/main">
@@ -1226,12 +1401,7 @@
           <a:lstStyle xmlns:a="http://schemas.openxmlformats.org/drawingml/2006/main"/>
           <a:p xmlns:a="http://schemas.openxmlformats.org/drawingml/2006/main">
             <a:r>
-              <a:t>[목표 시간 60초]</a:t>
-            </a:r>
-          </a:p>
-          <a:p xmlns:a="http://schemas.openxmlformats.org/drawingml/2006/main">
-            <a:r>
-              <a:t>일정을 만들 때는 이미 확정한 예약부터 배치합니다. 그 사이의 빈 시간에 선택한 장소를 넣을 수 있는지 확인합니다. 머무르는 시간만 맞으면 되는 게 아니라, 이전 장소에서 오는 시간과 다음 예약으로 가는 시간까지 함께 봐야 합니다. 이동시간이나 영업 여부를 모르면 기본적으로는 배치를 보류하고, 사용자가 잠정 초안을 허용했을 때만 미확인 표시와 함께 넣습니다. 편집도 먼저 미리보기를 보여 줍니다. 뒤 일정이나 예약에 어떤 영향을 주는지 확인한 뒤 적용하고, 마음에 들지 않으면 되돌릴 수 있습니다. 되돌리기도 과거 상태를 무조건 복구하는 게 아니라 현재 조건을 다시 검사합니다. 그리고 일정에서 항목을 지워도 실제 외부 예약이 취소되는 것은 아닙니다.</a:t>
+              <a:t>[목표 60초 / 행동: 120분과 150분을 비교한 다음 편집 순서로 넘어갑니다.]</a:t>
             </a:r>
           </a:p>
           <a:p xmlns:a="http://schemas.openxmlformats.org/drawingml/2006/main">
@@ -1241,6 +1411,36 @@
           </a:p>
           <a:p xmlns:a="http://schemas.openxmlformats.org/drawingml/2006/main">
             <a:r>
+              <a:t>일정에서는 이미 확정한 예약을 먼저 보존합니다. 예를 들어 점심이 오후 한 시에 끝나고 다음 예약이 세 시라면, 사이에 두 시간이 있습니다.</a:t>
+            </a:r>
+          </a:p>
+          <a:p xmlns:a="http://schemas.openxmlformats.org/drawingml/2006/main">
+            <a:r>
+              <a:t/>
+            </a:r>
+          </a:p>
+          <a:p xmlns:a="http://schemas.openxmlformats.org/drawingml/2006/main">
+            <a:r>
+              <a:t>그런데 새 장소에서 한 시간 반을 머물고, 오가는 데 각각 삼십 분이 걸리면 총 두 시간 반이 필요합니다. 체류시간만 보면 들어갈 것 같지만 실제로는 넣으면 안 되는 일정입니다. 이런 계산을 서버에서 검사합니다. 이동시간을 모를 때도 영 분으로 처리하지 않습니다.</a:t>
+            </a:r>
+          </a:p>
+          <a:p xmlns:a="http://schemas.openxmlformats.org/drawingml/2006/main">
+            <a:r>
+              <a:t/>
+            </a:r>
+          </a:p>
+          <a:p xmlns:a="http://schemas.openxmlformats.org/drawingml/2006/main">
+            <a:r>
+              <a:t>편집은 미리보기, 적용, 되돌리기 순서입니다. 뒤의 예약에 어떤 영향이 있는지 먼저 보고 적용합니다. 그리고 일정에서 항목을 빼는 것과 외부 예약을 취소하는 것은 별개입니다.</a:t>
+            </a:r>
+          </a:p>
+          <a:p xmlns:a="http://schemas.openxmlformats.org/drawingml/2006/main">
+            <a:r>
+              <a:t/>
+            </a:r>
+          </a:p>
+          <a:p xmlns:a="http://schemas.openxmlformats.org/drawingml/2006/main">
+            <a:r>
               <a:t>[근거·검증 범위 / 낭독하지 않음]</a:t>
             </a:r>
           </a:p>
@@ -1252,6 +1452,11 @@
           <a:p xmlns:a="http://schemas.openxmlformats.org/drawingml/2006/main">
             <a:r>
               <a:t>화면은 현재 코드와 합성 계정·메일·예약으로 촬영. 실제 운영 개인 자료를 공개하지 않음.</a:t>
+            </a:r>
+          </a:p>
+          <a:p xmlns:a="http://schemas.openxmlformats.org/drawingml/2006/main">
+            <a:r>
+              <a:t>120분 창과150분 필요 시간은 합성 계산 예시. 오른쪽 앱 화면의 측정 경로값이 아님.</a:t>
             </a:r>
           </a:p>
         </p:txBody>
@@ -1321,12 +1526,37 @@
           <a:lstStyle xmlns:a="http://schemas.openxmlformats.org/drawingml/2006/main"/>
           <a:p xmlns:a="http://schemas.openxmlformats.org/drawingml/2006/main">
             <a:r>
-              <a:t>[목표 시간 55초]</a:t>
-            </a:r>
-          </a:p>
-          <a:p xmlns:a="http://schemas.openxmlformats.org/drawingml/2006/main">
-            <a:r>
-              <a:t>기능을 늘리는 것만큼, 중간에 실패해도 다시 사용할 수 있게 만드는 데 시간이 들었습니다. 오래 걸리는 분석은 작업 번호와 상태를 DB에 저장해서 새로고침해도 이어서 확인할 수 있게 했습니다. 무료 서버의 로컬 디스크에만 저장하면 재시작 때 자료가 사라질 수 있어서, 운영 데이터는 Supabase에 보관하도록 바꿨습니다. 장소 검색이 계속 실패했던 문제도 있었는데, 단순히 한도가 소진됐다는 안내를 반복하는 대신 실제 오류를 조사했습니다. 운영 서버에서 기존 지도 서버로 연결이 거절되는 것을 확인했고, 무료 Photon 검색으로 바꾼 뒤 런던 지점 50곳을 받아 음식점 12곳을 화면에 표시했습니다. 다시 찾을 때는 유효한 자료를 재사용해서 불필요한 외부 호출을 줄였습니다.</a:t>
+              <a:t>[목표 60초 / 행동: 세 가지 실패 상황과 대응을 짝지어 말합니다.]</a:t>
+            </a:r>
+          </a:p>
+          <a:p xmlns:a="http://schemas.openxmlformats.org/drawingml/2006/main">
+            <a:r>
+              <a:t/>
+            </a:r>
+          </a:p>
+          <a:p xmlns:a="http://schemas.openxmlformats.org/drawingml/2006/main">
+            <a:r>
+              <a:t>사용 중에 실패해도 자료를 계속 볼 수 있게 하는 작업도 필요했습니다. 분석 상태를 화면에만 두면 새로고침했을 때 진행 상황을 잃게 됩니다. 그래서 작업 번호와 상태를 데이터베이스에 저장했습니다.</a:t>
+            </a:r>
+          </a:p>
+          <a:p xmlns:a="http://schemas.openxmlformats.org/drawingml/2006/main">
+            <a:r>
+              <a:t/>
+            </a:r>
+          </a:p>
+          <a:p xmlns:a="http://schemas.openxmlformats.org/drawingml/2006/main">
+            <a:r>
+              <a:t>운영 데이터도 무료 서버의 임시 디스크에만 두지 않고 수파베이스에 보관하도록 바꿨습니다. 메일 원문은 비공개 저장소로 분리했고요.</a:t>
+            </a:r>
+          </a:p>
+          <a:p xmlns:a="http://schemas.openxmlformats.org/drawingml/2006/main">
+            <a:r>
+              <a:t/>
+            </a:r>
+          </a:p>
+          <a:p xmlns:a="http://schemas.openxmlformats.org/drawingml/2006/main">
+            <a:r>
+              <a:t>지도 검색이 계속 실패한 적도 있었습니다. 실제로 확인해 보니 운영 서버에서 기존 지도 서버로 연결이 거절되고 있었습니다. 포톤 검색으로 바꾼 뒤 런던의 실제 지점 자료를 받아 음식점 후보 열두 곳을 표시했고, 같은 조건의 재조회에서는 추가 지도 호출이 없었습니다. 다만 방문 가능 여부까지 검증한 열두 곳이라는 뜻은 아닙니다.</a:t>
             </a:r>
           </a:p>
           <a:p xmlns:a="http://schemas.openxmlformats.org/drawingml/2006/main">
@@ -1444,6 +1674,7 @@
                 <a:spcPts val="0"/>
               </a:spcAft>
               <a:buNone/>
+              <a:defRPr/>
             </a:lvl1pPr>
             <a:lvl2pPr marL="0" indent="0">
               <a:lnSpc>
@@ -1456,6 +1687,7 @@
                 <a:spcPts val="0"/>
               </a:spcAft>
               <a:buNone/>
+              <a:defRPr/>
             </a:lvl2pPr>
             <a:lvl3pPr marL="0" indent="0">
               <a:lnSpc>
@@ -1468,6 +1700,7 @@
                 <a:spcPts val="0"/>
               </a:spcAft>
               <a:buNone/>
+              <a:defRPr/>
             </a:lvl3pPr>
             <a:lvl4pPr marL="0" indent="0">
               <a:lnSpc>
@@ -1480,6 +1713,7 @@
                 <a:spcPts val="0"/>
               </a:spcAft>
               <a:buNone/>
+              <a:defRPr/>
             </a:lvl4pPr>
             <a:lvl5pPr marL="0" indent="0">
               <a:lnSpc>
@@ -1492,6 +1726,7 @@
                 <a:spcPts val="0"/>
               </a:spcAft>
               <a:buNone/>
+              <a:defRPr/>
             </a:lvl5pPr>
             <a:lvl6pPr marL="0" indent="0">
               <a:lnSpc>
@@ -1504,6 +1739,7 @@
                 <a:spcPts val="0"/>
               </a:spcAft>
               <a:buNone/>
+              <a:defRPr/>
             </a:lvl6pPr>
             <a:lvl7pPr marL="0" indent="0">
               <a:lnSpc>
@@ -1516,6 +1752,7 @@
                 <a:spcPts val="0"/>
               </a:spcAft>
               <a:buNone/>
+              <a:defRPr/>
             </a:lvl7pPr>
             <a:lvl8pPr marL="0" indent="0">
               <a:lnSpc>
@@ -1528,6 +1765,7 @@
                 <a:spcPts val="0"/>
               </a:spcAft>
               <a:buNone/>
+              <a:defRPr/>
             </a:lvl8pPr>
             <a:lvl9pPr marL="0" indent="0">
               <a:lnSpc>
@@ -1540,6 +1778,7 @@
                 <a:spcPts val="0"/>
               </a:spcAft>
               <a:buNone/>
+              <a:defRPr/>
             </a:lvl9pPr>
           </a:lstStyle>
           <a:p xmlns:a="http://schemas.openxmlformats.org/drawingml/2006/main"/>
@@ -1601,6 +1840,7 @@
                 <a:spcPts val="0"/>
               </a:spcAft>
               <a:buNone/>
+              <a:defRPr/>
             </a:lvl1pPr>
             <a:lvl2pPr marL="0" indent="0">
               <a:lnSpc>
@@ -1613,6 +1853,7 @@
                 <a:spcPts val="0"/>
               </a:spcAft>
               <a:buNone/>
+              <a:defRPr/>
             </a:lvl2pPr>
             <a:lvl3pPr marL="0" indent="0">
               <a:lnSpc>
@@ -1625,6 +1866,7 @@
                 <a:spcPts val="0"/>
               </a:spcAft>
               <a:buNone/>
+              <a:defRPr/>
             </a:lvl3pPr>
             <a:lvl4pPr marL="0" indent="0">
               <a:lnSpc>
@@ -1637,6 +1879,7 @@
                 <a:spcPts val="0"/>
               </a:spcAft>
               <a:buNone/>
+              <a:defRPr/>
             </a:lvl4pPr>
             <a:lvl5pPr marL="0" indent="0">
               <a:lnSpc>
@@ -1649,6 +1892,7 @@
                 <a:spcPts val="0"/>
               </a:spcAft>
               <a:buNone/>
+              <a:defRPr/>
             </a:lvl5pPr>
             <a:lvl6pPr marL="0" indent="0">
               <a:lnSpc>
@@ -1661,6 +1905,7 @@
                 <a:spcPts val="0"/>
               </a:spcAft>
               <a:buNone/>
+              <a:defRPr/>
             </a:lvl6pPr>
             <a:lvl7pPr marL="0" indent="0">
               <a:lnSpc>
@@ -1673,6 +1918,7 @@
                 <a:spcPts val="0"/>
               </a:spcAft>
               <a:buNone/>
+              <a:defRPr/>
             </a:lvl7pPr>
             <a:lvl8pPr marL="0" indent="0">
               <a:lnSpc>
@@ -1685,6 +1931,7 @@
                 <a:spcPts val="0"/>
               </a:spcAft>
               <a:buNone/>
+              <a:defRPr/>
             </a:lvl8pPr>
             <a:lvl9pPr marL="0" indent="0">
               <a:lnSpc>
@@ -1697,6 +1944,7 @@
                 <a:spcPts val="0"/>
               </a:spcAft>
               <a:buNone/>
+              <a:defRPr/>
             </a:lvl9pPr>
           </a:lstStyle>
           <a:p xmlns:a="http://schemas.openxmlformats.org/drawingml/2006/main"/>
@@ -1775,6 +2023,7 @@
                 <a:spcPts val="0"/>
               </a:spcAft>
               <a:buNone/>
+              <a:defRPr/>
             </a:lvl1pPr>
             <a:lvl2pPr marL="0" indent="0">
               <a:lnSpc>
@@ -1787,6 +2036,7 @@
                 <a:spcPts val="0"/>
               </a:spcAft>
               <a:buNone/>
+              <a:defRPr/>
             </a:lvl2pPr>
             <a:lvl3pPr marL="0" indent="0">
               <a:lnSpc>
@@ -1799,6 +2049,7 @@
                 <a:spcPts val="0"/>
               </a:spcAft>
               <a:buNone/>
+              <a:defRPr/>
             </a:lvl3pPr>
             <a:lvl4pPr marL="0" indent="0">
               <a:lnSpc>
@@ -1811,6 +2062,7 @@
                 <a:spcPts val="0"/>
               </a:spcAft>
               <a:buNone/>
+              <a:defRPr/>
             </a:lvl4pPr>
             <a:lvl5pPr marL="0" indent="0">
               <a:lnSpc>
@@ -1823,6 +2075,7 @@
                 <a:spcPts val="0"/>
               </a:spcAft>
               <a:buNone/>
+              <a:defRPr/>
             </a:lvl5pPr>
             <a:lvl6pPr marL="0" indent="0">
               <a:lnSpc>
@@ -1835,6 +2088,7 @@
                 <a:spcPts val="0"/>
               </a:spcAft>
               <a:buNone/>
+              <a:defRPr/>
             </a:lvl6pPr>
             <a:lvl7pPr marL="0" indent="0">
               <a:lnSpc>
@@ -1847,6 +2101,7 @@
                 <a:spcPts val="0"/>
               </a:spcAft>
               <a:buNone/>
+              <a:defRPr/>
             </a:lvl7pPr>
             <a:lvl8pPr marL="0" indent="0">
               <a:lnSpc>
@@ -1859,6 +2114,7 @@
                 <a:spcPts val="0"/>
               </a:spcAft>
               <a:buNone/>
+              <a:defRPr/>
             </a:lvl8pPr>
             <a:lvl9pPr marL="0" indent="0">
               <a:lnSpc>
@@ -1871,6 +2127,7 @@
                 <a:spcPts val="0"/>
               </a:spcAft>
               <a:buNone/>
+              <a:defRPr/>
             </a:lvl9pPr>
           </a:lstStyle>
           <a:p xmlns:a="http://schemas.openxmlformats.org/drawingml/2006/main"/>
@@ -1949,6 +2206,7 @@
                 <a:spcPts val="0"/>
               </a:spcAft>
               <a:buNone/>
+              <a:defRPr/>
             </a:lvl1pPr>
             <a:lvl2pPr marL="0" indent="0">
               <a:lnSpc>
@@ -1961,6 +2219,7 @@
                 <a:spcPts val="0"/>
               </a:spcAft>
               <a:buNone/>
+              <a:defRPr/>
             </a:lvl2pPr>
             <a:lvl3pPr marL="0" indent="0">
               <a:lnSpc>
@@ -1973,6 +2232,7 @@
                 <a:spcPts val="0"/>
               </a:spcAft>
               <a:buNone/>
+              <a:defRPr/>
             </a:lvl3pPr>
             <a:lvl4pPr marL="0" indent="0">
               <a:lnSpc>
@@ -1985,6 +2245,7 @@
                 <a:spcPts val="0"/>
               </a:spcAft>
               <a:buNone/>
+              <a:defRPr/>
             </a:lvl4pPr>
             <a:lvl5pPr marL="0" indent="0">
               <a:lnSpc>
@@ -1997,6 +2258,7 @@
                 <a:spcPts val="0"/>
               </a:spcAft>
               <a:buNone/>
+              <a:defRPr/>
             </a:lvl5pPr>
             <a:lvl6pPr marL="0" indent="0">
               <a:lnSpc>
@@ -2009,6 +2271,7 @@
                 <a:spcPts val="0"/>
               </a:spcAft>
               <a:buNone/>
+              <a:defRPr/>
             </a:lvl6pPr>
             <a:lvl7pPr marL="0" indent="0">
               <a:lnSpc>
@@ -2021,6 +2284,7 @@
                 <a:spcPts val="0"/>
               </a:spcAft>
               <a:buNone/>
+              <a:defRPr/>
             </a:lvl7pPr>
             <a:lvl8pPr marL="0" indent="0">
               <a:lnSpc>
@@ -2033,6 +2297,7 @@
                 <a:spcPts val="0"/>
               </a:spcAft>
               <a:buNone/>
+              <a:defRPr/>
             </a:lvl8pPr>
             <a:lvl9pPr marL="0" indent="0">
               <a:lnSpc>
@@ -2045,6 +2310,7 @@
                 <a:spcPts val="0"/>
               </a:spcAft>
               <a:buNone/>
+              <a:defRPr/>
             </a:lvl9pPr>
           </a:lstStyle>
           <a:p xmlns:a="http://schemas.openxmlformats.org/drawingml/2006/main"/>
@@ -2106,6 +2372,7 @@
                 <a:spcPts val="1200"/>
               </a:spcAft>
               <a:buChar char="•"/>
+              <a:defRPr/>
             </a:lvl1pPr>
             <a:lvl2pPr marL="533400" indent="-228600">
               <a:lnSpc>
@@ -2118,6 +2385,7 @@
                 <a:spcPts val="1200"/>
               </a:spcAft>
               <a:buChar char="•"/>
+              <a:defRPr/>
             </a:lvl2pPr>
             <a:lvl3pPr marL="838200" indent="-228600">
               <a:lnSpc>
@@ -2130,6 +2398,7 @@
                 <a:spcPts val="1200"/>
               </a:spcAft>
               <a:buChar char="•"/>
+              <a:defRPr/>
             </a:lvl3pPr>
             <a:lvl4pPr marL="1143000" indent="-228600">
               <a:lnSpc>
@@ -2142,6 +2411,7 @@
                 <a:spcPts val="1200"/>
               </a:spcAft>
               <a:buChar char="•"/>
+              <a:defRPr/>
             </a:lvl4pPr>
             <a:lvl5pPr marL="1447800" indent="-228600">
               <a:lnSpc>
@@ -2154,6 +2424,7 @@
                 <a:spcPts val="1200"/>
               </a:spcAft>
               <a:buChar char="•"/>
+              <a:defRPr/>
             </a:lvl5pPr>
             <a:lvl6pPr marL="1752600" indent="-228600">
               <a:lnSpc>
@@ -2166,6 +2437,7 @@
                 <a:spcPts val="1200"/>
               </a:spcAft>
               <a:buChar char="•"/>
+              <a:defRPr/>
             </a:lvl6pPr>
             <a:lvl7pPr marL="2057400" indent="-228600">
               <a:lnSpc>
@@ -2178,6 +2450,7 @@
                 <a:spcPts val="1200"/>
               </a:spcAft>
               <a:buChar char="•"/>
+              <a:defRPr/>
             </a:lvl7pPr>
             <a:lvl8pPr marL="2362200" indent="-228600">
               <a:lnSpc>
@@ -2190,6 +2463,7 @@
                 <a:spcPts val="1200"/>
               </a:spcAft>
               <a:buChar char="•"/>
+              <a:defRPr/>
             </a:lvl8pPr>
             <a:lvl9pPr marL="2667000" indent="-228600">
               <a:lnSpc>
@@ -2202,6 +2476,7 @@
                 <a:spcPts val="1200"/>
               </a:spcAft>
               <a:buChar char="•"/>
+              <a:defRPr/>
             </a:lvl9pPr>
           </a:lstStyle>
           <a:p xmlns:a="http://schemas.openxmlformats.org/drawingml/2006/main"/>
@@ -2280,6 +2555,7 @@
                 <a:spcPts val="0"/>
               </a:spcAft>
               <a:buNone/>
+              <a:defRPr/>
             </a:lvl1pPr>
             <a:lvl2pPr marL="0" indent="0">
               <a:lnSpc>
@@ -2292,6 +2568,7 @@
                 <a:spcPts val="0"/>
               </a:spcAft>
               <a:buNone/>
+              <a:defRPr/>
             </a:lvl2pPr>
             <a:lvl3pPr marL="0" indent="0">
               <a:lnSpc>
@@ -2304,6 +2581,7 @@
                 <a:spcPts val="0"/>
               </a:spcAft>
               <a:buNone/>
+              <a:defRPr/>
             </a:lvl3pPr>
             <a:lvl4pPr marL="0" indent="0">
               <a:lnSpc>
@@ -2316,6 +2594,7 @@
                 <a:spcPts val="0"/>
               </a:spcAft>
               <a:buNone/>
+              <a:defRPr/>
             </a:lvl4pPr>
             <a:lvl5pPr marL="0" indent="0">
               <a:lnSpc>
@@ -2328,6 +2607,7 @@
                 <a:spcPts val="0"/>
               </a:spcAft>
               <a:buNone/>
+              <a:defRPr/>
             </a:lvl5pPr>
             <a:lvl6pPr marL="0" indent="0">
               <a:lnSpc>
@@ -2340,6 +2620,7 @@
                 <a:spcPts val="0"/>
               </a:spcAft>
               <a:buNone/>
+              <a:defRPr/>
             </a:lvl6pPr>
             <a:lvl7pPr marL="0" indent="0">
               <a:lnSpc>
@@ -2352,6 +2633,7 @@
                 <a:spcPts val="0"/>
               </a:spcAft>
               <a:buNone/>
+              <a:defRPr/>
             </a:lvl7pPr>
             <a:lvl8pPr marL="0" indent="0">
               <a:lnSpc>
@@ -2364,6 +2646,7 @@
                 <a:spcPts val="0"/>
               </a:spcAft>
               <a:buNone/>
+              <a:defRPr/>
             </a:lvl8pPr>
             <a:lvl9pPr marL="0" indent="0">
               <a:lnSpc>
@@ -2376,6 +2659,7 @@
                 <a:spcPts val="0"/>
               </a:spcAft>
               <a:buNone/>
+              <a:defRPr/>
             </a:lvl9pPr>
           </a:lstStyle>
           <a:p xmlns:a="http://schemas.openxmlformats.org/drawingml/2006/main"/>
@@ -2437,6 +2721,7 @@
                 <a:spcPts val="1200"/>
               </a:spcAft>
               <a:buChar char="•"/>
+              <a:defRPr/>
             </a:lvl1pPr>
             <a:lvl2pPr marL="533400" indent="-228600">
               <a:lnSpc>
@@ -2449,6 +2734,7 @@
                 <a:spcPts val="1200"/>
               </a:spcAft>
               <a:buChar char="•"/>
+              <a:defRPr/>
             </a:lvl2pPr>
             <a:lvl3pPr marL="838200" indent="-228600">
               <a:lnSpc>
@@ -2461,6 +2747,7 @@
                 <a:spcPts val="1200"/>
               </a:spcAft>
               <a:buChar char="•"/>
+              <a:defRPr/>
             </a:lvl3pPr>
             <a:lvl4pPr marL="1143000" indent="-228600">
               <a:lnSpc>
@@ -2473,6 +2760,7 @@
                 <a:spcPts val="1200"/>
               </a:spcAft>
               <a:buChar char="•"/>
+              <a:defRPr/>
             </a:lvl4pPr>
             <a:lvl5pPr marL="1447800" indent="-228600">
               <a:lnSpc>
@@ -2485,6 +2773,7 @@
                 <a:spcPts val="1200"/>
               </a:spcAft>
               <a:buChar char="•"/>
+              <a:defRPr/>
             </a:lvl5pPr>
             <a:lvl6pPr marL="1752600" indent="-228600">
               <a:lnSpc>
@@ -2497,6 +2786,7 @@
                 <a:spcPts val="1200"/>
               </a:spcAft>
               <a:buChar char="•"/>
+              <a:defRPr/>
             </a:lvl6pPr>
             <a:lvl7pPr marL="2057400" indent="-228600">
               <a:lnSpc>
@@ -2509,6 +2799,7 @@
                 <a:spcPts val="1200"/>
               </a:spcAft>
               <a:buChar char="•"/>
+              <a:defRPr/>
             </a:lvl7pPr>
             <a:lvl8pPr marL="2362200" indent="-228600">
               <a:lnSpc>
@@ -2521,6 +2812,7 @@
                 <a:spcPts val="1200"/>
               </a:spcAft>
               <a:buChar char="•"/>
+              <a:defRPr/>
             </a:lvl8pPr>
             <a:lvl9pPr marL="2667000" indent="-228600">
               <a:lnSpc>
@@ -2533,6 +2825,7 @@
                 <a:spcPts val="1200"/>
               </a:spcAft>
               <a:buChar char="•"/>
+              <a:defRPr/>
             </a:lvl9pPr>
           </a:lstStyle>
           <a:p xmlns:a="http://schemas.openxmlformats.org/drawingml/2006/main"/>
@@ -2594,6 +2887,7 @@
                 <a:spcPts val="1200"/>
               </a:spcAft>
               <a:buChar char="•"/>
+              <a:defRPr/>
             </a:lvl1pPr>
             <a:lvl2pPr marL="533400" indent="-228600">
               <a:lnSpc>
@@ -2606,6 +2900,7 @@
                 <a:spcPts val="1200"/>
               </a:spcAft>
               <a:buChar char="•"/>
+              <a:defRPr/>
             </a:lvl2pPr>
             <a:lvl3pPr marL="838200" indent="-228600">
               <a:lnSpc>
@@ -2618,6 +2913,7 @@
                 <a:spcPts val="1200"/>
               </a:spcAft>
               <a:buChar char="•"/>
+              <a:defRPr/>
             </a:lvl3pPr>
             <a:lvl4pPr marL="1143000" indent="-228600">
               <a:lnSpc>
@@ -2630,6 +2926,7 @@
                 <a:spcPts val="1200"/>
               </a:spcAft>
               <a:buChar char="•"/>
+              <a:defRPr/>
             </a:lvl4pPr>
             <a:lvl5pPr marL="1447800" indent="-228600">
               <a:lnSpc>
@@ -2642,6 +2939,7 @@
                 <a:spcPts val="1200"/>
               </a:spcAft>
               <a:buChar char="•"/>
+              <a:defRPr/>
             </a:lvl5pPr>
             <a:lvl6pPr marL="1752600" indent="-228600">
               <a:lnSpc>
@@ -2654,6 +2952,7 @@
                 <a:spcPts val="1200"/>
               </a:spcAft>
               <a:buChar char="•"/>
+              <a:defRPr/>
             </a:lvl6pPr>
             <a:lvl7pPr marL="2057400" indent="-228600">
               <a:lnSpc>
@@ -2666,6 +2965,7 @@
                 <a:spcPts val="1200"/>
               </a:spcAft>
               <a:buChar char="•"/>
+              <a:defRPr/>
             </a:lvl7pPr>
             <a:lvl8pPr marL="2362200" indent="-228600">
               <a:lnSpc>
@@ -2678,6 +2978,7 @@
                 <a:spcPts val="1200"/>
               </a:spcAft>
               <a:buChar char="•"/>
+              <a:defRPr/>
             </a:lvl8pPr>
             <a:lvl9pPr marL="2667000" indent="-228600">
               <a:lnSpc>
@@ -2690,6 +2991,7 @@
                 <a:spcPts val="1200"/>
               </a:spcAft>
               <a:buChar char="•"/>
+              <a:defRPr/>
             </a:lvl9pPr>
           </a:lstStyle>
           <a:p xmlns:a="http://schemas.openxmlformats.org/drawingml/2006/main"/>
@@ -2768,6 +3070,7 @@
                 <a:spcPts val="0"/>
               </a:spcAft>
               <a:buNone/>
+              <a:defRPr/>
             </a:lvl1pPr>
             <a:lvl2pPr marL="0" indent="0">
               <a:lnSpc>
@@ -2780,6 +3083,7 @@
                 <a:spcPts val="0"/>
               </a:spcAft>
               <a:buNone/>
+              <a:defRPr/>
             </a:lvl2pPr>
             <a:lvl3pPr marL="0" indent="0">
               <a:lnSpc>
@@ -2792,6 +3096,7 @@
                 <a:spcPts val="0"/>
               </a:spcAft>
               <a:buNone/>
+              <a:defRPr/>
             </a:lvl3pPr>
             <a:lvl4pPr marL="0" indent="0">
               <a:lnSpc>
@@ -2804,6 +3109,7 @@
                 <a:spcPts val="0"/>
               </a:spcAft>
               <a:buNone/>
+              <a:defRPr/>
             </a:lvl4pPr>
             <a:lvl5pPr marL="0" indent="0">
               <a:lnSpc>
@@ -2816,6 +3122,7 @@
                 <a:spcPts val="0"/>
               </a:spcAft>
               <a:buNone/>
+              <a:defRPr/>
             </a:lvl5pPr>
             <a:lvl6pPr marL="0" indent="0">
               <a:lnSpc>
@@ -2828,6 +3135,7 @@
                 <a:spcPts val="0"/>
               </a:spcAft>
               <a:buNone/>
+              <a:defRPr/>
             </a:lvl6pPr>
             <a:lvl7pPr marL="0" indent="0">
               <a:lnSpc>
@@ -2840,6 +3148,7 @@
                 <a:spcPts val="0"/>
               </a:spcAft>
               <a:buNone/>
+              <a:defRPr/>
             </a:lvl7pPr>
             <a:lvl8pPr marL="0" indent="0">
               <a:lnSpc>
@@ -2852,6 +3161,7 @@
                 <a:spcPts val="0"/>
               </a:spcAft>
               <a:buNone/>
+              <a:defRPr/>
             </a:lvl8pPr>
             <a:lvl9pPr marL="0" indent="0">
               <a:lnSpc>
@@ -2864,6 +3174,7 @@
                 <a:spcPts val="0"/>
               </a:spcAft>
               <a:buNone/>
+              <a:defRPr/>
             </a:lvl9pPr>
           </a:lstStyle>
           <a:p xmlns:a="http://schemas.openxmlformats.org/drawingml/2006/main"/>
@@ -2925,6 +3236,7 @@
                 <a:spcPts val="1200"/>
               </a:spcAft>
               <a:buChar char="•"/>
+              <a:defRPr/>
             </a:lvl1pPr>
             <a:lvl2pPr marL="533400" indent="-228600">
               <a:lnSpc>
@@ -2937,6 +3249,7 @@
                 <a:spcPts val="1200"/>
               </a:spcAft>
               <a:buChar char="•"/>
+              <a:defRPr/>
             </a:lvl2pPr>
             <a:lvl3pPr marL="838200" indent="-228600">
               <a:lnSpc>
@@ -2949,6 +3262,7 @@
                 <a:spcPts val="1200"/>
               </a:spcAft>
               <a:buChar char="•"/>
+              <a:defRPr/>
             </a:lvl3pPr>
             <a:lvl4pPr marL="1143000" indent="-228600">
               <a:lnSpc>
@@ -2961,6 +3275,7 @@
                 <a:spcPts val="1200"/>
               </a:spcAft>
               <a:buChar char="•"/>
+              <a:defRPr/>
             </a:lvl4pPr>
             <a:lvl5pPr marL="1447800" indent="-228600">
               <a:lnSpc>
@@ -2973,6 +3288,7 @@
                 <a:spcPts val="1200"/>
               </a:spcAft>
               <a:buChar char="•"/>
+              <a:defRPr/>
             </a:lvl5pPr>
             <a:lvl6pPr marL="1752600" indent="-228600">
               <a:lnSpc>
@@ -2985,6 +3301,7 @@
                 <a:spcPts val="1200"/>
               </a:spcAft>
               <a:buChar char="•"/>
+              <a:defRPr/>
             </a:lvl6pPr>
             <a:lvl7pPr marL="2057400" indent="-228600">
               <a:lnSpc>
@@ -2997,6 +3314,7 @@
                 <a:spcPts val="1200"/>
               </a:spcAft>
               <a:buChar char="•"/>
+              <a:defRPr/>
             </a:lvl7pPr>
             <a:lvl8pPr marL="2362200" indent="-228600">
               <a:lnSpc>
@@ -3009,6 +3327,7 @@
                 <a:spcPts val="1200"/>
               </a:spcAft>
               <a:buChar char="•"/>
+              <a:defRPr/>
             </a:lvl8pPr>
             <a:lvl9pPr marL="2667000" indent="-228600">
               <a:lnSpc>
@@ -3021,6 +3340,7 @@
                 <a:spcPts val="1200"/>
               </a:spcAft>
               <a:buChar char="•"/>
+              <a:defRPr/>
             </a:lvl9pPr>
           </a:lstStyle>
           <a:p xmlns:a="http://schemas.openxmlformats.org/drawingml/2006/main"/>
@@ -3069,12 +3389,12 @@
   </p:cSld>
   <p:clrMap bg1="lt1" tx1="dk1" bg2="lt2" tx2="dk2" accent1="accent1" accent2="accent2" accent3="accent3" accent4="accent4" accent5="accent5" accent6="accent6" hlink="hlink" folHlink="folHlink"/>
   <p:sldLayoutIdLst>
-    <p:sldLayoutId xmlns:r="http://schemas.openxmlformats.org/officeDocument/2006/relationships" id="2147483649" r:id="R3cba8072f76f4bb0"/>
-    <p:sldLayoutId xmlns:r="http://schemas.openxmlformats.org/officeDocument/2006/relationships" id="2147483650" r:id="R5d3b355cd7a34532"/>
-    <p:sldLayoutId xmlns:r="http://schemas.openxmlformats.org/officeDocument/2006/relationships" id="2147483651" r:id="R76dfd948e59746e3"/>
-    <p:sldLayoutId xmlns:r="http://schemas.openxmlformats.org/officeDocument/2006/relationships" id="2147483652" r:id="Rc87986c73f2c4c1b"/>
-    <p:sldLayoutId xmlns:r="http://schemas.openxmlformats.org/officeDocument/2006/relationships" id="2147483653" r:id="R5abe5141f1b347dd"/>
-    <p:sldLayoutId xmlns:r="http://schemas.openxmlformats.org/officeDocument/2006/relationships" id="2147483654" r:id="R89dbc5d3a5db4ab4"/>
+    <p:sldLayoutId xmlns:r="http://schemas.openxmlformats.org/officeDocument/2006/relationships" id="2147483649" r:id="Raecaad7ad74b44cc"/>
+    <p:sldLayoutId xmlns:r="http://schemas.openxmlformats.org/officeDocument/2006/relationships" id="2147483650" r:id="R972374664ad946bd"/>
+    <p:sldLayoutId xmlns:r="http://schemas.openxmlformats.org/officeDocument/2006/relationships" id="2147483651" r:id="R7a6b5cdaaa2a425c"/>
+    <p:sldLayoutId xmlns:r="http://schemas.openxmlformats.org/officeDocument/2006/relationships" id="2147483652" r:id="Rbce73dadbc924056"/>
+    <p:sldLayoutId xmlns:r="http://schemas.openxmlformats.org/officeDocument/2006/relationships" id="2147483653" r:id="R763df4c8c6ae44db"/>
+    <p:sldLayoutId xmlns:r="http://schemas.openxmlformats.org/officeDocument/2006/relationships" id="2147483654" r:id="Rfc215bffeaa24687"/>
   </p:sldLayoutIdLst>
   <p:txStyles>
     <p:titleStyle>
@@ -3625,7 +3945,7 @@
           <p:cNvPr id="7" name="">
             <a:extLst xmlns:a="http://schemas.openxmlformats.org/drawingml/2006/main">
               <a:ext uri="{FF2B5EF4-FFF2-40B4-BE49-F238E27FC236}">
-                <a16:creationId xmlns:a16="http://schemas.microsoft.com/office/drawing/2014/main" id="{9A50D768-B5BC-443A-A5F2-CD321A669559}"/>
+                <a16:creationId xmlns:a16="http://schemas.microsoft.com/office/drawing/2014/main" id="{73A5D5CF-F8B8-4044-A823-C529341296B0}"/>
               </a:ext>
             </a:extLst>
           </p:cNvPr>
@@ -3635,7 +3955,7 @@
           <p:nvPr/>
         </p:nvPicPr>
         <p:blipFill>
-          <a:blip xmlns:r="http://schemas.openxmlformats.org/officeDocument/2006/relationships" xmlns:a="http://schemas.openxmlformats.org/drawingml/2006/main" r:embed="R85dbd165d84042b2"/>
+          <a:blip xmlns:r="http://schemas.openxmlformats.org/officeDocument/2006/relationships" xmlns:a="http://schemas.openxmlformats.org/drawingml/2006/main" r:embed="R2e8503a1a1db452e"/>
           <a:stretch xmlns:a="http://schemas.openxmlformats.org/drawingml/2006/main"/>
         </p:blipFill>
         <p:spPr>
@@ -3693,6 +4013,7 @@
           </a:lstStyle>
           <a:p xmlns:a="http://schemas.openxmlformats.org/drawingml/2006/main">
             <a:pPr>
+              <a:buNone/>
               <a:defRPr sz="2025" b="0">
                 <a:solidFill>
                   <a:srgbClr val="E2EBE9"/>
@@ -3761,6 +4082,7 @@
           </a:lstStyle>
           <a:p xmlns:a="http://schemas.openxmlformats.org/drawingml/2006/main">
             <a:pPr>
+              <a:buNone/>
               <a:defRPr sz="8400" b="1">
                 <a:solidFill>
                   <a:srgbClr val="FFFFFF"/>
@@ -3829,6 +4151,7 @@
           </a:lstStyle>
           <a:p xmlns:a="http://schemas.openxmlformats.org/drawingml/2006/main">
             <a:pPr>
+              <a:buNone/>
               <a:defRPr sz="3150" b="0">
                 <a:solidFill>
                   <a:srgbClr val="FFFFFF"/>
@@ -3897,6 +4220,7 @@
           </a:lstStyle>
           <a:p xmlns:a="http://schemas.openxmlformats.org/drawingml/2006/main">
             <a:pPr>
+              <a:buNone/>
               <a:defRPr sz="1875" b="0">
                 <a:solidFill>
                   <a:srgbClr val="E2EBE9"/>
@@ -3965,6 +4289,7 @@
           </a:lstStyle>
           <a:p xmlns:a="http://schemas.openxmlformats.org/drawingml/2006/main">
             <a:pPr>
+              <a:buNone/>
               <a:defRPr sz="1350" b="0">
                 <a:solidFill>
                   <a:srgbClr val="E2EBE9"/>
@@ -4062,6 +4387,7 @@
           </a:lstStyle>
           <a:p xmlns:a="http://schemas.openxmlformats.org/drawingml/2006/main">
             <a:pPr>
+              <a:buNone/>
               <a:defRPr sz="1350" b="0">
                 <a:solidFill>
                   <a:srgbClr val="606C70"/>
@@ -4130,6 +4456,7 @@
           </a:lstStyle>
           <a:p xmlns:a="http://schemas.openxmlformats.org/drawingml/2006/main">
             <a:pPr>
+              <a:buNone/>
               <a:defRPr sz="3450" b="1">
                 <a:solidFill>
                   <a:srgbClr val="252B2C"/>
@@ -4148,7 +4475,7 @@
                 <a:ea typeface="Pretendard"/>
                 <a:cs typeface="Pretendard"/>
               </a:rPr>
-              <a:t>현재 상태와 다음 과제</a:t>
+              <a:t>만든 것, 확인한 것, 다음에 할 것</a:t>
             </a:r>
           </a:p>
         </p:txBody>
@@ -4198,6 +4525,7 @@
           </a:lstStyle>
           <a:p xmlns:a="http://schemas.openxmlformats.org/drawingml/2006/main">
             <a:pPr>
+              <a:buNone/>
               <a:defRPr sz="1875" b="0">
                 <a:solidFill>
                   <a:srgbClr val="606C70"/>
@@ -4216,7 +4544,7 @@
                 <a:ea typeface="Pretendard"/>
                 <a:cs typeface="Pretendard"/>
               </a:rPr>
-              <a:t>직접 써 보면서 입력과 대기 시간을 더 줄이려 합니다</a:t>
+              <a:t>예약에서 일정까지 연결한 비공개 베타</a:t>
             </a:r>
           </a:p>
         </p:txBody>
@@ -4266,6 +4594,7 @@
           </a:lstStyle>
           <a:p xmlns:a="http://schemas.openxmlformats.org/drawingml/2006/main">
             <a:pPr>
+              <a:buNone/>
               <a:defRPr sz="1275" b="0">
                 <a:solidFill>
                   <a:srgbClr val="606C70"/>
@@ -4334,6 +4663,7 @@
           </a:lstStyle>
           <a:p xmlns:a="http://schemas.openxmlformats.org/drawingml/2006/main">
             <a:pPr>
+              <a:buNone/>
               <a:defRPr sz="1200" b="0">
                 <a:solidFill>
                   <a:srgbClr val="606C70"/>
@@ -4352,7 +4682,7 @@
                 <a:ea typeface="Pretendard"/>
                 <a:cs typeface="Pretendard"/>
               </a:rPr>
-              <a:t>고잉 · Travel Agent  |  2026.10</a:t>
+              <a:t/>
             </a:r>
           </a:p>
         </p:txBody>
@@ -4373,8 +4703,8 @@
         </p:nvSpPr>
         <p:spPr>
           <a:xfrm xmlns:a="http://schemas.openxmlformats.org/drawingml/2006/main">
-            <a:off x="609600" y="2343150"/>
-            <a:ext cx="4714875" cy="847725"/>
+            <a:off x="609600" y="2324100"/>
+            <a:ext cx="5143500" cy="523875"/>
           </a:xfrm>
           <a:prstGeom xmlns:a="http://schemas.openxmlformats.org/drawingml/2006/main" prst="rect">
             <a:avLst/>
@@ -4390,7 +4720,7 @@
           </a:bodyPr>
           <a:lstStyle xmlns:a="http://schemas.openxmlformats.org/drawingml/2006/main">
             <a:defPPr>
-              <a:defRPr sz="5100" b="1">
+              <a:defRPr sz="2400" b="1">
                 <a:solidFill>
                   <a:srgbClr val="25485A"/>
                 </a:solidFill>
@@ -4402,7 +4732,8 @@
           </a:lstStyle>
           <a:p xmlns:a="http://schemas.openxmlformats.org/drawingml/2006/main">
             <a:pPr>
-              <a:defRPr sz="5100" b="1">
+              <a:buNone/>
+              <a:defRPr sz="2400" b="1">
                 <a:solidFill>
                   <a:srgbClr val="25485A"/>
                 </a:solidFill>
@@ -4412,7 +4743,7 @@
               </a:defRPr>
             </a:pPr>
             <a:r>
-              <a:rPr sz="5100" b="1">
+              <a:rPr sz="2400" b="1">
                 <a:solidFill>
                   <a:srgbClr val="25485A"/>
                 </a:solidFill>
@@ -4420,7 +4751,7 @@
                 <a:ea typeface="Pretendard"/>
                 <a:cs typeface="Pretendard"/>
               </a:rPr>
-              <a:t>1,039</a:t>
+              <a:t>연결한 흐름</a:t>
             </a:r>
           </a:p>
         </p:txBody>
@@ -4441,8 +4772,8 @@
         </p:nvSpPr>
         <p:spPr>
           <a:xfrm xmlns:a="http://schemas.openxmlformats.org/drawingml/2006/main">
-            <a:off x="609600" y="3248025"/>
-            <a:ext cx="5429250" cy="447675"/>
+            <a:off x="609600" y="3000375"/>
+            <a:ext cx="5191125" cy="971550"/>
           </a:xfrm>
           <a:prstGeom xmlns:a="http://schemas.openxmlformats.org/drawingml/2006/main" prst="rect">
             <a:avLst/>
@@ -4458,9 +4789,9 @@
           </a:bodyPr>
           <a:lstStyle xmlns:a="http://schemas.openxmlformats.org/drawingml/2006/main">
             <a:defPPr>
-              <a:defRPr sz="1725" b="0">
-                <a:solidFill>
-                  <a:srgbClr val="606C70"/>
+              <a:defRPr sz="2100" b="0">
+                <a:solidFill>
+                  <a:srgbClr val="252B2C"/>
                 </a:solidFill>
                 <a:latin typeface="Pretendard"/>
                 <a:ea typeface="Pretendard"/>
@@ -4470,9 +4801,10 @@
           </a:lstStyle>
           <a:p xmlns:a="http://schemas.openxmlformats.org/drawingml/2006/main">
             <a:pPr>
-              <a:defRPr sz="1725" b="0">
-                <a:solidFill>
-                  <a:srgbClr val="606C70"/>
+              <a:buNone/>
+              <a:defRPr sz="2100" b="0">
+                <a:solidFill>
+                  <a:srgbClr val="252B2C"/>
                 </a:solidFill>
                 <a:latin typeface="Pretendard"/>
                 <a:ea typeface="Pretendard"/>
@@ -4480,15 +4812,39 @@
               </a:defRPr>
             </a:pPr>
             <a:r>
-              <a:rPr sz="1725" b="0">
-                <a:solidFill>
-                  <a:srgbClr val="606C70"/>
+              <a:rPr sz="2100" b="0">
+                <a:solidFill>
+                  <a:srgbClr val="252B2C"/>
                 </a:solidFill>
                 <a:latin typeface="Pretendard"/>
                 <a:ea typeface="Pretendard"/>
                 <a:cs typeface="Pretendard"/>
               </a:rPr>
-              <a:t>Python 시험 통과 · 외부 환경 15개 skip</a:t>
+              <a:t>예약 정리 → 질문 → 장소 탐색</a:t>
+            </a:r>
+          </a:p>
+          <a:p xmlns:a="http://schemas.openxmlformats.org/drawingml/2006/main">
+            <a:pPr>
+              <a:buNone/>
+              <a:defRPr sz="2100" b="0">
+                <a:solidFill>
+                  <a:srgbClr val="252B2C"/>
+                </a:solidFill>
+                <a:latin typeface="Pretendard"/>
+                <a:ea typeface="Pretendard"/>
+                <a:cs typeface="Pretendard"/>
+              </a:defRPr>
+            </a:pPr>
+            <a:r>
+              <a:rPr sz="2100" b="0">
+                <a:solidFill>
+                  <a:srgbClr val="252B2C"/>
+                </a:solidFill>
+                <a:latin typeface="Pretendard"/>
+                <a:ea typeface="Pretendard"/>
+                <a:cs typeface="Pretendard"/>
+              </a:rPr>
+              <a:t>→ 일정 생성·편집</a:t>
             </a:r>
           </a:p>
         </p:txBody>
@@ -4509,8 +4865,8 @@
         </p:nvSpPr>
         <p:spPr>
           <a:xfrm xmlns:a="http://schemas.openxmlformats.org/drawingml/2006/main">
-            <a:off x="6619875" y="2343150"/>
-            <a:ext cx="4286250" cy="847725"/>
+            <a:off x="6619875" y="2324100"/>
+            <a:ext cx="4857750" cy="523875"/>
           </a:xfrm>
           <a:prstGeom xmlns:a="http://schemas.openxmlformats.org/drawingml/2006/main" prst="rect">
             <a:avLst/>
@@ -4526,7 +4882,7 @@
           </a:bodyPr>
           <a:lstStyle xmlns:a="http://schemas.openxmlformats.org/drawingml/2006/main">
             <a:defPPr>
-              <a:defRPr sz="5100" b="1">
+              <a:defRPr sz="2400" b="1">
                 <a:solidFill>
                   <a:srgbClr val="25485A"/>
                 </a:solidFill>
@@ -4538,7 +4894,8 @@
           </a:lstStyle>
           <a:p xmlns:a="http://schemas.openxmlformats.org/drawingml/2006/main">
             <a:pPr>
-              <a:defRPr sz="5100" b="1">
+              <a:buNone/>
+              <a:defRPr sz="2400" b="1">
                 <a:solidFill>
                   <a:srgbClr val="25485A"/>
                 </a:solidFill>
@@ -4548,7 +4905,7 @@
               </a:defRPr>
             </a:pPr>
             <a:r>
-              <a:rPr sz="5100" b="1">
+              <a:rPr sz="2400" b="1">
                 <a:solidFill>
                   <a:srgbClr val="25485A"/>
                 </a:solidFill>
@@ -4556,7 +4913,7 @@
                 <a:ea typeface="Pretendard"/>
                 <a:cs typeface="Pretendard"/>
               </a:rPr>
-              <a:t>124</a:t>
+              <a:t>아직 확인할 것</a:t>
             </a:r>
           </a:p>
         </p:txBody>
@@ -4577,8 +4934,8 @@
         </p:nvSpPr>
         <p:spPr>
           <a:xfrm xmlns:a="http://schemas.openxmlformats.org/drawingml/2006/main">
-            <a:off x="6619875" y="3248025"/>
-            <a:ext cx="4286250" cy="447675"/>
+            <a:off x="6619875" y="3000375"/>
+            <a:ext cx="4857750" cy="971550"/>
           </a:xfrm>
           <a:prstGeom xmlns:a="http://schemas.openxmlformats.org/drawingml/2006/main" prst="rect">
             <a:avLst/>
@@ -4594,9 +4951,9 @@
           </a:bodyPr>
           <a:lstStyle xmlns:a="http://schemas.openxmlformats.org/drawingml/2006/main">
             <a:defPPr>
-              <a:defRPr sz="1725" b="0">
-                <a:solidFill>
-                  <a:srgbClr val="606C70"/>
+              <a:defRPr sz="2100" b="0">
+                <a:solidFill>
+                  <a:srgbClr val="252B2C"/>
                 </a:solidFill>
                 <a:latin typeface="Pretendard"/>
                 <a:ea typeface="Pretendard"/>
@@ -4606,9 +4963,10 @@
           </a:lstStyle>
           <a:p xmlns:a="http://schemas.openxmlformats.org/drawingml/2006/main">
             <a:pPr>
-              <a:defRPr sz="1725" b="0">
-                <a:solidFill>
-                  <a:srgbClr val="606C70"/>
+              <a:buNone/>
+              <a:defRPr sz="2100" b="0">
+                <a:solidFill>
+                  <a:srgbClr val="252B2C"/>
                 </a:solidFill>
                 <a:latin typeface="Pretendard"/>
                 <a:ea typeface="Pretendard"/>
@@ -4616,15 +4974,39 @@
               </a:defRPr>
             </a:pPr>
             <a:r>
-              <a:rPr sz="1725" b="0">
-                <a:solidFill>
-                  <a:srgbClr val="606C70"/>
+              <a:rPr sz="2100" b="0">
+                <a:solidFill>
+                  <a:srgbClr val="252B2C"/>
                 </a:solidFill>
                 <a:latin typeface="Pretendard"/>
                 <a:ea typeface="Pretendard"/>
                 <a:cs typeface="Pretendard"/>
               </a:rPr>
-              <a:t>JavaScript 시험 통과</a:t>
+              <a:t>도시별 자료의 충분함</a:t>
+            </a:r>
+          </a:p>
+          <a:p xmlns:a="http://schemas.openxmlformats.org/drawingml/2006/main">
+            <a:pPr>
+              <a:buNone/>
+              <a:defRPr sz="2100" b="0">
+                <a:solidFill>
+                  <a:srgbClr val="252B2C"/>
+                </a:solidFill>
+                <a:latin typeface="Pretendard"/>
+                <a:ea typeface="Pretendard"/>
+                <a:cs typeface="Pretendard"/>
+              </a:defRPr>
+            </a:pPr>
+            <a:r>
+              <a:rPr sz="2100" b="0">
+                <a:solidFill>
+                  <a:srgbClr val="252B2C"/>
+                </a:solidFill>
+                <a:latin typeface="Pretendard"/>
+                <a:ea typeface="Pretendard"/>
+                <a:cs typeface="Pretendard"/>
+              </a:rPr>
+              <a:t>실제 사용자의 만족도</a:t>
             </a:r>
           </a:p>
         </p:txBody>
@@ -4645,8 +5027,8 @@
         </p:nvSpPr>
         <p:spPr>
           <a:xfrm xmlns:a="http://schemas.openxmlformats.org/drawingml/2006/main">
-            <a:off x="609600" y="4305300"/>
-            <a:ext cx="10763250" cy="571500"/>
+            <a:off x="609600" y="4495800"/>
+            <a:ext cx="10953750" cy="590550"/>
           </a:xfrm>
           <a:prstGeom xmlns:a="http://schemas.openxmlformats.org/drawingml/2006/main" prst="rect">
             <a:avLst/>
@@ -4674,6 +5056,7 @@
           </a:lstStyle>
           <a:p xmlns:a="http://schemas.openxmlformats.org/drawingml/2006/main">
             <a:pPr>
+              <a:buNone/>
               <a:defRPr sz="2700" b="1">
                 <a:solidFill>
                   <a:srgbClr val="252B2C"/>
@@ -4692,7 +5075,7 @@
                 <a:ea typeface="Pretendard"/>
                 <a:cs typeface="Pretendard"/>
               </a:rPr>
-              <a:t>다음은 실제 사용에서 막히는 지점</a:t>
+              <a:t>다음 목표: 검색 대기와 불편한 입력 줄이기</a:t>
             </a:r>
           </a:p>
         </p:txBody>
@@ -4713,7 +5096,7 @@
         </p:nvSpPr>
         <p:spPr>
           <a:xfrm xmlns:a="http://schemas.openxmlformats.org/drawingml/2006/main">
-            <a:off x="609600" y="5038725"/>
+            <a:off x="609600" y="5229225"/>
             <a:ext cx="10953750" cy="495300"/>
           </a:xfrm>
           <a:prstGeom xmlns:a="http://schemas.openxmlformats.org/drawingml/2006/main" prst="rect">
@@ -4730,9 +5113,9 @@
           </a:bodyPr>
           <a:lstStyle xmlns:a="http://schemas.openxmlformats.org/drawingml/2006/main">
             <a:defPPr>
-              <a:defRPr sz="2175" b="0">
-                <a:solidFill>
-                  <a:srgbClr val="252B2C"/>
+              <a:defRPr sz="2100" b="0">
+                <a:solidFill>
+                  <a:srgbClr val="25485A"/>
                 </a:solidFill>
                 <a:latin typeface="Pretendard"/>
                 <a:ea typeface="Pretendard"/>
@@ -4742,9 +5125,10 @@
           </a:lstStyle>
           <a:p xmlns:a="http://schemas.openxmlformats.org/drawingml/2006/main">
             <a:pPr>
-              <a:defRPr sz="2175" b="0">
-                <a:solidFill>
-                  <a:srgbClr val="252B2C"/>
+              <a:buNone/>
+              <a:defRPr sz="2100" b="0">
+                <a:solidFill>
+                  <a:srgbClr val="25485A"/>
                 </a:solidFill>
                 <a:latin typeface="Pretendard"/>
                 <a:ea typeface="Pretendard"/>
@@ -4752,15 +5136,15 @@
               </a:defRPr>
             </a:pPr>
             <a:r>
-              <a:rPr sz="2175" b="0">
-                <a:solidFill>
-                  <a:srgbClr val="252B2C"/>
+              <a:rPr sz="2100" b="0">
+                <a:solidFill>
+                  <a:srgbClr val="25485A"/>
                 </a:solidFill>
                 <a:latin typeface="Pretendard"/>
                 <a:ea typeface="Pretendard"/>
                 <a:cs typeface="Pretendard"/>
               </a:rPr>
-              <a:t>반복 입력 줄이기 · 검색 대기 개선 · 도시별 근거 보강</a:t>
+              <a:t>AI의 답변뿐 아니라 근거와 실패 이후까지 설계했습니다.</a:t>
             </a:r>
           </a:p>
         </p:txBody>
@@ -4781,8 +5165,8 @@
         </p:nvSpPr>
         <p:spPr>
           <a:xfrm xmlns:a="http://schemas.openxmlformats.org/drawingml/2006/main">
-            <a:off x="609600" y="5838825"/>
-            <a:ext cx="10953750" cy="381000"/>
+            <a:off x="609600" y="6057900"/>
+            <a:ext cx="10715625" cy="304800"/>
           </a:xfrm>
           <a:prstGeom xmlns:a="http://schemas.openxmlformats.org/drawingml/2006/main" prst="rect">
             <a:avLst/>
@@ -4798,7 +5182,7 @@
           </a:bodyPr>
           <a:lstStyle xmlns:a="http://schemas.openxmlformats.org/drawingml/2006/main">
             <a:defPPr>
-              <a:defRPr sz="1650" b="0">
+              <a:defRPr sz="1500" b="0">
                 <a:solidFill>
                   <a:srgbClr val="606C70"/>
                 </a:solidFill>
@@ -4810,7 +5194,8 @@
           </a:lstStyle>
           <a:p xmlns:a="http://schemas.openxmlformats.org/drawingml/2006/main">
             <a:pPr>
-              <a:defRPr sz="1650" b="0">
+              <a:buNone/>
+              <a:defRPr sz="1500" b="0">
                 <a:solidFill>
                   <a:srgbClr val="606C70"/>
                 </a:solidFill>
@@ -4820,7 +5205,7 @@
               </a:defRPr>
             </a:pPr>
             <a:r>
-              <a:rPr sz="1650" b="0">
+              <a:rPr sz="1500" b="0">
                 <a:solidFill>
                   <a:srgbClr val="606C70"/>
                 </a:solidFill>
@@ -4828,7 +5213,7 @@
                 <a:ea typeface="Pretendard"/>
                 <a:cs typeface="Pretendard"/>
               </a:rPr>
-              <a:t>100개 도시 입력 지원 ≠ 100개 도시 추천 검증  /  실사용 만족도는 미측정</a:t>
+              <a:t>기존 회귀 시험: Python 1,039 · JS 124 통과 / Python 15 skip · 2026-10-07</a:t>
             </a:r>
           </a:p>
         </p:txBody>
@@ -4907,6 +5292,7 @@
           </a:lstStyle>
           <a:p xmlns:a="http://schemas.openxmlformats.org/drawingml/2006/main">
             <a:pPr>
+              <a:buNone/>
               <a:defRPr sz="1350" b="0">
                 <a:solidFill>
                   <a:srgbClr val="606C70"/>
@@ -4975,6 +5361,7 @@
           </a:lstStyle>
           <a:p xmlns:a="http://schemas.openxmlformats.org/drawingml/2006/main">
             <a:pPr>
+              <a:buNone/>
               <a:defRPr sz="3450" b="1">
                 <a:solidFill>
                   <a:srgbClr val="252B2C"/>
@@ -5043,6 +5430,7 @@
           </a:lstStyle>
           <a:p xmlns:a="http://schemas.openxmlformats.org/drawingml/2006/main">
             <a:pPr>
+              <a:buNone/>
               <a:defRPr sz="1875" b="0">
                 <a:solidFill>
                   <a:srgbClr val="606C70"/>
@@ -5111,6 +5499,7 @@
           </a:lstStyle>
           <a:p xmlns:a="http://schemas.openxmlformats.org/drawingml/2006/main">
             <a:pPr>
+              <a:buNone/>
               <a:defRPr sz="1275" b="0">
                 <a:solidFill>
                   <a:srgbClr val="606C70"/>
@@ -5179,6 +5568,7 @@
           </a:lstStyle>
           <a:p xmlns:a="http://schemas.openxmlformats.org/drawingml/2006/main">
             <a:pPr>
+              <a:buNone/>
               <a:defRPr sz="1200" b="0">
                 <a:solidFill>
                   <a:srgbClr val="606C70"/>
@@ -5197,7 +5587,7 @@
                 <a:ea typeface="Pretendard"/>
                 <a:cs typeface="Pretendard"/>
               </a:rPr>
-              <a:t>고잉 · Travel Agent  |  2026.10</a:t>
+              <a:t/>
             </a:r>
           </a:p>
         </p:txBody>
@@ -5247,6 +5637,7 @@
           </a:lstStyle>
           <a:p xmlns:a="http://schemas.openxmlformats.org/drawingml/2006/main">
             <a:pPr>
+              <a:buNone/>
               <a:defRPr sz="3375" b="1">
                 <a:solidFill>
                   <a:srgbClr val="25485A"/>
@@ -5315,6 +5706,7 @@
           </a:lstStyle>
           <a:p xmlns:a="http://schemas.openxmlformats.org/drawingml/2006/main">
             <a:pPr>
+              <a:buNone/>
               <a:defRPr sz="2700" b="0">
                 <a:solidFill>
                   <a:srgbClr val="252B2C"/>
@@ -5383,6 +5775,7 @@
           </a:lstStyle>
           <a:p xmlns:a="http://schemas.openxmlformats.org/drawingml/2006/main">
             <a:pPr>
+              <a:buNone/>
               <a:defRPr sz="2175" b="1">
                 <a:solidFill>
                   <a:srgbClr val="25485A"/>
@@ -5451,6 +5844,7 @@
           </a:lstStyle>
           <a:p xmlns:a="http://schemas.openxmlformats.org/drawingml/2006/main">
             <a:pPr>
+              <a:buNone/>
               <a:defRPr sz="1800" b="0">
                 <a:solidFill>
                   <a:srgbClr val="606C70"/>
@@ -5519,6 +5913,7 @@
           </a:lstStyle>
           <a:p xmlns:a="http://schemas.openxmlformats.org/drawingml/2006/main">
             <a:pPr>
+              <a:buNone/>
               <a:defRPr sz="2175" b="1">
                 <a:solidFill>
                   <a:srgbClr val="25485A"/>
@@ -5587,6 +5982,7 @@
           </a:lstStyle>
           <a:p xmlns:a="http://schemas.openxmlformats.org/drawingml/2006/main">
             <a:pPr>
+              <a:buNone/>
               <a:defRPr sz="1800" b="0">
                 <a:solidFill>
                   <a:srgbClr val="606C70"/>
@@ -5655,6 +6051,7 @@
           </a:lstStyle>
           <a:p xmlns:a="http://schemas.openxmlformats.org/drawingml/2006/main">
             <a:pPr>
+              <a:buNone/>
               <a:defRPr sz="2175" b="1">
                 <a:solidFill>
                   <a:srgbClr val="25485A"/>
@@ -5723,6 +6120,7 @@
           </a:lstStyle>
           <a:p xmlns:a="http://schemas.openxmlformats.org/drawingml/2006/main">
             <a:pPr>
+              <a:buNone/>
               <a:defRPr sz="1800" b="0">
                 <a:solidFill>
                   <a:srgbClr val="606C70"/>
@@ -5820,6 +6218,7 @@
           </a:lstStyle>
           <a:p xmlns:a="http://schemas.openxmlformats.org/drawingml/2006/main">
             <a:pPr>
+              <a:buNone/>
               <a:defRPr sz="1350" b="0">
                 <a:solidFill>
                   <a:srgbClr val="606C70"/>
@@ -5888,6 +6287,7 @@
           </a:lstStyle>
           <a:p xmlns:a="http://schemas.openxmlformats.org/drawingml/2006/main">
             <a:pPr>
+              <a:buNone/>
               <a:defRPr sz="3450" b="1">
                 <a:solidFill>
                   <a:srgbClr val="252B2C"/>
@@ -5956,6 +6356,7 @@
           </a:lstStyle>
           <a:p xmlns:a="http://schemas.openxmlformats.org/drawingml/2006/main">
             <a:pPr>
+              <a:buNone/>
               <a:defRPr sz="1875" b="0">
                 <a:solidFill>
                   <a:srgbClr val="606C70"/>
@@ -6024,6 +6425,7 @@
           </a:lstStyle>
           <a:p xmlns:a="http://schemas.openxmlformats.org/drawingml/2006/main">
             <a:pPr>
+              <a:buNone/>
               <a:defRPr sz="1275" b="0">
                 <a:solidFill>
                   <a:srgbClr val="606C70"/>
@@ -6092,6 +6494,7 @@
           </a:lstStyle>
           <a:p xmlns:a="http://schemas.openxmlformats.org/drawingml/2006/main">
             <a:pPr>
+              <a:buNone/>
               <a:defRPr sz="1200" b="0">
                 <a:solidFill>
                   <a:srgbClr val="606C70"/>
@@ -6110,7 +6513,7 @@
                 <a:ea typeface="Pretendard"/>
                 <a:cs typeface="Pretendard"/>
               </a:rPr>
-              <a:t>고잉 · Travel Agent  |  2026.10</a:t>
+              <a:t/>
             </a:r>
           </a:p>
         </p:txBody>
@@ -6160,6 +6563,7 @@
           </a:lstStyle>
           <a:p xmlns:a="http://schemas.openxmlformats.org/drawingml/2006/main">
             <a:pPr>
+              <a:buNone/>
               <a:defRPr sz="2400" b="1">
                 <a:solidFill>
                   <a:srgbClr val="25485A"/>
@@ -6228,6 +6632,7 @@
           </a:lstStyle>
           <a:p xmlns:a="http://schemas.openxmlformats.org/drawingml/2006/main">
             <a:pPr>
+              <a:buNone/>
               <a:defRPr sz="2100" b="0">
                 <a:solidFill>
                   <a:srgbClr val="252B2C"/>
@@ -6251,6 +6656,7 @@
           </a:p>
           <a:p xmlns:a="http://schemas.openxmlformats.org/drawingml/2006/main">
             <a:pPr>
+              <a:buNone/>
               <a:defRPr sz="2100" b="0">
                 <a:solidFill>
                   <a:srgbClr val="252B2C"/>
@@ -6319,6 +6725,7 @@
           </a:lstStyle>
           <a:p xmlns:a="http://schemas.openxmlformats.org/drawingml/2006/main">
             <a:pPr>
+              <a:buNone/>
               <a:defRPr sz="1875" b="0">
                 <a:solidFill>
                   <a:srgbClr val="606C70"/>
@@ -6342,6 +6749,7 @@
           </a:p>
           <a:p xmlns:a="http://schemas.openxmlformats.org/drawingml/2006/main">
             <a:pPr>
+              <a:buNone/>
               <a:defRPr sz="1875" b="0">
                 <a:solidFill>
                   <a:srgbClr val="606C70"/>
@@ -6370,7 +6778,7 @@
           <p:cNvPr id="9" name="">
             <a:extLst xmlns:a="http://schemas.openxmlformats.org/drawingml/2006/main">
               <a:ext uri="{FF2B5EF4-FFF2-40B4-BE49-F238E27FC236}">
-                <a16:creationId xmlns:a16="http://schemas.microsoft.com/office/drawing/2014/main" id="{784396CC-C044-445B-8294-D9B1EA95EEF5}"/>
+                <a16:creationId xmlns:a16="http://schemas.microsoft.com/office/drawing/2014/main" id="{68180F65-2821-4FC7-A348-FBD709B6AF98}"/>
               </a:ext>
             </a:extLst>
           </p:cNvPr>
@@ -6380,7 +6788,7 @@
           <p:nvPr/>
         </p:nvPicPr>
         <p:blipFill>
-          <a:blip xmlns:r="http://schemas.openxmlformats.org/officeDocument/2006/relationships" xmlns:a="http://schemas.openxmlformats.org/drawingml/2006/main" r:embed="R196a2ce353b24f81"/>
+          <a:blip xmlns:r="http://schemas.openxmlformats.org/officeDocument/2006/relationships" xmlns:a="http://schemas.openxmlformats.org/drawingml/2006/main" r:embed="Rf62ed2ee935c4c19"/>
           <a:stretch xmlns:a="http://schemas.openxmlformats.org/drawingml/2006/main"/>
         </p:blipFill>
         <p:spPr>
@@ -6467,6 +6875,7 @@
           </a:lstStyle>
           <a:p xmlns:a="http://schemas.openxmlformats.org/drawingml/2006/main">
             <a:pPr>
+              <a:buNone/>
               <a:defRPr sz="1350" b="0">
                 <a:solidFill>
                   <a:srgbClr val="606C70"/>
@@ -6535,6 +6944,7 @@
           </a:lstStyle>
           <a:p xmlns:a="http://schemas.openxmlformats.org/drawingml/2006/main">
             <a:pPr>
+              <a:buNone/>
               <a:defRPr sz="3450" b="1">
                 <a:solidFill>
                   <a:srgbClr val="252B2C"/>
@@ -6603,6 +7013,7 @@
           </a:lstStyle>
           <a:p xmlns:a="http://schemas.openxmlformats.org/drawingml/2006/main">
             <a:pPr>
+              <a:buNone/>
               <a:defRPr sz="1875" b="0">
                 <a:solidFill>
                   <a:srgbClr val="606C70"/>
@@ -6671,6 +7082,7 @@
           </a:lstStyle>
           <a:p xmlns:a="http://schemas.openxmlformats.org/drawingml/2006/main">
             <a:pPr>
+              <a:buNone/>
               <a:defRPr sz="1275" b="0">
                 <a:solidFill>
                   <a:srgbClr val="606C70"/>
@@ -6739,6 +7151,7 @@
           </a:lstStyle>
           <a:p xmlns:a="http://schemas.openxmlformats.org/drawingml/2006/main">
             <a:pPr>
+              <a:buNone/>
               <a:defRPr sz="1200" b="0">
                 <a:solidFill>
                   <a:srgbClr val="606C70"/>
@@ -6757,7 +7170,7 @@
                 <a:ea typeface="Pretendard"/>
                 <a:cs typeface="Pretendard"/>
               </a:rPr>
-              <a:t>고잉 · Travel Agent  |  2026.10</a:t>
+              <a:t/>
             </a:r>
           </a:p>
         </p:txBody>
@@ -6807,6 +7220,7 @@
           </a:lstStyle>
           <a:p xmlns:a="http://schemas.openxmlformats.org/drawingml/2006/main">
             <a:pPr>
+              <a:buNone/>
               <a:defRPr sz="2400" b="1">
                 <a:solidFill>
                   <a:srgbClr val="25485A"/>
@@ -6846,8 +7260,8 @@
         </p:nvSpPr>
         <p:spPr>
           <a:xfrm xmlns:a="http://schemas.openxmlformats.org/drawingml/2006/main">
-            <a:off x="609600" y="3057525"/>
-            <a:ext cx="5334000" cy="952500"/>
+            <a:off x="609600" y="3086100"/>
+            <a:ext cx="5524500" cy="666750"/>
           </a:xfrm>
           <a:prstGeom xmlns:a="http://schemas.openxmlformats.org/drawingml/2006/main" prst="rect">
             <a:avLst/>
@@ -6863,7 +7277,7 @@
           </a:bodyPr>
           <a:lstStyle xmlns:a="http://schemas.openxmlformats.org/drawingml/2006/main">
             <a:defPPr>
-              <a:defRPr sz="1950" b="0">
+              <a:defRPr sz="2175" b="0">
                 <a:solidFill>
                   <a:srgbClr val="252B2C"/>
                 </a:solidFill>
@@ -6875,7 +7289,8 @@
           </a:lstStyle>
           <a:p xmlns:a="http://schemas.openxmlformats.org/drawingml/2006/main">
             <a:pPr>
-              <a:defRPr sz="1950" b="0">
+              <a:buNone/>
+              <a:defRPr sz="2175" b="0">
                 <a:solidFill>
                   <a:srgbClr val="252B2C"/>
                 </a:solidFill>
@@ -6885,7 +7300,7 @@
               </a:defRPr>
             </a:pPr>
             <a:r>
-              <a:rPr sz="1950" b="0">
+              <a:rPr sz="2175" b="0">
                 <a:solidFill>
                   <a:srgbClr val="252B2C"/>
                 </a:solidFill>
@@ -6893,30 +7308,7 @@
                 <a:ea typeface="Pretendard"/>
                 <a:cs typeface="Pretendard"/>
               </a:rPr>
-              <a:t>gpt-5-mini · 구조화 추출</a:t>
-            </a:r>
-          </a:p>
-          <a:p xmlns:a="http://schemas.openxmlformats.org/drawingml/2006/main">
-            <a:pPr>
-              <a:defRPr sz="1950" b="0">
-                <a:solidFill>
-                  <a:srgbClr val="252B2C"/>
-                </a:solidFill>
-                <a:latin typeface="Pretendard"/>
-                <a:ea typeface="Pretendard"/>
-                <a:cs typeface="Pretendard"/>
-              </a:defRPr>
-            </a:pPr>
-            <a:r>
-              <a:rPr sz="1950" b="0">
-                <a:solidFill>
-                  <a:srgbClr val="252B2C"/>
-                </a:solidFill>
-                <a:latin typeface="Pretendard"/>
-                <a:ea typeface="Pretendard"/>
-                <a:cs typeface="Pretendard"/>
-              </a:rPr>
-              <a:t>text-embedding-3-small · 검색</a:t>
+              <a:t>AI가 읽고, 사용자가 확인합니다</a:t>
             </a:r>
           </a:p>
         </p:txBody>
@@ -6937,8 +7329,8 @@
         </p:nvSpPr>
         <p:spPr>
           <a:xfrm xmlns:a="http://schemas.openxmlformats.org/drawingml/2006/main">
-            <a:off x="609600" y="4333875"/>
-            <a:ext cx="5238750" cy="952500"/>
+            <a:off x="609600" y="4019550"/>
+            <a:ext cx="5619750" cy="1066800"/>
           </a:xfrm>
           <a:prstGeom xmlns:a="http://schemas.openxmlformats.org/drawingml/2006/main" prst="rect">
             <a:avLst/>
@@ -6954,7 +7346,7 @@
           </a:bodyPr>
           <a:lstStyle xmlns:a="http://schemas.openxmlformats.org/drawingml/2006/main">
             <a:defPPr>
-              <a:defRPr sz="2100" b="0">
+              <a:defRPr sz="2025" b="0">
                 <a:solidFill>
                   <a:srgbClr val="252B2C"/>
                 </a:solidFill>
@@ -6966,7 +7358,8 @@
           </a:lstStyle>
           <a:p xmlns:a="http://schemas.openxmlformats.org/drawingml/2006/main">
             <a:pPr>
-              <a:defRPr sz="2100" b="0">
+              <a:buNone/>
+              <a:defRPr sz="2025" b="0">
                 <a:solidFill>
                   <a:srgbClr val="252B2C"/>
                 </a:solidFill>
@@ -6976,7 +7369,7 @@
               </a:defRPr>
             </a:pPr>
             <a:r>
-              <a:rPr sz="2100" b="0">
+              <a:rPr sz="2025" b="0">
                 <a:solidFill>
                   <a:srgbClr val="252B2C"/>
                 </a:solidFill>
@@ -6984,12 +7377,13 @@
                 <a:ea typeface="Pretendard"/>
                 <a:cs typeface="Pretendard"/>
               </a:rPr>
-              <a:t>복수 예약 · 왕복 구간</a:t>
+              <a:t>복수 예약과 왕복편을 각각 저장</a:t>
             </a:r>
           </a:p>
           <a:p xmlns:a="http://schemas.openxmlformats.org/drawingml/2006/main">
             <a:pPr>
-              <a:defRPr sz="2100" b="0">
+              <a:buNone/>
+              <a:defRPr sz="2025" b="0">
                 <a:solidFill>
                   <a:srgbClr val="252B2C"/>
                 </a:solidFill>
@@ -6999,7 +7393,7 @@
               </a:defRPr>
             </a:pPr>
             <a:r>
-              <a:rPr sz="2100" b="0">
+              <a:rPr sz="2025" b="0">
                 <a:solidFill>
                   <a:srgbClr val="252B2C"/>
                 </a:solidFill>
@@ -7007,7 +7401,7 @@
                 <a:ea typeface="Pretendard"/>
                 <a:cs typeface="Pretendard"/>
               </a:rPr>
-              <a:t>현재 값 · 원문 · 사용자 교정</a:t>
+              <a:t>교정한 값은 재분석 후에도 보존</a:t>
             </a:r>
           </a:p>
         </p:txBody>
@@ -7028,8 +7422,8 @@
         </p:nvSpPr>
         <p:spPr>
           <a:xfrm xmlns:a="http://schemas.openxmlformats.org/drawingml/2006/main">
-            <a:off x="609600" y="5695950"/>
-            <a:ext cx="5219700" cy="571500"/>
+            <a:off x="609600" y="5505450"/>
+            <a:ext cx="5524500" cy="704850"/>
           </a:xfrm>
           <a:prstGeom xmlns:a="http://schemas.openxmlformats.org/drawingml/2006/main" prst="rect">
             <a:avLst/>
@@ -7045,7 +7439,7 @@
           </a:bodyPr>
           <a:lstStyle xmlns:a="http://schemas.openxmlformats.org/drawingml/2006/main">
             <a:defPPr>
-              <a:defRPr sz="1500" b="0">
+              <a:defRPr sz="1575" b="0">
                 <a:solidFill>
                   <a:srgbClr val="606C70"/>
                 </a:solidFill>
@@ -7057,7 +7451,8 @@
           </a:lstStyle>
           <a:p xmlns:a="http://schemas.openxmlformats.org/drawingml/2006/main">
             <a:pPr>
-              <a:defRPr sz="1500" b="0">
+              <a:buNone/>
+              <a:defRPr sz="1575" b="0">
                 <a:solidFill>
                   <a:srgbClr val="606C70"/>
                 </a:solidFill>
@@ -7067,7 +7462,7 @@
               </a:defRPr>
             </a:pPr>
             <a:r>
-              <a:rPr sz="1500" b="0">
+              <a:rPr sz="1575" b="0">
                 <a:solidFill>
                   <a:srgbClr val="606C70"/>
                 </a:solidFill>
@@ -7075,12 +7470,13 @@
                 <a:ea typeface="Pretendard"/>
                 <a:cs typeface="Pretendard"/>
               </a:rPr>
-              <a:t>촬영: 가상 메일 + 무료 기본 분석</a:t>
+              <a:t>운영: gpt-5-mini + 검색 임베딩</a:t>
             </a:r>
           </a:p>
           <a:p xmlns:a="http://schemas.openxmlformats.org/drawingml/2006/main">
             <a:pPr>
-              <a:defRPr sz="1500" b="0">
+              <a:buNone/>
+              <a:defRPr sz="1575" b="0">
                 <a:solidFill>
                   <a:srgbClr val="606C70"/>
                 </a:solidFill>
@@ -7090,7 +7486,7 @@
               </a:defRPr>
             </a:pPr>
             <a:r>
-              <a:rPr sz="1500" b="0">
+              <a:rPr sz="1575" b="0">
                 <a:solidFill>
                   <a:srgbClr val="606C70"/>
                 </a:solidFill>
@@ -7098,7 +7494,7 @@
                 <a:ea typeface="Pretendard"/>
                 <a:cs typeface="Pretendard"/>
               </a:rPr>
-              <a:t>운영 AI 검증은 별도 기록</a:t>
+              <a:t>화면: 가상 메일을 기본 분석한 예시</a:t>
             </a:r>
           </a:p>
         </p:txBody>
@@ -7108,7 +7504,7 @@
           <p:cNvPr id="10" name="">
             <a:extLst xmlns:a="http://schemas.openxmlformats.org/drawingml/2006/main">
               <a:ext uri="{FF2B5EF4-FFF2-40B4-BE49-F238E27FC236}">
-                <a16:creationId xmlns:a16="http://schemas.microsoft.com/office/drawing/2014/main" id="{817B81F0-0149-4E35-BFAE-315389B9AD5B}"/>
+                <a16:creationId xmlns:a16="http://schemas.microsoft.com/office/drawing/2014/main" id="{672E5BF4-B7AA-4E30-8C9F-56A530FDD559}"/>
               </a:ext>
             </a:extLst>
           </p:cNvPr>
@@ -7118,7 +7514,7 @@
           <p:nvPr/>
         </p:nvPicPr>
         <p:blipFill>
-          <a:blip xmlns:r="http://schemas.openxmlformats.org/officeDocument/2006/relationships" xmlns:a="http://schemas.openxmlformats.org/drawingml/2006/main" r:embed="Rc0ef4e2b741a44b3"/>
+          <a:blip xmlns:r="http://schemas.openxmlformats.org/officeDocument/2006/relationships" xmlns:a="http://schemas.openxmlformats.org/drawingml/2006/main" r:embed="Rf4a1d5331a14480d"/>
           <a:stretch xmlns:a="http://schemas.openxmlformats.org/drawingml/2006/main"/>
         </p:blipFill>
         <p:spPr>
@@ -7205,6 +7601,7 @@
           </a:lstStyle>
           <a:p xmlns:a="http://schemas.openxmlformats.org/drawingml/2006/main">
             <a:pPr>
+              <a:buNone/>
               <a:defRPr sz="1350" b="0">
                 <a:solidFill>
                   <a:srgbClr val="606C70"/>
@@ -7273,6 +7670,7 @@
           </a:lstStyle>
           <a:p xmlns:a="http://schemas.openxmlformats.org/drawingml/2006/main">
             <a:pPr>
+              <a:buNone/>
               <a:defRPr sz="3450" b="1">
                 <a:solidFill>
                   <a:srgbClr val="252B2C"/>
@@ -7291,7 +7689,7 @@
                 <a:ea typeface="Pretendard"/>
                 <a:cs typeface="Pretendard"/>
               </a:rPr>
-              <a:t>답변에 출처를 붙이기</a:t>
+              <a:t>하루 예약은 빠짐없이, 답변은 근거와 함께</a:t>
             </a:r>
           </a:p>
         </p:txBody>
@@ -7341,6 +7739,7 @@
           </a:lstStyle>
           <a:p xmlns:a="http://schemas.openxmlformats.org/drawingml/2006/main">
             <a:pPr>
+              <a:buNone/>
               <a:defRPr sz="1875" b="0">
                 <a:solidFill>
                   <a:srgbClr val="606C70"/>
@@ -7359,7 +7758,7 @@
                 <a:ea typeface="Pretendard"/>
                 <a:cs typeface="Pretendard"/>
               </a:rPr>
-              <a:t>날짜 질문은 그날 예약을 빠짐없이 조회합니다</a:t>
+              <a:t>날짜 전체 조회와 본문 검색을 구분합니다</a:t>
             </a:r>
           </a:p>
         </p:txBody>
@@ -7409,6 +7808,7 @@
           </a:lstStyle>
           <a:p xmlns:a="http://schemas.openxmlformats.org/drawingml/2006/main">
             <a:pPr>
+              <a:buNone/>
               <a:defRPr sz="1275" b="0">
                 <a:solidFill>
                   <a:srgbClr val="606C70"/>
@@ -7477,6 +7877,7 @@
           </a:lstStyle>
           <a:p xmlns:a="http://schemas.openxmlformats.org/drawingml/2006/main">
             <a:pPr>
+              <a:buNone/>
               <a:defRPr sz="1200" b="0">
                 <a:solidFill>
                   <a:srgbClr val="606C70"/>
@@ -7495,7 +7896,7 @@
                 <a:ea typeface="Pretendard"/>
                 <a:cs typeface="Pretendard"/>
               </a:rPr>
-              <a:t>고잉 · Travel Agent  |  2026.10</a:t>
+              <a:t/>
             </a:r>
           </a:p>
         </p:txBody>
@@ -7505,7 +7906,7 @@
           <p:cNvPr id="6" name="">
             <a:extLst xmlns:a="http://schemas.openxmlformats.org/drawingml/2006/main">
               <a:ext uri="{FF2B5EF4-FFF2-40B4-BE49-F238E27FC236}">
-                <a16:creationId xmlns:a16="http://schemas.microsoft.com/office/drawing/2014/main" id="{0F3365A9-EEEB-4ABD-9EB8-1D564C11A33D}"/>
+                <a16:creationId xmlns:a16="http://schemas.microsoft.com/office/drawing/2014/main" id="{037199FF-8EEA-40A6-A535-9406EF33B4AC}"/>
               </a:ext>
             </a:extLst>
           </p:cNvPr>
@@ -7515,7 +7916,7 @@
           <p:nvPr/>
         </p:nvPicPr>
         <p:blipFill>
-          <a:blip xmlns:r="http://schemas.openxmlformats.org/officeDocument/2006/relationships" xmlns:a="http://schemas.openxmlformats.org/drawingml/2006/main" r:embed="Rdb0d7a634fe34853"/>
+          <a:blip xmlns:r="http://schemas.openxmlformats.org/officeDocument/2006/relationships" xmlns:a="http://schemas.openxmlformats.org/drawingml/2006/main" r:embed="Rc09ad5a526d94cc0"/>
           <a:stretch xmlns:a="http://schemas.openxmlformats.org/drawingml/2006/main"/>
         </p:blipFill>
         <p:spPr>
@@ -7533,7 +7934,7 @@
           <p:cNvPr id="7" name="">
             <a:extLst xmlns:a="http://schemas.openxmlformats.org/drawingml/2006/main">
               <a:ext uri="{FF2B5EF4-FFF2-40B4-BE49-F238E27FC236}">
-                <a16:creationId xmlns:a16="http://schemas.microsoft.com/office/drawing/2014/main" id="{2F1B04BE-5E2D-4E35-AD4A-0C63FB763363}"/>
+                <a16:creationId xmlns:a16="http://schemas.microsoft.com/office/drawing/2014/main" id="{FCCC2C05-8F34-497C-8745-4ACCB5B089BC}"/>
               </a:ext>
             </a:extLst>
           </p:cNvPr>
@@ -7543,7 +7944,7 @@
           <p:nvPr/>
         </p:nvPicPr>
         <p:blipFill>
-          <a:blip xmlns:r="http://schemas.openxmlformats.org/officeDocument/2006/relationships" xmlns:a="http://schemas.openxmlformats.org/drawingml/2006/main" r:embed="R1f6a2b97aefa4adc"/>
+          <a:blip xmlns:r="http://schemas.openxmlformats.org/officeDocument/2006/relationships" xmlns:a="http://schemas.openxmlformats.org/drawingml/2006/main" r:embed="Rbe346d9918f04f10"/>
           <a:stretch xmlns:a="http://schemas.openxmlformats.org/drawingml/2006/main"/>
         </p:blipFill>
         <p:spPr>
@@ -7573,7 +7974,7 @@
         <p:spPr>
           <a:xfrm xmlns:a="http://schemas.openxmlformats.org/drawingml/2006/main">
             <a:off x="609600" y="6134100"/>
-            <a:ext cx="10858500" cy="314325"/>
+            <a:ext cx="10477500" cy="361950"/>
           </a:xfrm>
           <a:prstGeom xmlns:a="http://schemas.openxmlformats.org/drawingml/2006/main" prst="rect">
             <a:avLst/>
@@ -7589,7 +7990,7 @@
           </a:bodyPr>
           <a:lstStyle xmlns:a="http://schemas.openxmlformats.org/drawingml/2006/main">
             <a:defPPr>
-              <a:defRPr sz="1875" b="1">
+              <a:defRPr sz="1800" b="1">
                 <a:solidFill>
                   <a:srgbClr val="25485A"/>
                 </a:solidFill>
@@ -7601,7 +8002,8 @@
           </a:lstStyle>
           <a:p xmlns:a="http://schemas.openxmlformats.org/drawingml/2006/main">
             <a:pPr>
-              <a:defRPr sz="1875" b="1">
+              <a:buNone/>
+              <a:defRPr sz="1800" b="1">
                 <a:solidFill>
                   <a:srgbClr val="25485A"/>
                 </a:solidFill>
@@ -7611,7 +8013,7 @@
               </a:defRPr>
             </a:pPr>
             <a:r>
-              <a:rPr sz="1875" b="1">
+              <a:rPr sz="1800" b="1">
                 <a:solidFill>
                   <a:srgbClr val="25485A"/>
                 </a:solidFill>
@@ -7619,7 +8021,7 @@
                 <a:ea typeface="Pretendard"/>
                 <a:cs typeface="Pretendard"/>
               </a:rPr>
-              <a:t>SQL 날짜 조회 + 수동 입력 예약 + 원문 근거</a:t>
+              <a:t>날짜 전체는 SQL 조회 · 본문 설명은 근거 검색</a:t>
             </a:r>
           </a:p>
         </p:txBody>
@@ -7698,6 +8100,7 @@
           </a:lstStyle>
           <a:p xmlns:a="http://schemas.openxmlformats.org/drawingml/2006/main">
             <a:pPr>
+              <a:buNone/>
               <a:defRPr sz="1350" b="0">
                 <a:solidFill>
                   <a:srgbClr val="606C70"/>
@@ -7766,6 +8169,7 @@
           </a:lstStyle>
           <a:p xmlns:a="http://schemas.openxmlformats.org/drawingml/2006/main">
             <a:pPr>
+              <a:buNone/>
               <a:defRPr sz="3450" b="1">
                 <a:solidFill>
                   <a:srgbClr val="252B2C"/>
@@ -7834,6 +8238,7 @@
           </a:lstStyle>
           <a:p xmlns:a="http://schemas.openxmlformats.org/drawingml/2006/main">
             <a:pPr>
+              <a:buNone/>
               <a:defRPr sz="1875" b="0">
                 <a:solidFill>
                   <a:srgbClr val="606C70"/>
@@ -7902,6 +8307,7 @@
           </a:lstStyle>
           <a:p xmlns:a="http://schemas.openxmlformats.org/drawingml/2006/main">
             <a:pPr>
+              <a:buNone/>
               <a:defRPr sz="1275" b="0">
                 <a:solidFill>
                   <a:srgbClr val="606C70"/>
@@ -7970,6 +8376,7 @@
           </a:lstStyle>
           <a:p xmlns:a="http://schemas.openxmlformats.org/drawingml/2006/main">
             <a:pPr>
+              <a:buNone/>
               <a:defRPr sz="1200" b="0">
                 <a:solidFill>
                   <a:srgbClr val="606C70"/>
@@ -7988,7 +8395,7 @@
                 <a:ea typeface="Pretendard"/>
                 <a:cs typeface="Pretendard"/>
               </a:rPr>
-              <a:t>고잉 · Travel Agent  |  2026.10</a:t>
+              <a:t/>
             </a:r>
           </a:p>
         </p:txBody>
@@ -8038,6 +8445,7 @@
           </a:lstStyle>
           <a:p xmlns:a="http://schemas.openxmlformats.org/drawingml/2006/main">
             <a:pPr>
+              <a:buNone/>
               <a:defRPr sz="2400" b="1">
                 <a:solidFill>
                   <a:srgbClr val="25485A"/>
@@ -8106,6 +8514,7 @@
           </a:lstStyle>
           <a:p xmlns:a="http://schemas.openxmlformats.org/drawingml/2006/main">
             <a:pPr>
+              <a:buNone/>
               <a:defRPr sz="2175" b="0">
                 <a:solidFill>
                   <a:srgbClr val="252B2C"/>
@@ -8129,6 +8538,7 @@
           </a:p>
           <a:p xmlns:a="http://schemas.openxmlformats.org/drawingml/2006/main">
             <a:pPr>
+              <a:buNone/>
               <a:defRPr sz="2175" b="0">
                 <a:solidFill>
                   <a:srgbClr val="252B2C"/>
@@ -8197,6 +8607,7 @@
           </a:lstStyle>
           <a:p xmlns:a="http://schemas.openxmlformats.org/drawingml/2006/main">
             <a:pPr>
+              <a:buNone/>
               <a:defRPr sz="1875" b="0">
                 <a:solidFill>
                   <a:srgbClr val="606C70"/>
@@ -8220,6 +8631,7 @@
           </a:p>
           <a:p xmlns:a="http://schemas.openxmlformats.org/drawingml/2006/main">
             <a:pPr>
+              <a:buNone/>
               <a:defRPr sz="1875" b="0">
                 <a:solidFill>
                   <a:srgbClr val="606C70"/>
@@ -8288,6 +8700,7 @@
           </a:lstStyle>
           <a:p xmlns:a="http://schemas.openxmlformats.org/drawingml/2006/main">
             <a:pPr>
+              <a:buNone/>
               <a:defRPr sz="1350" b="0">
                 <a:solidFill>
                   <a:srgbClr val="606C70"/>
@@ -8316,7 +8729,7 @@
           <p:cNvPr id="10" name="">
             <a:extLst xmlns:a="http://schemas.openxmlformats.org/drawingml/2006/main">
               <a:ext uri="{FF2B5EF4-FFF2-40B4-BE49-F238E27FC236}">
-                <a16:creationId xmlns:a16="http://schemas.microsoft.com/office/drawing/2014/main" id="{5B9D4CD3-BFAC-4B64-8B57-D8AED2D3B602}"/>
+                <a16:creationId xmlns:a16="http://schemas.microsoft.com/office/drawing/2014/main" id="{B2DFE606-F84A-420E-9F34-C77E85F76105}"/>
               </a:ext>
             </a:extLst>
           </p:cNvPr>
@@ -8326,7 +8739,7 @@
           <p:nvPr/>
         </p:nvPicPr>
         <p:blipFill>
-          <a:blip xmlns:r="http://schemas.openxmlformats.org/officeDocument/2006/relationships" xmlns:a="http://schemas.openxmlformats.org/drawingml/2006/main" r:embed="R369d28d0acf84891"/>
+          <a:blip xmlns:r="http://schemas.openxmlformats.org/officeDocument/2006/relationships" xmlns:a="http://schemas.openxmlformats.org/drawingml/2006/main" r:embed="R85e4734dc968485c"/>
           <a:stretch xmlns:a="http://schemas.openxmlformats.org/drawingml/2006/main"/>
         </p:blipFill>
         <p:spPr>
@@ -8413,6 +8826,7 @@
           </a:lstStyle>
           <a:p xmlns:a="http://schemas.openxmlformats.org/drawingml/2006/main">
             <a:pPr>
+              <a:buNone/>
               <a:defRPr sz="1350" b="0">
                 <a:solidFill>
                   <a:srgbClr val="606C70"/>
@@ -8481,6 +8895,7 @@
           </a:lstStyle>
           <a:p xmlns:a="http://schemas.openxmlformats.org/drawingml/2006/main">
             <a:pPr>
+              <a:buNone/>
               <a:defRPr sz="3450" b="1">
                 <a:solidFill>
                   <a:srgbClr val="252B2C"/>
@@ -8549,6 +8964,7 @@
           </a:lstStyle>
           <a:p xmlns:a="http://schemas.openxmlformats.org/drawingml/2006/main">
             <a:pPr>
+              <a:buNone/>
               <a:defRPr sz="1875" b="0">
                 <a:solidFill>
                   <a:srgbClr val="606C70"/>
@@ -8617,6 +9033,7 @@
           </a:lstStyle>
           <a:p xmlns:a="http://schemas.openxmlformats.org/drawingml/2006/main">
             <a:pPr>
+              <a:buNone/>
               <a:defRPr sz="1275" b="0">
                 <a:solidFill>
                   <a:srgbClr val="606C70"/>
@@ -8685,6 +9102,7 @@
           </a:lstStyle>
           <a:p xmlns:a="http://schemas.openxmlformats.org/drawingml/2006/main">
             <a:pPr>
+              <a:buNone/>
               <a:defRPr sz="1200" b="0">
                 <a:solidFill>
                   <a:srgbClr val="606C70"/>
@@ -8703,7 +9121,7 @@
                 <a:ea typeface="Pretendard"/>
                 <a:cs typeface="Pretendard"/>
               </a:rPr>
-              <a:t>고잉 · Travel Agent  |  2026.10</a:t>
+              <a:t/>
             </a:r>
           </a:p>
         </p:txBody>
@@ -8753,6 +9171,7 @@
           </a:lstStyle>
           <a:p xmlns:a="http://schemas.openxmlformats.org/drawingml/2006/main">
             <a:pPr>
+              <a:buNone/>
               <a:defRPr sz="2925" b="1">
                 <a:solidFill>
                   <a:srgbClr val="25485A"/>
@@ -8821,6 +9240,7 @@
           </a:lstStyle>
           <a:p xmlns:a="http://schemas.openxmlformats.org/drawingml/2006/main">
             <a:pPr>
+              <a:buNone/>
               <a:defRPr sz="2175" b="0">
                 <a:solidFill>
                   <a:srgbClr val="252B2C"/>
@@ -8889,6 +9309,7 @@
           </a:lstStyle>
           <a:p xmlns:a="http://schemas.openxmlformats.org/drawingml/2006/main">
             <a:pPr>
+              <a:buNone/>
               <a:defRPr sz="2400" b="0">
                 <a:solidFill>
                   <a:srgbClr val="252B2C"/>
@@ -8957,6 +9378,7 @@
           </a:lstStyle>
           <a:p xmlns:a="http://schemas.openxmlformats.org/drawingml/2006/main">
             <a:pPr>
+              <a:buNone/>
               <a:defRPr sz="2400" b="1">
                 <a:solidFill>
                   <a:srgbClr val="87662A"/>
@@ -9025,6 +9447,7 @@
           </a:lstStyle>
           <a:p xmlns:a="http://schemas.openxmlformats.org/drawingml/2006/main">
             <a:pPr>
+              <a:buNone/>
               <a:defRPr sz="1875" b="0">
                 <a:solidFill>
                   <a:srgbClr val="606C70"/>
@@ -9122,6 +9545,7 @@
           </a:lstStyle>
           <a:p xmlns:a="http://schemas.openxmlformats.org/drawingml/2006/main">
             <a:pPr>
+              <a:buNone/>
               <a:defRPr sz="1350" b="0">
                 <a:solidFill>
                   <a:srgbClr val="606C70"/>
@@ -9190,6 +9614,7 @@
           </a:lstStyle>
           <a:p xmlns:a="http://schemas.openxmlformats.org/drawingml/2006/main">
             <a:pPr>
+              <a:buNone/>
               <a:defRPr sz="3450" b="1">
                 <a:solidFill>
                   <a:srgbClr val="252B2C"/>
@@ -9208,7 +9633,7 @@
                 <a:ea typeface="Pretendard"/>
                 <a:cs typeface="Pretendard"/>
               </a:rPr>
-              <a:t>예약을 지키면서 일정 편집하기</a:t>
+              <a:t>두 시간의 빈칸에 넣을 수 있을까?</a:t>
             </a:r>
           </a:p>
         </p:txBody>
@@ -9258,6 +9683,7 @@
           </a:lstStyle>
           <a:p xmlns:a="http://schemas.openxmlformats.org/drawingml/2006/main">
             <a:pPr>
+              <a:buNone/>
               <a:defRPr sz="1875" b="0">
                 <a:solidFill>
                   <a:srgbClr val="606C70"/>
@@ -9276,7 +9702,7 @@
                 <a:ea typeface="Pretendard"/>
                 <a:cs typeface="Pretendard"/>
               </a:rPr>
-              <a:t>바로 덮어쓰지 않고 변경 영향을 먼저 봅니다</a:t>
+              <a:t>체류시간과 양쪽 이동을 모두 계산합니다</a:t>
             </a:r>
           </a:p>
         </p:txBody>
@@ -9326,6 +9752,7 @@
           </a:lstStyle>
           <a:p xmlns:a="http://schemas.openxmlformats.org/drawingml/2006/main">
             <a:pPr>
+              <a:buNone/>
               <a:defRPr sz="1275" b="0">
                 <a:solidFill>
                   <a:srgbClr val="606C70"/>
@@ -9394,6 +9821,7 @@
           </a:lstStyle>
           <a:p xmlns:a="http://schemas.openxmlformats.org/drawingml/2006/main">
             <a:pPr>
+              <a:buNone/>
               <a:defRPr sz="1200" b="0">
                 <a:solidFill>
                   <a:srgbClr val="606C70"/>
@@ -9412,7 +9840,7 @@
                 <a:ea typeface="Pretendard"/>
                 <a:cs typeface="Pretendard"/>
               </a:rPr>
-              <a:t>고잉 · Travel Agent  |  2026.10</a:t>
+              <a:t/>
             </a:r>
           </a:p>
         </p:txBody>
@@ -9433,8 +9861,8 @@
         </p:nvSpPr>
         <p:spPr>
           <a:xfrm xmlns:a="http://schemas.openxmlformats.org/drawingml/2006/main">
-            <a:off x="609600" y="2314575"/>
-            <a:ext cx="10906125" cy="476250"/>
+            <a:off x="609600" y="2276475"/>
+            <a:ext cx="5238750" cy="619125"/>
           </a:xfrm>
           <a:prstGeom xmlns:a="http://schemas.openxmlformats.org/drawingml/2006/main" prst="rect">
             <a:avLst/>
@@ -9450,7 +9878,7 @@
           </a:bodyPr>
           <a:lstStyle xmlns:a="http://schemas.openxmlformats.org/drawingml/2006/main">
             <a:defPPr>
-              <a:defRPr sz="2400" b="1">
+              <a:defRPr sz="3000" b="1">
                 <a:solidFill>
                   <a:srgbClr val="25485A"/>
                 </a:solidFill>
@@ -9462,7 +9890,8 @@
           </a:lstStyle>
           <a:p xmlns:a="http://schemas.openxmlformats.org/drawingml/2006/main">
             <a:pPr>
-              <a:defRPr sz="2400" b="1">
+              <a:buNone/>
+              <a:defRPr sz="3000" b="1">
                 <a:solidFill>
                   <a:srgbClr val="25485A"/>
                 </a:solidFill>
@@ -9472,7 +9901,7 @@
               </a:defRPr>
             </a:pPr>
             <a:r>
-              <a:rPr sz="2400" b="1">
+              <a:rPr sz="3000" b="1">
                 <a:solidFill>
                   <a:srgbClr val="25485A"/>
                 </a:solidFill>
@@ -9480,7 +9909,7 @@
                 <a:ea typeface="Pretendard"/>
                 <a:cs typeface="Pretendard"/>
               </a:rPr>
-              <a:t>확정 예약을 먼저 보존</a:t>
+              <a:t>13:00 → 15:00</a:t>
             </a:r>
           </a:p>
         </p:txBody>
@@ -9501,8 +9930,8 @@
         </p:nvSpPr>
         <p:spPr>
           <a:xfrm xmlns:a="http://schemas.openxmlformats.org/drawingml/2006/main">
-            <a:off x="609600" y="2867025"/>
-            <a:ext cx="10906125" cy="428625"/>
+            <a:off x="609600" y="3000375"/>
+            <a:ext cx="5381625" cy="428625"/>
           </a:xfrm>
           <a:prstGeom xmlns:a="http://schemas.openxmlformats.org/drawingml/2006/main" prst="rect">
             <a:avLst/>
@@ -9520,7 +9949,7 @@
             <a:defPPr>
               <a:defRPr sz="1875" b="0">
                 <a:solidFill>
-                  <a:srgbClr val="252B2C"/>
+                  <a:srgbClr val="606C70"/>
                 </a:solidFill>
                 <a:latin typeface="Pretendard"/>
                 <a:ea typeface="Pretendard"/>
@@ -9530,9 +9959,10 @@
           </a:lstStyle>
           <a:p xmlns:a="http://schemas.openxmlformats.org/drawingml/2006/main">
             <a:pPr>
+              <a:buNone/>
               <a:defRPr sz="1875" b="0">
                 <a:solidFill>
-                  <a:srgbClr val="252B2C"/>
+                  <a:srgbClr val="606C70"/>
                 </a:solidFill>
                 <a:latin typeface="Pretendard"/>
                 <a:ea typeface="Pretendard"/>
@@ -9542,13 +9972,13 @@
             <a:r>
               <a:rPr sz="1875" b="0">
                 <a:solidFill>
-                  <a:srgbClr val="252B2C"/>
+                  <a:srgbClr val="606C70"/>
                 </a:solidFill>
                 <a:latin typeface="Pretendard"/>
                 <a:ea typeface="Pretendard"/>
                 <a:cs typeface="Pretendard"/>
               </a:rPr>
-              <a:t>이전 이동 + 체류 + 다음 이동 + 준비 버퍼를 함께 검사합니다.</a:t>
+              <a:t>점심 종료부터 다음 예약까지 120분</a:t>
             </a:r>
           </a:p>
         </p:txBody>
@@ -9558,7 +9988,7 @@
           <p:cNvPr id="8" name="">
             <a:extLst xmlns:a="http://schemas.openxmlformats.org/drawingml/2006/main">
               <a:ext uri="{FF2B5EF4-FFF2-40B4-BE49-F238E27FC236}">
-                <a16:creationId xmlns:a16="http://schemas.microsoft.com/office/drawing/2014/main" id="{B00B876C-5D7B-4F58-B72D-527F8161FF8E}"/>
+                <a16:creationId xmlns:a16="http://schemas.microsoft.com/office/drawing/2014/main" id="{C39391D7-6BC7-4DAE-ADA0-0E9782F426B3}"/>
               </a:ext>
             </a:extLst>
           </p:cNvPr>
@@ -9568,13 +9998,14 @@
           <p:nvPr/>
         </p:nvPicPr>
         <p:blipFill>
-          <a:blip xmlns:r="http://schemas.openxmlformats.org/officeDocument/2006/relationships" xmlns:a="http://schemas.openxmlformats.org/drawingml/2006/main" r:embed="R6cf7b62460ac41b0"/>
+          <a:blip xmlns:r="http://schemas.openxmlformats.org/officeDocument/2006/relationships" xmlns:a="http://schemas.openxmlformats.org/drawingml/2006/main" r:embed="Rdb7444ceadcb40c0"/>
+          <a:srcRect xmlns:a="http://schemas.openxmlformats.org/drawingml/2006/main" l="0" t="0" r="0" b="0"/>
           <a:stretch xmlns:a="http://schemas.openxmlformats.org/drawingml/2006/main"/>
         </p:blipFill>
         <p:spPr>
           <a:xfrm xmlns:a="http://schemas.openxmlformats.org/drawingml/2006/main">
-            <a:off x="5880486" y="3581400"/>
-            <a:ext cx="5203053" cy="2705100"/>
+            <a:off x="6391275" y="2647950"/>
+            <a:ext cx="5095875" cy="2695575"/>
           </a:xfrm>
           <a:prstGeom xmlns:a="http://schemas.openxmlformats.org/drawingml/2006/main" prst="rect">
             <a:avLst/>
@@ -9597,8 +10028,8 @@
         </p:nvSpPr>
         <p:spPr>
           <a:xfrm xmlns:a="http://schemas.openxmlformats.org/drawingml/2006/main">
-            <a:off x="609600" y="3686175"/>
-            <a:ext cx="4286250" cy="1619250"/>
+            <a:off x="609600" y="3762375"/>
+            <a:ext cx="5476875" cy="647700"/>
           </a:xfrm>
           <a:prstGeom xmlns:a="http://schemas.openxmlformats.org/drawingml/2006/main" prst="rect">
             <a:avLst/>
@@ -9614,7 +10045,7 @@
           </a:bodyPr>
           <a:lstStyle xmlns:a="http://schemas.openxmlformats.org/drawingml/2006/main">
             <a:defPPr>
-              <a:defRPr sz="2550" b="1">
+              <a:defRPr sz="2625" b="1">
                 <a:solidFill>
                   <a:srgbClr val="252B2C"/>
                 </a:solidFill>
@@ -9626,7 +10057,8 @@
           </a:lstStyle>
           <a:p xmlns:a="http://schemas.openxmlformats.org/drawingml/2006/main">
             <a:pPr>
-              <a:defRPr sz="2550" b="1">
+              <a:buNone/>
+              <a:defRPr sz="2625" b="1">
                 <a:solidFill>
                   <a:srgbClr val="252B2C"/>
                 </a:solidFill>
@@ -9636,7 +10068,7 @@
               </a:defRPr>
             </a:pPr>
             <a:r>
-              <a:rPr sz="2550" b="1">
+              <a:rPr sz="2625" b="1">
                 <a:solidFill>
                   <a:srgbClr val="252B2C"/>
                 </a:solidFill>
@@ -9644,53 +10076,7 @@
                 <a:ea typeface="Pretendard"/>
                 <a:cs typeface="Pretendard"/>
               </a:rPr>
-              <a:t>미리보기</a:t>
-            </a:r>
-          </a:p>
-          <a:p xmlns:a="http://schemas.openxmlformats.org/drawingml/2006/main">
-            <a:pPr>
-              <a:defRPr sz="2550" b="1">
-                <a:solidFill>
-                  <a:srgbClr val="252B2C"/>
-                </a:solidFill>
-                <a:latin typeface="Pretendard"/>
-                <a:ea typeface="Pretendard"/>
-                <a:cs typeface="Pretendard"/>
-              </a:defRPr>
-            </a:pPr>
-            <a:r>
-              <a:rPr sz="2550" b="1">
-                <a:solidFill>
-                  <a:srgbClr val="252B2C"/>
-                </a:solidFill>
-                <a:latin typeface="Pretendard"/>
-                <a:ea typeface="Pretendard"/>
-                <a:cs typeface="Pretendard"/>
-              </a:rPr>
-              <a:t>적용</a:t>
-            </a:r>
-          </a:p>
-          <a:p xmlns:a="http://schemas.openxmlformats.org/drawingml/2006/main">
-            <a:pPr>
-              <a:defRPr sz="2550" b="1">
-                <a:solidFill>
-                  <a:srgbClr val="252B2C"/>
-                </a:solidFill>
-                <a:latin typeface="Pretendard"/>
-                <a:ea typeface="Pretendard"/>
-                <a:cs typeface="Pretendard"/>
-              </a:defRPr>
-            </a:pPr>
-            <a:r>
-              <a:rPr sz="2550" b="1">
-                <a:solidFill>
-                  <a:srgbClr val="252B2C"/>
-                </a:solidFill>
-                <a:latin typeface="Pretendard"/>
-                <a:ea typeface="Pretendard"/>
-                <a:cs typeface="Pretendard"/>
-              </a:rPr>
-              <a:t>되돌리기</a:t>
+              <a:t>30 + 90 + 30 = 150분</a:t>
             </a:r>
           </a:p>
         </p:txBody>
@@ -9711,8 +10097,169 @@
         </p:nvSpPr>
         <p:spPr>
           <a:xfrm xmlns:a="http://schemas.openxmlformats.org/drawingml/2006/main">
-            <a:off x="609600" y="5534025"/>
-            <a:ext cx="4286250" cy="714375"/>
+            <a:off x="609600" y="4562475"/>
+            <a:ext cx="5476875" cy="857250"/>
+          </a:xfrm>
+          <a:prstGeom xmlns:a="http://schemas.openxmlformats.org/drawingml/2006/main" prst="rect">
+            <a:avLst/>
+          </a:prstGeom>
+          <a:noFill xmlns:a="http://schemas.openxmlformats.org/drawingml/2006/main"/>
+          <a:ln xmlns:a="http://schemas.openxmlformats.org/drawingml/2006/main" w="0">
+            <a:noFill/>
+          </a:ln>
+        </p:spPr>
+        <p:txBody>
+          <a:bodyPr xmlns:a="http://schemas.openxmlformats.org/drawingml/2006/main" wrap="square" lIns="0" tIns="0" rIns="0" bIns="0" anchor="t">
+            <a:noAutofit/>
+          </a:bodyPr>
+          <a:lstStyle xmlns:a="http://schemas.openxmlformats.org/drawingml/2006/main">
+            <a:defPPr>
+              <a:defRPr sz="1875" b="0">
+                <a:solidFill>
+                  <a:srgbClr val="252B2C"/>
+                </a:solidFill>
+                <a:latin typeface="Pretendard"/>
+                <a:ea typeface="Pretendard"/>
+                <a:cs typeface="Pretendard"/>
+              </a:defRPr>
+            </a:defPPr>
+          </a:lstStyle>
+          <a:p xmlns:a="http://schemas.openxmlformats.org/drawingml/2006/main">
+            <a:pPr>
+              <a:buNone/>
+              <a:defRPr sz="1875" b="0">
+                <a:solidFill>
+                  <a:srgbClr val="252B2C"/>
+                </a:solidFill>
+                <a:latin typeface="Pretendard"/>
+                <a:ea typeface="Pretendard"/>
+                <a:cs typeface="Pretendard"/>
+              </a:defRPr>
+            </a:pPr>
+            <a:r>
+              <a:rPr sz="1875" b="0">
+                <a:solidFill>
+                  <a:srgbClr val="252B2C"/>
+                </a:solidFill>
+                <a:latin typeface="Pretendard"/>
+                <a:ea typeface="Pretendard"/>
+                <a:cs typeface="Pretendard"/>
+              </a:rPr>
+              <a:t>이동 + 체류 + 이동 → 30분 부족</a:t>
+            </a:r>
+          </a:p>
+          <a:p xmlns:a="http://schemas.openxmlformats.org/drawingml/2006/main">
+            <a:pPr>
+              <a:buNone/>
+              <a:defRPr sz="1875" b="0">
+                <a:solidFill>
+                  <a:srgbClr val="252B2C"/>
+                </a:solidFill>
+                <a:latin typeface="Pretendard"/>
+                <a:ea typeface="Pretendard"/>
+                <a:cs typeface="Pretendard"/>
+              </a:defRPr>
+            </a:pPr>
+            <a:r>
+              <a:rPr sz="1875" b="0">
+                <a:solidFill>
+                  <a:srgbClr val="252B2C"/>
+                </a:solidFill>
+                <a:latin typeface="Pretendard"/>
+                <a:ea typeface="Pretendard"/>
+                <a:cs typeface="Pretendard"/>
+              </a:rPr>
+              <a:t>확정 예약을 옮겨서 끼워 넣지 않습니다</a:t>
+            </a:r>
+          </a:p>
+        </p:txBody>
+      </p:sp>
+      <p:sp>
+        <p:nvSpPr>
+          <p:cNvPr id="12" name="">
+            <a:extLst xmlns:a="http://schemas.openxmlformats.org/drawingml/2006/main">
+              <a:ext uri="{FF2B5EF4-FFF2-40B4-BE49-F238E27FC236}">
+                <a16:creationId xmlns:a16="http://schemas.microsoft.com/office/drawing/2014/main" id="{2CE87796-D301-44ED-92AF-E3EE75E5645B}"/>
+              </a:ext>
+            </a:extLst>
+          </p:cNvPr>
+          <p:cNvSpPr>
+            <a:spLocks xmlns:a="http://schemas.openxmlformats.org/drawingml/2006/main" noGrp="1"/>
+          </p:cNvSpPr>
+          <p:nvPr/>
+        </p:nvSpPr>
+        <p:spPr>
+          <a:xfrm xmlns:a="http://schemas.openxmlformats.org/drawingml/2006/main">
+            <a:off x="609600" y="5591175"/>
+            <a:ext cx="4953000" cy="295275"/>
+          </a:xfrm>
+          <a:prstGeom xmlns:a="http://schemas.openxmlformats.org/drawingml/2006/main" prst="rect">
+            <a:avLst/>
+          </a:prstGeom>
+          <a:noFill xmlns:a="http://schemas.openxmlformats.org/drawingml/2006/main"/>
+          <a:ln xmlns:a="http://schemas.openxmlformats.org/drawingml/2006/main" w="0">
+            <a:noFill/>
+          </a:ln>
+        </p:spPr>
+        <p:txBody>
+          <a:bodyPr xmlns:a="http://schemas.openxmlformats.org/drawingml/2006/main" wrap="square" lIns="0" tIns="0" rIns="0" bIns="0" anchor="t">
+            <a:noAutofit/>
+          </a:bodyPr>
+          <a:lstStyle xmlns:a="http://schemas.openxmlformats.org/drawingml/2006/main">
+            <a:defPPr>
+              <a:defRPr sz="1425" b="0">
+                <a:solidFill>
+                  <a:srgbClr val="606C70"/>
+                </a:solidFill>
+                <a:latin typeface="Pretendard"/>
+                <a:ea typeface="Pretendard"/>
+                <a:cs typeface="Pretendard"/>
+              </a:defRPr>
+            </a:defPPr>
+          </a:lstStyle>
+          <a:p xmlns:a="http://schemas.openxmlformats.org/drawingml/2006/main">
+            <a:pPr>
+              <a:defRPr sz="1425" b="0">
+                <a:solidFill>
+                  <a:srgbClr val="606C70"/>
+                </a:solidFill>
+                <a:latin typeface="Pretendard"/>
+                <a:ea typeface="Pretendard"/>
+                <a:cs typeface="Pretendard"/>
+              </a:defRPr>
+            </a:pPr>
+            <a:r>
+              <a:rPr sz="1425" b="0">
+                <a:solidFill>
+                  <a:srgbClr val="606C70"/>
+                </a:solidFill>
+                <a:latin typeface="Pretendard"/>
+                <a:ea typeface="Pretendard"/>
+                <a:cs typeface="Pretendard"/>
+              </a:rPr>
+              <a:t>합성 계산 예시</a:t>
+            </a:r>
+          </a:p>
+        </p:txBody>
+      </p:sp>
+      <p:sp>
+        <p:nvSpPr>
+          <p:cNvPr id="13" name="">
+            <a:extLst xmlns:a="http://schemas.openxmlformats.org/drawingml/2006/main">
+              <a:ext uri="{FF2B5EF4-FFF2-40B4-BE49-F238E27FC236}">
+                <a16:creationId xmlns:a16="http://schemas.microsoft.com/office/drawing/2014/main" id="{E568EEA8-603E-4F64-8975-C62BFDB9382F}"/>
+              </a:ext>
+            </a:extLst>
+          </p:cNvPr>
+          <p:cNvSpPr>
+            <a:spLocks xmlns:a="http://schemas.openxmlformats.org/drawingml/2006/main" noGrp="1"/>
+          </p:cNvSpPr>
+          <p:nvPr/>
+        </p:nvSpPr>
+        <p:spPr>
+          <a:xfrm xmlns:a="http://schemas.openxmlformats.org/drawingml/2006/main">
+            <a:off x="6515100" y="2276475"/>
+            <a:ext cx="5000625" cy="361950"/>
           </a:xfrm>
           <a:prstGeom xmlns:a="http://schemas.openxmlformats.org/drawingml/2006/main" prst="rect">
             <a:avLst/>
@@ -9758,14 +10305,59 @@
                 <a:ea typeface="Pretendard"/>
                 <a:cs typeface="Pretendard"/>
               </a:rPr>
-              <a:t>화면: 이동·준비 시간 충돌을</a:t>
-            </a:r>
-          </a:p>
+              <a:t>앱 화면: 고정 예약과 충돌 표시</a:t>
+            </a:r>
+          </a:p>
+        </p:txBody>
+      </p:sp>
+      <p:sp>
+        <p:nvSpPr>
+          <p:cNvPr id="14" name="">
+            <a:extLst xmlns:a="http://schemas.openxmlformats.org/drawingml/2006/main">
+              <a:ext uri="{FF2B5EF4-FFF2-40B4-BE49-F238E27FC236}">
+                <a16:creationId xmlns:a16="http://schemas.microsoft.com/office/drawing/2014/main" id="{F09F7083-BEB3-4ED7-A409-9A6F93090A1A}"/>
+              </a:ext>
+            </a:extLst>
+          </p:cNvPr>
+          <p:cNvSpPr>
+            <a:spLocks xmlns:a="http://schemas.openxmlformats.org/drawingml/2006/main" noGrp="1"/>
+          </p:cNvSpPr>
+          <p:nvPr/>
+        </p:nvSpPr>
+        <p:spPr>
+          <a:xfrm xmlns:a="http://schemas.openxmlformats.org/drawingml/2006/main">
+            <a:off x="6486525" y="5600700"/>
+            <a:ext cx="5048250" cy="428625"/>
+          </a:xfrm>
+          <a:prstGeom xmlns:a="http://schemas.openxmlformats.org/drawingml/2006/main" prst="rect">
+            <a:avLst/>
+          </a:prstGeom>
+          <a:noFill xmlns:a="http://schemas.openxmlformats.org/drawingml/2006/main"/>
+          <a:ln xmlns:a="http://schemas.openxmlformats.org/drawingml/2006/main" w="0">
+            <a:noFill/>
+          </a:ln>
+        </p:spPr>
+        <p:txBody>
+          <a:bodyPr xmlns:a="http://schemas.openxmlformats.org/drawingml/2006/main" wrap="square" lIns="0" tIns="0" rIns="0" bIns="0" anchor="t">
+            <a:noAutofit/>
+          </a:bodyPr>
+          <a:lstStyle xmlns:a="http://schemas.openxmlformats.org/drawingml/2006/main">
+            <a:defPPr>
+              <a:defRPr sz="2025" b="1">
+                <a:solidFill>
+                  <a:srgbClr val="25485A"/>
+                </a:solidFill>
+                <a:latin typeface="Pretendard"/>
+                <a:ea typeface="Pretendard"/>
+                <a:cs typeface="Pretendard"/>
+              </a:defRPr>
+            </a:defPPr>
+          </a:lstStyle>
           <a:p xmlns:a="http://schemas.openxmlformats.org/drawingml/2006/main">
             <a:pPr>
-              <a:defRPr sz="1725" b="0">
-                <a:solidFill>
-                  <a:srgbClr val="606C70"/>
+              <a:defRPr sz="2025" b="1">
+                <a:solidFill>
+                  <a:srgbClr val="25485A"/>
                 </a:solidFill>
                 <a:latin typeface="Pretendard"/>
                 <a:ea typeface="Pretendard"/>
@@ -9773,15 +10365,15 @@
               </a:defRPr>
             </a:pPr>
             <a:r>
-              <a:rPr sz="1725" b="0">
-                <a:solidFill>
-                  <a:srgbClr val="606C70"/>
+              <a:rPr sz="2025" b="1">
+                <a:solidFill>
+                  <a:srgbClr val="25485A"/>
                 </a:solidFill>
                 <a:latin typeface="Pretendard"/>
                 <a:ea typeface="Pretendard"/>
                 <a:cs typeface="Pretendard"/>
               </a:rPr>
-              <a:t>숨기지 않은 예시 일정</a:t>
+              <a:t>미리보기 → 적용 → 되돌리기</a:t>
             </a:r>
           </a:p>
         </p:txBody>
@@ -9860,6 +10452,7 @@
           </a:lstStyle>
           <a:p xmlns:a="http://schemas.openxmlformats.org/drawingml/2006/main">
             <a:pPr>
+              <a:buNone/>
               <a:defRPr sz="1350" b="0">
                 <a:solidFill>
                   <a:srgbClr val="606C70"/>
@@ -9928,6 +10521,7 @@
           </a:lstStyle>
           <a:p xmlns:a="http://schemas.openxmlformats.org/drawingml/2006/main">
             <a:pPr>
+              <a:buNone/>
               <a:defRPr sz="3450" b="1">
                 <a:solidFill>
                   <a:srgbClr val="252B2C"/>
@@ -9946,7 +10540,7 @@
                 <a:ea typeface="Pretendard"/>
                 <a:cs typeface="Pretendard"/>
               </a:rPr>
-              <a:t>계속 쓸 수 있게 고친 부분</a:t>
+              <a:t>실패해도 다시 이어서 쓸 수 있게</a:t>
             </a:r>
           </a:p>
         </p:txBody>
@@ -9996,6 +10590,7 @@
           </a:lstStyle>
           <a:p xmlns:a="http://schemas.openxmlformats.org/drawingml/2006/main">
             <a:pPr>
+              <a:buNone/>
               <a:defRPr sz="1875" b="0">
                 <a:solidFill>
                   <a:srgbClr val="606C70"/>
@@ -10014,7 +10609,7 @@
                 <a:ea typeface="Pretendard"/>
                 <a:cs typeface="Pretendard"/>
               </a:rPr>
-              <a:t>새로고침, 재시작, 외부 검색 실패에 대응합니다</a:t>
+              <a:t>새로고침 · 서버 재시작 · 지도 검색 장애</a:t>
             </a:r>
           </a:p>
         </p:txBody>
@@ -10064,6 +10659,7 @@
           </a:lstStyle>
           <a:p xmlns:a="http://schemas.openxmlformats.org/drawingml/2006/main">
             <a:pPr>
+              <a:buNone/>
               <a:defRPr sz="1275" b="0">
                 <a:solidFill>
                   <a:srgbClr val="606C70"/>
@@ -10132,6 +10728,7 @@
           </a:lstStyle>
           <a:p xmlns:a="http://schemas.openxmlformats.org/drawingml/2006/main">
             <a:pPr>
+              <a:buNone/>
               <a:defRPr sz="1200" b="0">
                 <a:solidFill>
                   <a:srgbClr val="606C70"/>
@@ -10150,7 +10747,7 @@
                 <a:ea typeface="Pretendard"/>
                 <a:cs typeface="Pretendard"/>
               </a:rPr>
-              <a:t>고잉 · Travel Agent  |  2026.10</a:t>
+              <a:t/>
             </a:r>
           </a:p>
         </p:txBody>
@@ -10200,6 +10797,7 @@
           </a:lstStyle>
           <a:p xmlns:a="http://schemas.openxmlformats.org/drawingml/2006/main">
             <a:pPr>
+              <a:buNone/>
               <a:defRPr sz="2325" b="1">
                 <a:solidFill>
                   <a:srgbClr val="25485A"/>
@@ -10218,7 +10816,7 @@
                 <a:ea typeface="Pretendard"/>
                 <a:cs typeface="Pretendard"/>
               </a:rPr>
-              <a:t>FastAPI + 단일 dispatcher</a:t>
+              <a:t>새로고침해도 작업을 찾습니다</a:t>
             </a:r>
           </a:p>
         </p:txBody>
@@ -10268,6 +10866,7 @@
           </a:lstStyle>
           <a:p xmlns:a="http://schemas.openxmlformats.org/drawingml/2006/main">
             <a:pPr>
+              <a:buNone/>
               <a:defRPr sz="1950" b="0">
                 <a:solidFill>
                   <a:srgbClr val="252B2C"/>
@@ -10286,7 +10885,7 @@
                 <a:ea typeface="Pretendard"/>
                 <a:cs typeface="Pretendard"/>
               </a:rPr>
-              <a:t>작업 상태·재시도·예산을 DB에 기록</a:t>
+              <a:t>작업 번호·진행 상태를 DB에 저장하고 다시 조회</a:t>
             </a:r>
           </a:p>
         </p:txBody>
@@ -10336,6 +10935,7 @@
           </a:lstStyle>
           <a:p xmlns:a="http://schemas.openxmlformats.org/drawingml/2006/main">
             <a:pPr>
+              <a:buNone/>
               <a:defRPr sz="2325" b="1">
                 <a:solidFill>
                   <a:srgbClr val="25485A"/>
@@ -10354,7 +10954,7 @@
                 <a:ea typeface="Pretendard"/>
                 <a:cs typeface="Pretendard"/>
               </a:rPr>
-              <a:t>Render Free + Supabase</a:t>
+              <a:t>서버가 재시작돼도 자료를 보관합니다</a:t>
             </a:r>
           </a:p>
         </p:txBody>
@@ -10404,6 +11004,7 @@
           </a:lstStyle>
           <a:p xmlns:a="http://schemas.openxmlformats.org/drawingml/2006/main">
             <a:pPr>
+              <a:buNone/>
               <a:defRPr sz="1950" b="0">
                 <a:solidFill>
                   <a:srgbClr val="252B2C"/>
@@ -10422,7 +11023,7 @@
                 <a:ea typeface="Pretendard"/>
                 <a:cs typeface="Pretendard"/>
               </a:rPr>
-              <a:t>SQL · 비공개 원문 · pgvector 보관</a:t>
+              <a:t>Render Free + Supabase SQL · 비공개 파일 · 검색</a:t>
             </a:r>
           </a:p>
         </p:txBody>
@@ -10472,6 +11073,7 @@
           </a:lstStyle>
           <a:p xmlns:a="http://schemas.openxmlformats.org/drawingml/2006/main">
             <a:pPr>
+              <a:buNone/>
               <a:defRPr sz="2325" b="1">
                 <a:solidFill>
                   <a:srgbClr val="25485A"/>
@@ -10490,7 +11092,7 @@
                 <a:ea typeface="Pretendard"/>
                 <a:cs typeface="Pretendard"/>
               </a:rPr>
-              <a:t>Photon 공개지도 검색</a:t>
+              <a:t>지도 실패는 실제 오류부터 확인했습니다</a:t>
             </a:r>
           </a:p>
         </p:txBody>
@@ -10540,6 +11142,7 @@
           </a:lstStyle>
           <a:p xmlns:a="http://schemas.openxmlformats.org/drawingml/2006/main">
             <a:pPr>
+              <a:buNone/>
               <a:defRPr sz="1950" b="0">
                 <a:solidFill>
                   <a:srgbClr val="252B2C"/>
@@ -10558,7 +11161,7 @@
                 <a:ea typeface="Pretendard"/>
                 <a:cs typeface="Pretendard"/>
               </a:rPr>
-              <a:t>런던 지점 50곳 · 음식점 후보 12곳</a:t>
+              <a:t>연결 거절 확인 → Photon 적용 → 런던 후보 12곳</a:t>
             </a:r>
           </a:p>
         </p:txBody>
@@ -10608,6 +11211,7 @@
           </a:lstStyle>
           <a:p xmlns:a="http://schemas.openxmlformats.org/drawingml/2006/main">
             <a:pPr>
+              <a:buNone/>
               <a:defRPr sz="1725" b="0">
                 <a:solidFill>
                   <a:srgbClr val="606C70"/>
@@ -10626,7 +11230,7 @@
                 <a:ea typeface="Pretendard"/>
                 <a:cs typeface="Pretendard"/>
               </a:rPr>
-              <a:t>캐시 재조회 시 추가 지도 호출 0회. 후보 수는 방문 적합성 검증 수와 다릅니다.</a:t>
+              <a:t>재조회 추가 지도 호출 0회 · 방문 조건까지 검증한 추천 수와는 다릅니다.</a:t>
             </a:r>
           </a:p>
         </p:txBody>

</xml_diff>

<commit_message>
Polish review choices, add timed sample mail and keep presentation scripts private
</commit_message>
<xml_diff>
--- a/docs/presentation/going-class-presentation.pptx
+++ b/docs/presentation/going-class-presentation.pptx
@@ -412,1198 +412,1198 @@
 </file>
 
 <file path=ppt/notesSlides/notesSlide1.xml><?xml version="1.0" encoding="utf-8"?>
-<p:notes xmlns:p="http://schemas.openxmlformats.org/presentationml/2006/main">
-  <p:cSld>
-    <p:spTree>
-      <p:nvGrpSpPr>
-        <p:cNvPr id="1" name=""/>
-        <p:cNvGrpSpPr/>
-        <p:nvPr/>
-      </p:nvGrpSpPr>
-      <p:grpSpPr>
-        <a:xfrm xmlns:a="http://schemas.openxmlformats.org/drawingml/2006/main"/>
-      </p:grpSpPr>
-      <p:sp>
-        <p:nvSpPr>
-          <p:cNvPr id="2" name="Slide Image Placeholder 1"/>
-          <p:cNvSpPr>
-            <a:spLocks xmlns:a="http://schemas.openxmlformats.org/drawingml/2006/main" noGrp="1"/>
-          </p:cNvSpPr>
-          <p:nvPr>
-            <p:ph type="sldImg" idx="0"/>
-          </p:nvPr>
-        </p:nvSpPr>
-        <p:spPr/>
-      </p:sp>
-      <p:sp>
-        <p:nvSpPr>
-          <p:cNvPr id="3" name="Notes Placeholder 2"/>
-          <p:cNvSpPr>
-            <a:spLocks xmlns:a="http://schemas.openxmlformats.org/drawingml/2006/main" noGrp="1"/>
-          </p:cNvSpPr>
-          <p:nvPr>
-            <p:ph type="body" idx="1"/>
-          </p:nvPr>
-        </p:nvSpPr>
-        <p:spPr/>
-        <p:txBody>
-          <a:bodyPr xmlns:a="http://schemas.openxmlformats.org/drawingml/2006/main"/>
-          <a:lstStyle xmlns:a="http://schemas.openxmlformats.org/drawingml/2006/main"/>
-          <a:p xmlns:a="http://schemas.openxmlformats.org/drawingml/2006/main">
-            <a:r>
-              <a:t>[목표 30초 / 행동: 표지를 보며 서비스 이름을 또렷하게 말합니다.]</a:t>
-            </a:r>
-          </a:p>
-          <a:p xmlns:a="http://schemas.openxmlformats.org/drawingml/2006/main">
-            <a:r>
-              <a:t/>
-            </a:r>
-          </a:p>
-          <a:p xmlns:a="http://schemas.openxmlformats.org/drawingml/2006/main">
-            <a:r>
-              <a:t>안녕하세요. 제가 만든 여행 준비 서비스, 고잉을 소개하겠습니다.</a:t>
-            </a:r>
-          </a:p>
-          <a:p xmlns:a="http://schemas.openxmlformats.org/drawingml/2006/main">
-            <a:r>
-              <a:t/>
-            </a:r>
-          </a:p>
-          <a:p xmlns:a="http://schemas.openxmlformats.org/drawingml/2006/main">
-            <a:r>
-              <a:t>여행을 예약하고 나서도 메일함과 지도, 메모를 계속 오가게 되는데요. 그 과정을 한곳에서 이어서 할 수 있으면 좋겠다는 생각으로 만들었습니다. 예약 정리부터 장소 선택, 일정 편집까지 실제 화면과 함께 보여드리겠습니다.</a:t>
-            </a:r>
-          </a:p>
-          <a:p xmlns:a="http://schemas.openxmlformats.org/drawingml/2006/main">
-            <a:r>
-              <a:t/>
-            </a:r>
-          </a:p>
-          <a:p xmlns:a="http://schemas.openxmlformats.org/drawingml/2006/main">
-            <a:r>
-              <a:t>[근거·검증 범위 / 낭독하지 않음]</a:t>
-            </a:r>
-          </a:p>
-          <a:p xmlns:a="http://schemas.openxmlformats.org/drawingml/2006/main">
-            <a:r>
-              <a:t>https://github.com/Jin-s-work/Travel-Agent/blob/main/README.md</a:t>
-            </a:r>
-          </a:p>
-        </p:txBody>
-      </p:sp>
-      <p:sp>
-        <p:nvSpPr>
-          <p:cNvPr id="4" name="Slide Number Placeholder 3"/>
-          <p:cNvSpPr>
-            <a:spLocks xmlns:a="http://schemas.openxmlformats.org/drawingml/2006/main" noGrp="1"/>
-          </p:cNvSpPr>
-          <p:nvPr>
-            <p:ph type="sldNum" idx="5"/>
-          </p:nvPr>
-        </p:nvSpPr>
-        <p:spPr/>
-        <p:txBody>
-          <a:bodyPr xmlns:a="http://schemas.openxmlformats.org/drawingml/2006/main"/>
-          <a:lstStyle xmlns:a="http://schemas.openxmlformats.org/drawingml/2006/main"/>
-          <a:p xmlns:a="http://schemas.openxmlformats.org/drawingml/2006/main"/>
-        </p:txBody>
-      </p:sp>
-    </p:spTree>
-  </p:cSld>
-  <p:clrMapOvr>
-    <a:masterClrMapping xmlns:a="http://schemas.openxmlformats.org/drawingml/2006/main"/>
-  </p:clrMapOvr>
-</p:notes>
+<ns0:notes xmlns:ns0="http://schemas.openxmlformats.org/presentationml/2006/main" xmlns:ns1="http://schemas.openxmlformats.org/drawingml/2006/main">
+  <ns0:cSld>
+    <ns0:spTree>
+      <ns0:nvGrpSpPr>
+        <ns0:cNvPr id="1" name=""/>
+        <ns0:cNvGrpSpPr/>
+        <ns0:nvPr/>
+      </ns0:nvGrpSpPr>
+      <ns0:grpSpPr>
+        <ns1:xfrm/>
+      </ns0:grpSpPr>
+      <ns0:sp>
+        <ns0:nvSpPr>
+          <ns0:cNvPr id="2" name="Slide Image Placeholder 1"/>
+          <ns0:cNvSpPr>
+            <ns1:spLocks noGrp="1"/>
+          </ns0:cNvSpPr>
+          <ns0:nvPr>
+            <ns0:ph type="sldImg" idx="0"/>
+          </ns0:nvPr>
+        </ns0:nvSpPr>
+        <ns0:spPr/>
+      </ns0:sp>
+      <ns0:sp>
+        <ns0:nvSpPr>
+          <ns0:cNvPr id="3" name="Notes Placeholder 2"/>
+          <ns0:cNvSpPr>
+            <ns1:spLocks noGrp="1"/>
+          </ns0:cNvSpPr>
+          <ns0:nvPr>
+            <ns0:ph type="body" idx="1"/>
+          </ns0:nvPr>
+        </ns0:nvSpPr>
+        <ns0:spPr/>
+        <ns0:txBody>
+          <ns1:bodyPr/>
+          <ns1:lstStyle/>
+          <ns1:p>
+            <ns1:r>
+              <ns1:t/>
+            </ns1:r>
+          </ns1:p>
+          <ns1:p>
+            <ns1:r>
+              <ns1:t/>
+            </ns1:r>
+          </ns1:p>
+          <ns1:p>
+            <ns1:r>
+              <ns1:t/>
+            </ns1:r>
+          </ns1:p>
+          <ns1:p>
+            <ns1:r>
+              <ns1:t/>
+            </ns1:r>
+          </ns1:p>
+          <ns1:p>
+            <ns1:r>
+              <ns1:t/>
+            </ns1:r>
+          </ns1:p>
+          <ns1:p>
+            <ns1:r>
+              <ns1:t/>
+            </ns1:r>
+          </ns1:p>
+          <ns1:p>
+            <ns1:r>
+              <ns1:t/>
+            </ns1:r>
+          </ns1:p>
+          <ns1:p>
+            <ns1:r>
+              <ns1:t/>
+            </ns1:r>
+          </ns1:p>
+        </ns0:txBody>
+      </ns0:sp>
+      <ns0:sp>
+        <ns0:nvSpPr>
+          <ns0:cNvPr id="4" name="Slide Number Placeholder 3"/>
+          <ns0:cNvSpPr>
+            <ns1:spLocks noGrp="1"/>
+          </ns0:cNvSpPr>
+          <ns0:nvPr>
+            <ns0:ph type="sldNum" idx="5"/>
+          </ns0:nvPr>
+        </ns0:nvSpPr>
+        <ns0:spPr/>
+        <ns0:txBody>
+          <ns1:bodyPr/>
+          <ns1:lstStyle/>
+          <ns1:p/>
+        </ns0:txBody>
+      </ns0:sp>
+    </ns0:spTree>
+  </ns0:cSld>
+  <ns0:clrMapOvr>
+    <ns1:masterClrMapping/>
+  </ns0:clrMapOvr>
+</ns0:notes>
 </file>
 
 <file path=ppt/notesSlides/notesSlide10.xml><?xml version="1.0" encoding="utf-8"?>
-<p:notes xmlns:p="http://schemas.openxmlformats.org/presentationml/2006/main">
-  <p:cSld>
-    <p:spTree>
-      <p:nvGrpSpPr>
-        <p:cNvPr id="1" name=""/>
-        <p:cNvGrpSpPr/>
-        <p:nvPr/>
-      </p:nvGrpSpPr>
-      <p:grpSpPr>
-        <a:xfrm xmlns:a="http://schemas.openxmlformats.org/drawingml/2006/main"/>
-      </p:grpSpPr>
-      <p:sp>
-        <p:nvSpPr>
-          <p:cNvPr id="2" name="Slide Image Placeholder 1"/>
-          <p:cNvSpPr>
-            <a:spLocks xmlns:a="http://schemas.openxmlformats.org/drawingml/2006/main" noGrp="1"/>
-          </p:cNvSpPr>
-          <p:nvPr>
-            <p:ph type="sldImg" idx="0"/>
-          </p:nvPr>
-        </p:nvSpPr>
-        <p:spPr/>
-      </p:sp>
-      <p:sp>
-        <p:nvSpPr>
-          <p:cNvPr id="3" name="Notes Placeholder 2"/>
-          <p:cNvSpPr>
-            <a:spLocks xmlns:a="http://schemas.openxmlformats.org/drawingml/2006/main" noGrp="1"/>
-          </p:cNvSpPr>
-          <p:nvPr>
-            <p:ph type="body" idx="1"/>
-          </p:nvPr>
-        </p:nvSpPr>
-        <p:spPr/>
-        <p:txBody>
-          <a:bodyPr xmlns:a="http://schemas.openxmlformats.org/drawingml/2006/main"/>
-          <a:lstStyle xmlns:a="http://schemas.openxmlformats.org/drawingml/2006/main"/>
-          <a:p xmlns:a="http://schemas.openxmlformats.org/drawingml/2006/main">
-            <a:r>
-              <a:t>[목표 50초 / 행동: 마지막 문장을 천천히 말하고 마칩니다.]</a:t>
-            </a:r>
-          </a:p>
-          <a:p xmlns:a="http://schemas.openxmlformats.org/drawingml/2006/main">
-            <a:r>
-              <a:t/>
-            </a:r>
-          </a:p>
-          <a:p xmlns:a="http://schemas.openxmlformats.org/drawingml/2006/main">
-            <a:r>
-              <a:t>현재는 초대한 소수 사용자가 접속하는 비공개 베타입니다. 예약을 정리하고, 장소를 살펴보고, 일정에 연결하는 흐름까지 만들었습니다.</a:t>
-            </a:r>
-          </a:p>
-          <a:p xmlns:a="http://schemas.openxmlformats.org/drawingml/2006/main">
-            <a:r>
-              <a:t/>
-            </a:r>
-          </a:p>
-          <a:p xmlns:a="http://schemas.openxmlformats.org/drawingml/2006/main">
-            <a:r>
-              <a:t>이번에 배운 점은 AI 답변을 만드는 것만큼, 그 답변의 근거와 실패했을 때의 처리가 중요하다는 것입니다. 자동 시험은 통과했지만 실제 사용자 만족도는 아직 측정하지 않았습니다. 백 개 도시를 선택할 수 있다는 것도 모든 도시의 추천 품질을 검증했다는 뜻은 아닙니다.</a:t>
-            </a:r>
-          </a:p>
-          <a:p xmlns:a="http://schemas.openxmlformats.org/drawingml/2006/main">
-            <a:r>
-              <a:t/>
-            </a:r>
-          </a:p>
-          <a:p xmlns:a="http://schemas.openxmlformats.org/drawingml/2006/main">
-            <a:r>
-              <a:t>다음에는 검색 대기 시간을 줄이고, 친구들이 사용하다 멈추는 부분을 먼저 확인하려고 합니다. 기능을 더 넣기 전에 지금 있는 흐름을 편하게 만드는 것이 다음 목표입니다. 감사합니다.</a:t>
-            </a:r>
-          </a:p>
-          <a:p xmlns:a="http://schemas.openxmlformats.org/drawingml/2006/main">
-            <a:r>
-              <a:t/>
-            </a:r>
-          </a:p>
-          <a:p xmlns:a="http://schemas.openxmlformats.org/drawingml/2006/main">
-            <a:r>
-              <a:t>[근거·검증 범위 / 낭독하지 않음]</a:t>
-            </a:r>
-          </a:p>
-          <a:p xmlns:a="http://schemas.openxmlformats.org/drawingml/2006/main">
-            <a:r>
-              <a:t>https://github.com/Jin-s-work/Travel-Agent/blob/main/docs/service-v3/reports/going-design-search-validation.md</a:t>
-            </a:r>
-          </a:p>
-        </p:txBody>
-      </p:sp>
-      <p:sp>
-        <p:nvSpPr>
-          <p:cNvPr id="4" name="Slide Number Placeholder 3"/>
-          <p:cNvSpPr>
-            <a:spLocks xmlns:a="http://schemas.openxmlformats.org/drawingml/2006/main" noGrp="1"/>
-          </p:cNvSpPr>
-          <p:nvPr>
-            <p:ph type="sldNum" idx="5"/>
-          </p:nvPr>
-        </p:nvSpPr>
-        <p:spPr/>
-        <p:txBody>
-          <a:bodyPr xmlns:a="http://schemas.openxmlformats.org/drawingml/2006/main"/>
-          <a:lstStyle xmlns:a="http://schemas.openxmlformats.org/drawingml/2006/main"/>
-          <a:p xmlns:a="http://schemas.openxmlformats.org/drawingml/2006/main"/>
-        </p:txBody>
-      </p:sp>
-    </p:spTree>
-  </p:cSld>
-  <p:clrMapOvr>
-    <a:masterClrMapping xmlns:a="http://schemas.openxmlformats.org/drawingml/2006/main"/>
-  </p:clrMapOvr>
-</p:notes>
+<ns0:notes xmlns:ns0="http://schemas.openxmlformats.org/presentationml/2006/main" xmlns:ns1="http://schemas.openxmlformats.org/drawingml/2006/main">
+  <ns0:cSld>
+    <ns0:spTree>
+      <ns0:nvGrpSpPr>
+        <ns0:cNvPr id="1" name=""/>
+        <ns0:cNvGrpSpPr/>
+        <ns0:nvPr/>
+      </ns0:nvGrpSpPr>
+      <ns0:grpSpPr>
+        <ns1:xfrm/>
+      </ns0:grpSpPr>
+      <ns0:sp>
+        <ns0:nvSpPr>
+          <ns0:cNvPr id="2" name="Slide Image Placeholder 1"/>
+          <ns0:cNvSpPr>
+            <ns1:spLocks noGrp="1"/>
+          </ns0:cNvSpPr>
+          <ns0:nvPr>
+            <ns0:ph type="sldImg" idx="0"/>
+          </ns0:nvPr>
+        </ns0:nvSpPr>
+        <ns0:spPr/>
+      </ns0:sp>
+      <ns0:sp>
+        <ns0:nvSpPr>
+          <ns0:cNvPr id="3" name="Notes Placeholder 2"/>
+          <ns0:cNvSpPr>
+            <ns1:spLocks noGrp="1"/>
+          </ns0:cNvSpPr>
+          <ns0:nvPr>
+            <ns0:ph type="body" idx="1"/>
+          </ns0:nvPr>
+        </ns0:nvSpPr>
+        <ns0:spPr/>
+        <ns0:txBody>
+          <ns1:bodyPr/>
+          <ns1:lstStyle/>
+          <ns1:p>
+            <ns1:r>
+              <ns1:t/>
+            </ns1:r>
+          </ns1:p>
+          <ns1:p>
+            <ns1:r>
+              <ns1:t/>
+            </ns1:r>
+          </ns1:p>
+          <ns1:p>
+            <ns1:r>
+              <ns1:t/>
+            </ns1:r>
+          </ns1:p>
+          <ns1:p>
+            <ns1:r>
+              <ns1:t/>
+            </ns1:r>
+          </ns1:p>
+          <ns1:p>
+            <ns1:r>
+              <ns1:t/>
+            </ns1:r>
+          </ns1:p>
+          <ns1:p>
+            <ns1:r>
+              <ns1:t/>
+            </ns1:r>
+          </ns1:p>
+          <ns1:p>
+            <ns1:r>
+              <ns1:t/>
+            </ns1:r>
+          </ns1:p>
+          <ns1:p>
+            <ns1:r>
+              <ns1:t/>
+            </ns1:r>
+          </ns1:p>
+          <ns1:p>
+            <ns1:r>
+              <ns1:t/>
+            </ns1:r>
+          </ns1:p>
+          <ns1:p>
+            <ns1:r>
+              <ns1:t/>
+            </ns1:r>
+          </ns1:p>
+        </ns0:txBody>
+      </ns0:sp>
+      <ns0:sp>
+        <ns0:nvSpPr>
+          <ns0:cNvPr id="4" name="Slide Number Placeholder 3"/>
+          <ns0:cNvSpPr>
+            <ns1:spLocks noGrp="1"/>
+          </ns0:cNvSpPr>
+          <ns0:nvPr>
+            <ns0:ph type="sldNum" idx="5"/>
+          </ns0:nvPr>
+        </ns0:nvSpPr>
+        <ns0:spPr/>
+        <ns0:txBody>
+          <ns1:bodyPr/>
+          <ns1:lstStyle/>
+          <ns1:p/>
+        </ns0:txBody>
+      </ns0:sp>
+    </ns0:spTree>
+  </ns0:cSld>
+  <ns0:clrMapOvr>
+    <ns1:masterClrMapping/>
+  </ns0:clrMapOvr>
+</ns0:notes>
 </file>
 
 <file path=ppt/notesSlides/notesSlide2.xml><?xml version="1.0" encoding="utf-8"?>
-<p:notes xmlns:p="http://schemas.openxmlformats.org/presentationml/2006/main">
-  <p:cSld>
-    <p:spTree>
-      <p:nvGrpSpPr>
-        <p:cNvPr id="1" name=""/>
-        <p:cNvGrpSpPr/>
-        <p:nvPr/>
-      </p:nvGrpSpPr>
-      <p:grpSpPr>
-        <a:xfrm xmlns:a="http://schemas.openxmlformats.org/drawingml/2006/main"/>
-      </p:grpSpPr>
-      <p:sp>
-        <p:nvSpPr>
-          <p:cNvPr id="2" name="Slide Image Placeholder 1"/>
-          <p:cNvSpPr>
-            <a:spLocks xmlns:a="http://schemas.openxmlformats.org/drawingml/2006/main" noGrp="1"/>
-          </p:cNvSpPr>
-          <p:nvPr>
-            <p:ph type="sldImg" idx="0"/>
-          </p:nvPr>
-        </p:nvSpPr>
-        <p:spPr/>
-      </p:sp>
-      <p:sp>
-        <p:nvSpPr>
-          <p:cNvPr id="3" name="Notes Placeholder 2"/>
-          <p:cNvSpPr>
-            <a:spLocks xmlns:a="http://schemas.openxmlformats.org/drawingml/2006/main" noGrp="1"/>
-          </p:cNvSpPr>
-          <p:nvPr>
-            <p:ph type="body" idx="1"/>
-          </p:nvPr>
-        </p:nvSpPr>
-        <p:spPr/>
-        <p:txBody>
-          <a:bodyPr xmlns:a="http://schemas.openxmlformats.org/drawingml/2006/main"/>
-          <a:lstStyle xmlns:a="http://schemas.openxmlformats.org/drawingml/2006/main"/>
-          <a:p xmlns:a="http://schemas.openxmlformats.org/drawingml/2006/main">
-            <a:r>
-              <a:t>[목표 45초 / 행동: 두 질문을 읽고 잠깐 쉽니다.]</a:t>
-            </a:r>
-          </a:p>
-          <a:p xmlns:a="http://schemas.openxmlformats.org/drawingml/2006/main">
-            <a:r>
-              <a:t/>
-            </a:r>
-          </a:p>
-          <a:p xmlns:a="http://schemas.openxmlformats.org/drawingml/2006/main">
-            <a:r>
-              <a:t>여행 준비할 때 이런 일이 있습니다. 숙소 체크아웃 시간이 궁금해서 확인 메일을 다시 찾고, 식당 하나를 고르려고 지도와 예약 사이트를 번갈아 보게 됩니다. 마지막에는 그 식당에 들렀다가 다음 예약에 늦지 않을지도 계산해야 하고요.</a:t>
-            </a:r>
-          </a:p>
-          <a:p xmlns:a="http://schemas.openxmlformats.org/drawingml/2006/main">
-            <a:r>
-              <a:t/>
-            </a:r>
-          </a:p>
-          <a:p xmlns:a="http://schemas.openxmlformats.org/drawingml/2006/main">
-            <a:r>
-              <a:t>문제는 정보가 없다는 것보다, 이미 있는 정보를 제가 계속 다시 정리해야 한다는 점이었습니다. 그래서 처음에는 메일을 읽고 질문에 답하는 기능을 만들었습니다. 여기에 장소 탐색과 일정 편집을 연결해서, 정리한 정보를 다음 단계에서도 그대로 쓸 수 있게 확장했습니다.</a:t>
-            </a:r>
-          </a:p>
-          <a:p xmlns:a="http://schemas.openxmlformats.org/drawingml/2006/main">
-            <a:r>
-              <a:t/>
-            </a:r>
-          </a:p>
-          <a:p xmlns:a="http://schemas.openxmlformats.org/drawingml/2006/main">
-            <a:r>
-              <a:t>[근거·검증 범위 / 낭독하지 않음]</a:t>
-            </a:r>
-          </a:p>
-          <a:p xmlns:a="http://schemas.openxmlformats.org/drawingml/2006/main">
-            <a:r>
-              <a:t>https://github.com/Jin-s-work/Travel-Agent/blob/main/docs/service-v3/PRD.md</a:t>
-            </a:r>
-          </a:p>
-        </p:txBody>
-      </p:sp>
-      <p:sp>
-        <p:nvSpPr>
-          <p:cNvPr id="4" name="Slide Number Placeholder 3"/>
-          <p:cNvSpPr>
-            <a:spLocks xmlns:a="http://schemas.openxmlformats.org/drawingml/2006/main" noGrp="1"/>
-          </p:cNvSpPr>
-          <p:nvPr>
-            <p:ph type="sldNum" idx="5"/>
-          </p:nvPr>
-        </p:nvSpPr>
-        <p:spPr/>
-        <p:txBody>
-          <a:bodyPr xmlns:a="http://schemas.openxmlformats.org/drawingml/2006/main"/>
-          <a:lstStyle xmlns:a="http://schemas.openxmlformats.org/drawingml/2006/main"/>
-          <a:p xmlns:a="http://schemas.openxmlformats.org/drawingml/2006/main"/>
-        </p:txBody>
-      </p:sp>
-    </p:spTree>
-  </p:cSld>
-  <p:clrMapOvr>
-    <a:masterClrMapping xmlns:a="http://schemas.openxmlformats.org/drawingml/2006/main"/>
-  </p:clrMapOvr>
-</p:notes>
+<ns0:notes xmlns:ns0="http://schemas.openxmlformats.org/presentationml/2006/main" xmlns:ns1="http://schemas.openxmlformats.org/drawingml/2006/main">
+  <ns0:cSld>
+    <ns0:spTree>
+      <ns0:nvGrpSpPr>
+        <ns0:cNvPr id="1" name=""/>
+        <ns0:cNvGrpSpPr/>
+        <ns0:nvPr/>
+      </ns0:nvGrpSpPr>
+      <ns0:grpSpPr>
+        <ns1:xfrm/>
+      </ns0:grpSpPr>
+      <ns0:sp>
+        <ns0:nvSpPr>
+          <ns0:cNvPr id="2" name="Slide Image Placeholder 1"/>
+          <ns0:cNvSpPr>
+            <ns1:spLocks noGrp="1"/>
+          </ns0:cNvSpPr>
+          <ns0:nvPr>
+            <ns0:ph type="sldImg" idx="0"/>
+          </ns0:nvPr>
+        </ns0:nvSpPr>
+        <ns0:spPr/>
+      </ns0:sp>
+      <ns0:sp>
+        <ns0:nvSpPr>
+          <ns0:cNvPr id="3" name="Notes Placeholder 2"/>
+          <ns0:cNvSpPr>
+            <ns1:spLocks noGrp="1"/>
+          </ns0:cNvSpPr>
+          <ns0:nvPr>
+            <ns0:ph type="body" idx="1"/>
+          </ns0:nvPr>
+        </ns0:nvSpPr>
+        <ns0:spPr/>
+        <ns0:txBody>
+          <ns1:bodyPr/>
+          <ns1:lstStyle/>
+          <ns1:p>
+            <ns1:r>
+              <ns1:t/>
+            </ns1:r>
+          </ns1:p>
+          <ns1:p>
+            <ns1:r>
+              <ns1:t/>
+            </ns1:r>
+          </ns1:p>
+          <ns1:p>
+            <ns1:r>
+              <ns1:t/>
+            </ns1:r>
+          </ns1:p>
+          <ns1:p>
+            <ns1:r>
+              <ns1:t/>
+            </ns1:r>
+          </ns1:p>
+          <ns1:p>
+            <ns1:r>
+              <ns1:t/>
+            </ns1:r>
+          </ns1:p>
+          <ns1:p>
+            <ns1:r>
+              <ns1:t/>
+            </ns1:r>
+          </ns1:p>
+          <ns1:p>
+            <ns1:r>
+              <ns1:t/>
+            </ns1:r>
+          </ns1:p>
+          <ns1:p>
+            <ns1:r>
+              <ns1:t/>
+            </ns1:r>
+          </ns1:p>
+        </ns0:txBody>
+      </ns0:sp>
+      <ns0:sp>
+        <ns0:nvSpPr>
+          <ns0:cNvPr id="4" name="Slide Number Placeholder 3"/>
+          <ns0:cNvSpPr>
+            <ns1:spLocks noGrp="1"/>
+          </ns0:cNvSpPr>
+          <ns0:nvPr>
+            <ns0:ph type="sldNum" idx="5"/>
+          </ns0:nvPr>
+        </ns0:nvSpPr>
+        <ns0:spPr/>
+        <ns0:txBody>
+          <ns1:bodyPr/>
+          <ns1:lstStyle/>
+          <ns1:p/>
+        </ns0:txBody>
+      </ns0:sp>
+    </ns0:spTree>
+  </ns0:cSld>
+  <ns0:clrMapOvr>
+    <ns1:masterClrMapping/>
+  </ns0:clrMapOvr>
+</ns0:notes>
 </file>
 
 <file path=ppt/notesSlides/notesSlide3.xml><?xml version="1.0" encoding="utf-8"?>
-<p:notes xmlns:p="http://schemas.openxmlformats.org/presentationml/2006/main">
-  <p:cSld>
-    <p:spTree>
-      <p:nvGrpSpPr>
-        <p:cNvPr id="1" name=""/>
-        <p:cNvGrpSpPr/>
-        <p:nvPr/>
-      </p:nvGrpSpPr>
-      <p:grpSpPr>
-        <a:xfrm xmlns:a="http://schemas.openxmlformats.org/drawingml/2006/main"/>
-      </p:grpSpPr>
-      <p:sp>
-        <p:nvSpPr>
-          <p:cNvPr id="2" name="Slide Image Placeholder 1"/>
-          <p:cNvSpPr>
-            <a:spLocks xmlns:a="http://schemas.openxmlformats.org/drawingml/2006/main" noGrp="1"/>
-          </p:cNvSpPr>
-          <p:nvPr>
-            <p:ph type="sldImg" idx="0"/>
-          </p:nvPr>
-        </p:nvSpPr>
-        <p:spPr/>
-      </p:sp>
-      <p:sp>
-        <p:nvSpPr>
-          <p:cNvPr id="3" name="Notes Placeholder 2"/>
-          <p:cNvSpPr>
-            <a:spLocks xmlns:a="http://schemas.openxmlformats.org/drawingml/2006/main" noGrp="1"/>
-          </p:cNvSpPr>
-          <p:nvPr>
-            <p:ph type="body" idx="1"/>
-          </p:nvPr>
-        </p:nvSpPr>
-        <p:spPr/>
-        <p:txBody>
-          <a:bodyPr xmlns:a="http://schemas.openxmlformats.org/drawingml/2006/main"/>
-          <a:lstStyle xmlns:a="http://schemas.openxmlformats.org/drawingml/2006/main"/>
-          <a:p xmlns:a="http://schemas.openxmlformats.org/drawingml/2006/main">
-            <a:r>
-              <a:t>[목표 45초 / 행동: 도시·기간과 세 가지 시작 버튼을 가리킵니다.]</a:t>
-            </a:r>
-          </a:p>
-          <a:p xmlns:a="http://schemas.openxmlformats.org/drawingml/2006/main">
-            <a:r>
-              <a:t/>
-            </a:r>
-          </a:p>
-          <a:p xmlns:a="http://schemas.openxmlformats.org/drawingml/2006/main">
-            <a:r>
-              <a:t>이게 현재 홈 화면입니다. 먼저 여행할 도시와 날짜를 입력합니다. 그러면 여기에서 예약 메일을 올리거나, 장소를 찾거나, 일정을 만들 수 있습니다.</a:t>
-            </a:r>
-          </a:p>
-          <a:p xmlns:a="http://schemas.openxmlformats.org/drawingml/2006/main">
-            <a:r>
-              <a:t/>
-            </a:r>
-          </a:p>
-          <a:p xmlns:a="http://schemas.openxmlformats.org/drawingml/2006/main">
-            <a:r>
-              <a:t>기능을 추가하면서 오히려 사용이 번거로워진 적도 있었는데요. 화면마다 같은 도시와 날짜를 입력하게 되거나, 숙소가 없으면 다음 단계가 막히는 식이었습니다. 그래서 여행에 입력한 정보는 다른 화면에서도 이어받도록 바꿨습니다. 숙소는 나중에 추가해도 되고, 자세한 조건도 필요할 때만 설정합니다. 기능 수보다 처음 들어온 사람이 어디를 눌러야 할지 보이는 게 더 중요하다고 생각했습니다.</a:t>
-            </a:r>
-          </a:p>
-          <a:p xmlns:a="http://schemas.openxmlformats.org/drawingml/2006/main">
-            <a:r>
-              <a:t/>
-            </a:r>
-          </a:p>
-          <a:p xmlns:a="http://schemas.openxmlformats.org/drawingml/2006/main">
-            <a:r>
-              <a:t>[근거·검증 범위 / 낭독하지 않음]</a:t>
-            </a:r>
-          </a:p>
-          <a:p xmlns:a="http://schemas.openxmlformats.org/drawingml/2006/main">
-            <a:r>
-              <a:t>https://github.com/Jin-s-work/Travel-Agent/blob/main/web/index.html</a:t>
-            </a:r>
-          </a:p>
-          <a:p xmlns:a="http://schemas.openxmlformats.org/drawingml/2006/main">
-            <a:r>
-              <a:t>https://github.com/Jin-s-work/Travel-Agent/blob/main/web/js/foundation.js</a:t>
-            </a:r>
-          </a:p>
-          <a:p xmlns:a="http://schemas.openxmlformats.org/drawingml/2006/main">
-            <a:r>
-              <a:t>화면은 현재 코드와 합성 계정·메일·예약으로 촬영. 실제 운영 개인 자료를 공개하지 않음.</a:t>
-            </a:r>
-          </a:p>
-        </p:txBody>
-      </p:sp>
-      <p:sp>
-        <p:nvSpPr>
-          <p:cNvPr id="4" name="Slide Number Placeholder 3"/>
-          <p:cNvSpPr>
-            <a:spLocks xmlns:a="http://schemas.openxmlformats.org/drawingml/2006/main" noGrp="1"/>
-          </p:cNvSpPr>
-          <p:nvPr>
-            <p:ph type="sldNum" idx="5"/>
-          </p:nvPr>
-        </p:nvSpPr>
-        <p:spPr/>
-        <p:txBody>
-          <a:bodyPr xmlns:a="http://schemas.openxmlformats.org/drawingml/2006/main"/>
-          <a:lstStyle xmlns:a="http://schemas.openxmlformats.org/drawingml/2006/main"/>
-          <a:p xmlns:a="http://schemas.openxmlformats.org/drawingml/2006/main"/>
-        </p:txBody>
-      </p:sp>
-    </p:spTree>
-  </p:cSld>
-  <p:clrMapOvr>
-    <a:masterClrMapping xmlns:a="http://schemas.openxmlformats.org/drawingml/2006/main"/>
-  </p:clrMapOvr>
-</p:notes>
+<ns0:notes xmlns:ns0="http://schemas.openxmlformats.org/presentationml/2006/main" xmlns:ns1="http://schemas.openxmlformats.org/drawingml/2006/main">
+  <ns0:cSld>
+    <ns0:spTree>
+      <ns0:nvGrpSpPr>
+        <ns0:cNvPr id="1" name=""/>
+        <ns0:cNvGrpSpPr/>
+        <ns0:nvPr/>
+      </ns0:nvGrpSpPr>
+      <ns0:grpSpPr>
+        <ns1:xfrm/>
+      </ns0:grpSpPr>
+      <ns0:sp>
+        <ns0:nvSpPr>
+          <ns0:cNvPr id="2" name="Slide Image Placeholder 1"/>
+          <ns0:cNvSpPr>
+            <ns1:spLocks noGrp="1"/>
+          </ns0:cNvSpPr>
+          <ns0:nvPr>
+            <ns0:ph type="sldImg" idx="0"/>
+          </ns0:nvPr>
+        </ns0:nvSpPr>
+        <ns0:spPr/>
+      </ns0:sp>
+      <ns0:sp>
+        <ns0:nvSpPr>
+          <ns0:cNvPr id="3" name="Notes Placeholder 2"/>
+          <ns0:cNvSpPr>
+            <ns1:spLocks noGrp="1"/>
+          </ns0:cNvSpPr>
+          <ns0:nvPr>
+            <ns0:ph type="body" idx="1"/>
+          </ns0:nvPr>
+        </ns0:nvSpPr>
+        <ns0:spPr/>
+        <ns0:txBody>
+          <ns1:bodyPr/>
+          <ns1:lstStyle/>
+          <ns1:p>
+            <ns1:r>
+              <ns1:t/>
+            </ns1:r>
+          </ns1:p>
+          <ns1:p>
+            <ns1:r>
+              <ns1:t/>
+            </ns1:r>
+          </ns1:p>
+          <ns1:p>
+            <ns1:r>
+              <ns1:t/>
+            </ns1:r>
+          </ns1:p>
+          <ns1:p>
+            <ns1:r>
+              <ns1:t/>
+            </ns1:r>
+          </ns1:p>
+          <ns1:p>
+            <ns1:r>
+              <ns1:t/>
+            </ns1:r>
+          </ns1:p>
+          <ns1:p>
+            <ns1:r>
+              <ns1:t/>
+            </ns1:r>
+          </ns1:p>
+          <ns1:p>
+            <ns1:r>
+              <ns1:t/>
+            </ns1:r>
+          </ns1:p>
+          <ns1:p>
+            <ns1:r>
+              <ns1:t/>
+            </ns1:r>
+          </ns1:p>
+          <ns1:p>
+            <ns1:r>
+              <ns1:t/>
+            </ns1:r>
+          </ns1:p>
+          <ns1:p>
+            <ns1:r>
+              <ns1:t/>
+            </ns1:r>
+          </ns1:p>
+        </ns0:txBody>
+      </ns0:sp>
+      <ns0:sp>
+        <ns0:nvSpPr>
+          <ns0:cNvPr id="4" name="Slide Number Placeholder 3"/>
+          <ns0:cNvSpPr>
+            <ns1:spLocks noGrp="1"/>
+          </ns0:cNvSpPr>
+          <ns0:nvPr>
+            <ns0:ph type="sldNum" idx="5"/>
+          </ns0:nvPr>
+        </ns0:nvSpPr>
+        <ns0:spPr/>
+        <ns0:txBody>
+          <ns1:bodyPr/>
+          <ns1:lstStyle/>
+          <ns1:p/>
+        </ns0:txBody>
+      </ns0:sp>
+    </ns0:spTree>
+  </ns0:cSld>
+  <ns0:clrMapOvr>
+    <ns1:masterClrMapping/>
+  </ns0:clrMapOvr>
+</ns0:notes>
 </file>
 
 <file path=ppt/notesSlides/notesSlide4.xml><?xml version="1.0" encoding="utf-8"?>
-<p:notes xmlns:p="http://schemas.openxmlformats.org/presentationml/2006/main">
-  <p:cSld>
-    <p:spTree>
-      <p:nvGrpSpPr>
-        <p:cNvPr id="1" name=""/>
-        <p:cNvGrpSpPr/>
-        <p:nvPr/>
-      </p:nvGrpSpPr>
-      <p:grpSpPr>
-        <a:xfrm xmlns:a="http://schemas.openxmlformats.org/drawingml/2006/main"/>
-      </p:grpSpPr>
-      <p:sp>
-        <p:nvSpPr>
-          <p:cNvPr id="2" name="Slide Image Placeholder 1"/>
-          <p:cNvSpPr>
-            <a:spLocks xmlns:a="http://schemas.openxmlformats.org/drawingml/2006/main" noGrp="1"/>
-          </p:cNvSpPr>
-          <p:nvPr>
-            <p:ph type="sldImg" idx="0"/>
-          </p:nvPr>
-        </p:nvSpPr>
-        <p:spPr/>
-      </p:sp>
-      <p:sp>
-        <p:nvSpPr>
-          <p:cNvPr id="3" name="Notes Placeholder 2"/>
-          <p:cNvSpPr>
-            <a:spLocks xmlns:a="http://schemas.openxmlformats.org/drawingml/2006/main" noGrp="1"/>
-          </p:cNvSpPr>
-          <p:nvPr>
-            <p:ph type="body" idx="1"/>
-          </p:nvPr>
-        </p:nvSpPr>
-        <p:spPr/>
-        <p:txBody>
-          <a:bodyPr xmlns:a="http://schemas.openxmlformats.org/drawingml/2006/main"/>
-          <a:lstStyle xmlns:a="http://schemas.openxmlformats.org/drawingml/2006/main"/>
-          <a:p xmlns:a="http://schemas.openxmlformats.org/drawingml/2006/main">
-            <a:r>
-              <a:t>[목표 55초 / 행동: 추출 결과와 사용자 교정의 차이를 설명합니다.]</a:t>
-            </a:r>
-          </a:p>
-          <a:p xmlns:a="http://schemas.openxmlformats.org/drawingml/2006/main">
-            <a:r>
-              <a:t/>
-            </a:r>
-          </a:p>
-          <a:p xmlns:a="http://schemas.openxmlformats.org/drawingml/2006/main">
-            <a:r>
-              <a:t>예약 메일을 올리면 날짜와 시간, 장소 같은 정보를 예약 항목으로 정리합니다. 운영에서는 오픈에이아이의 지피티 파이브 미니를 사용하고, 검색용 임베딩은 별도 모델로 만듭니다.</a:t>
-            </a:r>
-          </a:p>
-          <a:p xmlns:a="http://schemas.openxmlformats.org/drawingml/2006/main">
-            <a:r>
-              <a:t/>
-            </a:r>
-          </a:p>
-          <a:p xmlns:a="http://schemas.openxmlformats.org/drawingml/2006/main">
-            <a:r>
-              <a:t>여기서 신경 쓴 부분은 추출한 결과를 바로 정답으로 확정하지 않는 것입니다. 한 메일에 예약이 여러 개 있으면 나눠 저장하고, 사용자가 고친 값은 원문에서 읽은 값과 따로 보관합니다. 다시 분석하다가 실패해도 기존 예약은 남아 있어야 하고요.</a:t>
-            </a:r>
-          </a:p>
-          <a:p xmlns:a="http://schemas.openxmlformats.org/drawingml/2006/main">
-            <a:r>
-              <a:t/>
-            </a:r>
-          </a:p>
-          <a:p xmlns:a="http://schemas.openxmlformats.org/drawingml/2006/main">
-            <a:r>
-              <a:t>지금 보이는 화면은 가상 메일을 기본 분석한 예시입니다. 운영 AI 호출 검증은 별도로 기록했습니다. 결과를 보고 직접 고칠 수 있게 한 것이 이 화면의 핵심입니다.</a:t>
-            </a:r>
-          </a:p>
-          <a:p xmlns:a="http://schemas.openxmlformats.org/drawingml/2006/main">
-            <a:r>
-              <a:t/>
-            </a:r>
-          </a:p>
-          <a:p xmlns:a="http://schemas.openxmlformats.org/drawingml/2006/main">
-            <a:r>
-              <a:t>[근거·검증 범위 / 낭독하지 않음]</a:t>
-            </a:r>
-          </a:p>
-          <a:p xmlns:a="http://schemas.openxmlformats.org/drawingml/2006/main">
-            <a:r>
-              <a:t>https://github.com/Jin-s-work/Travel-Agent/blob/main/src/foundation/documents.py</a:t>
-            </a:r>
-          </a:p>
-          <a:p xmlns:a="http://schemas.openxmlformats.org/drawingml/2006/main">
-            <a:r>
-              <a:t>https://github.com/Jin-s-work/Travel-Agent/blob/main/docs/service-v3/reports/journey-layout-openai-validation.md</a:t>
-            </a:r>
-          </a:p>
-          <a:p xmlns:a="http://schemas.openxmlformats.org/drawingml/2006/main">
-            <a:r>
-              <a:t>화면은 현재 코드와 합성 계정·메일·예약으로 촬영. 실제 운영 개인 자료를 공개하지 않음.</a:t>
-            </a:r>
-          </a:p>
-          <a:p xmlns:a="http://schemas.openxmlformats.org/drawingml/2006/main">
-            <a:r>
-              <a:t>정확한 모델명: gpt-5-mini, text-embedding-3-small.</a:t>
-            </a:r>
-          </a:p>
-        </p:txBody>
-      </p:sp>
-      <p:sp>
-        <p:nvSpPr>
-          <p:cNvPr id="4" name="Slide Number Placeholder 3"/>
-          <p:cNvSpPr>
-            <a:spLocks xmlns:a="http://schemas.openxmlformats.org/drawingml/2006/main" noGrp="1"/>
-          </p:cNvSpPr>
-          <p:nvPr>
-            <p:ph type="sldNum" idx="5"/>
-          </p:nvPr>
-        </p:nvSpPr>
-        <p:spPr/>
-        <p:txBody>
-          <a:bodyPr xmlns:a="http://schemas.openxmlformats.org/drawingml/2006/main"/>
-          <a:lstStyle xmlns:a="http://schemas.openxmlformats.org/drawingml/2006/main"/>
-          <a:p xmlns:a="http://schemas.openxmlformats.org/drawingml/2006/main"/>
-        </p:txBody>
-      </p:sp>
-    </p:spTree>
-  </p:cSld>
-  <p:clrMapOvr>
-    <a:masterClrMapping xmlns:a="http://schemas.openxmlformats.org/drawingml/2006/main"/>
-  </p:clrMapOvr>
-</p:notes>
+<ns0:notes xmlns:ns0="http://schemas.openxmlformats.org/presentationml/2006/main" xmlns:ns1="http://schemas.openxmlformats.org/drawingml/2006/main">
+  <ns0:cSld>
+    <ns0:spTree>
+      <ns0:nvGrpSpPr>
+        <ns0:cNvPr id="1" name=""/>
+        <ns0:cNvGrpSpPr/>
+        <ns0:nvPr/>
+      </ns0:nvGrpSpPr>
+      <ns0:grpSpPr>
+        <ns1:xfrm/>
+      </ns0:grpSpPr>
+      <ns0:sp>
+        <ns0:nvSpPr>
+          <ns0:cNvPr id="2" name="Slide Image Placeholder 1"/>
+          <ns0:cNvSpPr>
+            <ns1:spLocks noGrp="1"/>
+          </ns0:cNvSpPr>
+          <ns0:nvPr>
+            <ns0:ph type="sldImg" idx="0"/>
+          </ns0:nvPr>
+        </ns0:nvSpPr>
+        <ns0:spPr/>
+      </ns0:sp>
+      <ns0:sp>
+        <ns0:nvSpPr>
+          <ns0:cNvPr id="3" name="Notes Placeholder 2"/>
+          <ns0:cNvSpPr>
+            <ns1:spLocks noGrp="1"/>
+          </ns0:cNvSpPr>
+          <ns0:nvPr>
+            <ns0:ph type="body" idx="1"/>
+          </ns0:nvPr>
+        </ns0:nvSpPr>
+        <ns0:spPr/>
+        <ns0:txBody>
+          <ns1:bodyPr/>
+          <ns1:lstStyle/>
+          <ns1:p>
+            <ns1:r>
+              <ns1:t/>
+            </ns1:r>
+          </ns1:p>
+          <ns1:p>
+            <ns1:r>
+              <ns1:t/>
+            </ns1:r>
+          </ns1:p>
+          <ns1:p>
+            <ns1:r>
+              <ns1:t/>
+            </ns1:r>
+          </ns1:p>
+          <ns1:p>
+            <ns1:r>
+              <ns1:t/>
+            </ns1:r>
+          </ns1:p>
+          <ns1:p>
+            <ns1:r>
+              <ns1:t/>
+            </ns1:r>
+          </ns1:p>
+          <ns1:p>
+            <ns1:r>
+              <ns1:t/>
+            </ns1:r>
+          </ns1:p>
+          <ns1:p>
+            <ns1:r>
+              <ns1:t/>
+            </ns1:r>
+          </ns1:p>
+          <ns1:p>
+            <ns1:r>
+              <ns1:t/>
+            </ns1:r>
+          </ns1:p>
+          <ns1:p>
+            <ns1:r>
+              <ns1:t/>
+            </ns1:r>
+          </ns1:p>
+          <ns1:p>
+            <ns1:r>
+              <ns1:t/>
+            </ns1:r>
+          </ns1:p>
+          <ns1:p>
+            <ns1:r>
+              <ns1:t/>
+            </ns1:r>
+          </ns1:p>
+          <ns1:p>
+            <ns1:r>
+              <ns1:t/>
+            </ns1:r>
+          </ns1:p>
+          <ns1:p>
+            <ns1:r>
+              <ns1:t/>
+            </ns1:r>
+          </ns1:p>
+        </ns0:txBody>
+      </ns0:sp>
+      <ns0:sp>
+        <ns0:nvSpPr>
+          <ns0:cNvPr id="4" name="Slide Number Placeholder 3"/>
+          <ns0:cNvSpPr>
+            <ns1:spLocks noGrp="1"/>
+          </ns0:cNvSpPr>
+          <ns0:nvPr>
+            <ns0:ph type="sldNum" idx="5"/>
+          </ns0:nvPr>
+        </ns0:nvSpPr>
+        <ns0:spPr/>
+        <ns0:txBody>
+          <ns1:bodyPr/>
+          <ns1:lstStyle/>
+          <ns1:p/>
+        </ns0:txBody>
+      </ns0:sp>
+    </ns0:spTree>
+  </ns0:cSld>
+  <ns0:clrMapOvr>
+    <ns1:masterClrMapping/>
+  </ns0:clrMapOvr>
+</ns0:notes>
 </file>
 
 <file path=ppt/notesSlides/notesSlide5.xml><?xml version="1.0" encoding="utf-8"?>
-<p:notes xmlns:p="http://schemas.openxmlformats.org/presentationml/2006/main">
-  <p:cSld>
-    <p:spTree>
-      <p:nvGrpSpPr>
-        <p:cNvPr id="1" name=""/>
-        <p:cNvGrpSpPr/>
-        <p:nvPr/>
-      </p:nvGrpSpPr>
-      <p:grpSpPr>
-        <a:xfrm xmlns:a="http://schemas.openxmlformats.org/drawingml/2006/main"/>
-      </p:grpSpPr>
-      <p:sp>
-        <p:nvSpPr>
-          <p:cNvPr id="2" name="Slide Image Placeholder 1"/>
-          <p:cNvSpPr>
-            <a:spLocks xmlns:a="http://schemas.openxmlformats.org/drawingml/2006/main" noGrp="1"/>
-          </p:cNvSpPr>
-          <p:nvPr>
-            <p:ph type="sldImg" idx="0"/>
-          </p:nvPr>
-        </p:nvSpPr>
-        <p:spPr/>
-      </p:sp>
-      <p:sp>
-        <p:nvSpPr>
-          <p:cNvPr id="3" name="Notes Placeholder 2"/>
-          <p:cNvSpPr>
-            <a:spLocks xmlns:a="http://schemas.openxmlformats.org/drawingml/2006/main" noGrp="1"/>
-          </p:cNvSpPr>
-          <p:nvPr>
-            <p:ph type="body" idx="1"/>
-          </p:nvPr>
-        </p:nvSpPr>
-        <p:spPr/>
-        <p:txBody>
-          <a:bodyPr xmlns:a="http://schemas.openxmlformats.org/drawingml/2006/main"/>
-          <a:lstStyle xmlns:a="http://schemas.openxmlformats.org/drawingml/2006/main"/>
-          <a:p xmlns:a="http://schemas.openxmlformats.org/drawingml/2006/main">
-            <a:r>
-              <a:t>[목표 60초 / 행동: 왼쪽 결과와 오른쪽 원문 보기를 가리킵니다.]</a:t>
-            </a:r>
-          </a:p>
-          <a:p xmlns:a="http://schemas.openxmlformats.org/drawingml/2006/main">
-            <a:r>
-              <a:t/>
-            </a:r>
-          </a:p>
-          <a:p xmlns:a="http://schemas.openxmlformats.org/drawingml/2006/main">
-            <a:r>
-              <a:t>이제 “둘째 날 예약을 전부 알려줘”라고 물어볼 수 있습니다. 왼쪽은 답변이고, 오른쪽은 그 답변의 근거입니다. 메일에서 가져온 내용과 직접 입력한 예약을 구분해서 볼 수 있습니다.</a:t>
-            </a:r>
-          </a:p>
-          <a:p xmlns:a="http://schemas.openxmlformats.org/drawingml/2006/main">
-            <a:r>
-              <a:t/>
-            </a:r>
-          </a:p>
-          <a:p xmlns:a="http://schemas.openxmlformats.org/drawingml/2006/main">
-            <a:r>
-              <a:t>이 질문은 단순히 AI에게 잘 답해 달라고 해서는 부족했습니다. 의미가 비슷한 문서를 몇 개만 검색하면, 같은 날 예약이 여덟 개여도 일부가 빠질 수 있기 때문입니다. 그래서 하루 전체를 묻는 질문은 데이터베이스에서 그 날짜의 예약을 모두 조회하게 했습니다.</a:t>
-            </a:r>
-          </a:p>
-          <a:p xmlns:a="http://schemas.openxmlformats.org/drawingml/2006/main">
-            <a:r>
-              <a:t/>
-            </a:r>
-          </a:p>
-          <a:p xmlns:a="http://schemas.openxmlformats.org/drawingml/2006/main">
-            <a:r>
-              <a:t>반대로 환불 규정처럼 본문의 설명을 찾아야 하는 질문에는 검색을 사용합니다. 질문의 성격에 맞춰 방법을 나누고, 사용자가 원문까지 확인할 수 있도록 했습니다.</a:t>
-            </a:r>
-          </a:p>
-          <a:p xmlns:a="http://schemas.openxmlformats.org/drawingml/2006/main">
-            <a:r>
-              <a:t/>
-            </a:r>
-          </a:p>
-          <a:p xmlns:a="http://schemas.openxmlformats.org/drawingml/2006/main">
-            <a:r>
-              <a:t>[근거·검증 범위 / 낭독하지 않음]</a:t>
-            </a:r>
-          </a:p>
-          <a:p xmlns:a="http://schemas.openxmlformats.org/drawingml/2006/main">
-            <a:r>
-              <a:t>https://github.com/Jin-s-work/Travel-Agent/blob/main/src/foundation/search.py</a:t>
-            </a:r>
-          </a:p>
-          <a:p xmlns:a="http://schemas.openxmlformats.org/drawingml/2006/main">
-            <a:r>
-              <a:t>https://github.com/Jin-s-work/Travel-Agent/blob/main/docs/service-v2/FOUNDATION_RUNBOOK.md</a:t>
-            </a:r>
-          </a:p>
-          <a:p xmlns:a="http://schemas.openxmlformats.org/drawingml/2006/main">
-            <a:r>
-              <a:t>화면은 현재 코드와 합성 계정·메일·예약으로 촬영. 실제 운영 개인 자료를 공개하지 않음.</a:t>
-            </a:r>
-          </a:p>
-        </p:txBody>
-      </p:sp>
-      <p:sp>
-        <p:nvSpPr>
-          <p:cNvPr id="4" name="Slide Number Placeholder 3"/>
-          <p:cNvSpPr>
-            <a:spLocks xmlns:a="http://schemas.openxmlformats.org/drawingml/2006/main" noGrp="1"/>
-          </p:cNvSpPr>
-          <p:nvPr>
-            <p:ph type="sldNum" idx="5"/>
-          </p:nvPr>
-        </p:nvSpPr>
-        <p:spPr/>
-        <p:txBody>
-          <a:bodyPr xmlns:a="http://schemas.openxmlformats.org/drawingml/2006/main"/>
-          <a:lstStyle xmlns:a="http://schemas.openxmlformats.org/drawingml/2006/main"/>
-          <a:p xmlns:a="http://schemas.openxmlformats.org/drawingml/2006/main"/>
-        </p:txBody>
-      </p:sp>
-    </p:spTree>
-  </p:cSld>
-  <p:clrMapOvr>
-    <a:masterClrMapping xmlns:a="http://schemas.openxmlformats.org/drawingml/2006/main"/>
-  </p:clrMapOvr>
-</p:notes>
+<ns0:notes xmlns:ns0="http://schemas.openxmlformats.org/presentationml/2006/main" xmlns:ns1="http://schemas.openxmlformats.org/drawingml/2006/main">
+  <ns0:cSld>
+    <ns0:spTree>
+      <ns0:nvGrpSpPr>
+        <ns0:cNvPr id="1" name=""/>
+        <ns0:cNvGrpSpPr/>
+        <ns0:nvPr/>
+      </ns0:nvGrpSpPr>
+      <ns0:grpSpPr>
+        <ns1:xfrm/>
+      </ns0:grpSpPr>
+      <ns0:sp>
+        <ns0:nvSpPr>
+          <ns0:cNvPr id="2" name="Slide Image Placeholder 1"/>
+          <ns0:cNvSpPr>
+            <ns1:spLocks noGrp="1"/>
+          </ns0:cNvSpPr>
+          <ns0:nvPr>
+            <ns0:ph type="sldImg" idx="0"/>
+          </ns0:nvPr>
+        </ns0:nvSpPr>
+        <ns0:spPr/>
+      </ns0:sp>
+      <ns0:sp>
+        <ns0:nvSpPr>
+          <ns0:cNvPr id="3" name="Notes Placeholder 2"/>
+          <ns0:cNvSpPr>
+            <ns1:spLocks noGrp="1"/>
+          </ns0:cNvSpPr>
+          <ns0:nvPr>
+            <ns0:ph type="body" idx="1"/>
+          </ns0:nvPr>
+        </ns0:nvSpPr>
+        <ns0:spPr/>
+        <ns0:txBody>
+          <ns1:bodyPr/>
+          <ns1:lstStyle/>
+          <ns1:p>
+            <ns1:r>
+              <ns1:t/>
+            </ns1:r>
+          </ns1:p>
+          <ns1:p>
+            <ns1:r>
+              <ns1:t/>
+            </ns1:r>
+          </ns1:p>
+          <ns1:p>
+            <ns1:r>
+              <ns1:t/>
+            </ns1:r>
+          </ns1:p>
+          <ns1:p>
+            <ns1:r>
+              <ns1:t/>
+            </ns1:r>
+          </ns1:p>
+          <ns1:p>
+            <ns1:r>
+              <ns1:t/>
+            </ns1:r>
+          </ns1:p>
+          <ns1:p>
+            <ns1:r>
+              <ns1:t/>
+            </ns1:r>
+          </ns1:p>
+          <ns1:p>
+            <ns1:r>
+              <ns1:t/>
+            </ns1:r>
+          </ns1:p>
+          <ns1:p>
+            <ns1:r>
+              <ns1:t/>
+            </ns1:r>
+          </ns1:p>
+          <ns1:p>
+            <ns1:r>
+              <ns1:t/>
+            </ns1:r>
+          </ns1:p>
+          <ns1:p>
+            <ns1:r>
+              <ns1:t/>
+            </ns1:r>
+          </ns1:p>
+          <ns1:p>
+            <ns1:r>
+              <ns1:t/>
+            </ns1:r>
+          </ns1:p>
+          <ns1:p>
+            <ns1:r>
+              <ns1:t/>
+            </ns1:r>
+          </ns1:p>
+        </ns0:txBody>
+      </ns0:sp>
+      <ns0:sp>
+        <ns0:nvSpPr>
+          <ns0:cNvPr id="4" name="Slide Number Placeholder 3"/>
+          <ns0:cNvSpPr>
+            <ns1:spLocks noGrp="1"/>
+          </ns0:cNvSpPr>
+          <ns0:nvPr>
+            <ns0:ph type="sldNum" idx="5"/>
+          </ns0:nvPr>
+        </ns0:nvSpPr>
+        <ns0:spPr/>
+        <ns0:txBody>
+          <ns1:bodyPr/>
+          <ns1:lstStyle/>
+          <ns1:p/>
+        </ns0:txBody>
+      </ns0:sp>
+    </ns0:spTree>
+  </ns0:cSld>
+  <ns0:clrMapOvr>
+    <ns1:masterClrMapping/>
+  </ns0:clrMapOvr>
+</ns0:notes>
 </file>
 
 <file path=ppt/notesSlides/notesSlide6.xml><?xml version="1.0" encoding="utf-8"?>
-<p:notes xmlns:p="http://schemas.openxmlformats.org/presentationml/2006/main">
-  <p:cSld>
-    <p:spTree>
-      <p:nvGrpSpPr>
-        <p:cNvPr id="1" name=""/>
-        <p:cNvGrpSpPr/>
-        <p:nvPr/>
-      </p:nvGrpSpPr>
-      <p:grpSpPr>
-        <a:xfrm xmlns:a="http://schemas.openxmlformats.org/drawingml/2006/main"/>
-      </p:grpSpPr>
-      <p:sp>
-        <p:nvSpPr>
-          <p:cNvPr id="2" name="Slide Image Placeholder 1"/>
-          <p:cNvSpPr>
-            <a:spLocks xmlns:a="http://schemas.openxmlformats.org/drawingml/2006/main" noGrp="1"/>
-          </p:cNvSpPr>
-          <p:nvPr>
-            <p:ph type="sldImg" idx="0"/>
-          </p:nvPr>
-        </p:nvSpPr>
-        <p:spPr/>
-      </p:sp>
-      <p:sp>
-        <p:nvSpPr>
-          <p:cNvPr id="3" name="Notes Placeholder 2"/>
-          <p:cNvSpPr>
-            <a:spLocks xmlns:a="http://schemas.openxmlformats.org/drawingml/2006/main" noGrp="1"/>
-          </p:cNvSpPr>
-          <p:nvPr>
-            <p:ph type="body" idx="1"/>
-          </p:nvPr>
-        </p:nvSpPr>
-        <p:spPr/>
-        <p:txBody>
-          <a:bodyPr xmlns:a="http://schemas.openxmlformats.org/drawingml/2006/main"/>
-          <a:lstStyle xmlns:a="http://schemas.openxmlformats.org/drawingml/2006/main"/>
-          <a:p xmlns:a="http://schemas.openxmlformats.org/drawingml/2006/main">
-            <a:r>
-              <a:t>[목표 55초 / 행동: 사진과 방문 전 확인 필요 문구를 가리킵니다.]</a:t>
-            </a:r>
-          </a:p>
-          <a:p xmlns:a="http://schemas.openxmlformats.org/drawingml/2006/main">
-            <a:r>
-              <a:t/>
-            </a:r>
-          </a:p>
-          <a:p xmlns:a="http://schemas.openxmlformats.org/drawingml/2006/main">
-            <a:r>
-              <a:t>예약을 정리한 다음에는 가고 싶은 장소를 찾습니다. 현지 분위기의 식당을 찾는 경우와, 유명한 명소를 보고 싶은 경우를 나눴습니다. 음식점이나 카페 같은 분류는 따로 고를 수 있습니다.</a:t>
-            </a:r>
-          </a:p>
-          <a:p xmlns:a="http://schemas.openxmlformats.org/drawingml/2006/main">
-            <a:r>
-              <a:t/>
-            </a:r>
-          </a:p>
-          <a:p xmlns:a="http://schemas.openxmlformats.org/drawingml/2006/main">
-            <a:r>
-              <a:t>이 화면은 마드리드의 실제 식당 자료입니다. 지점과 이용 권한을 확인한 사진이 있으면 실내나 음식 사진도 보여줍니다. 상세 정보를 보고 최대 세 곳을 비교할 수 있고, 숙소 위치가 확인되면 거리 조건도 적용할 수 있습니다.</a:t>
-            </a:r>
-          </a:p>
-          <a:p xmlns:a="http://schemas.openxmlformats.org/drawingml/2006/main">
-            <a:r>
-              <a:t/>
-            </a:r>
-          </a:p>
-          <a:p xmlns:a="http://schemas.openxmlformats.org/drawingml/2006/main">
-            <a:r>
-              <a:t>다만 사진이 있다고 그날 예약할 수 있다는 뜻은 아닙니다. 영업이나 인원 조건을 확인하지 못한 곳은 확인 필요로 남깁니다. 직선거리와 실제 도보시간도 구분해서 보여주도록 했습니다.</a:t>
-            </a:r>
-          </a:p>
-          <a:p xmlns:a="http://schemas.openxmlformats.org/drawingml/2006/main">
-            <a:r>
-              <a:t/>
-            </a:r>
-          </a:p>
-          <a:p xmlns:a="http://schemas.openxmlformats.org/drawingml/2006/main">
-            <a:r>
-              <a:t>[근거·검증 범위 / 낭독하지 않음]</a:t>
-            </a:r>
-          </a:p>
-          <a:p xmlns:a="http://schemas.openxmlformats.org/drawingml/2006/main">
-            <a:r>
-              <a:t>https://github.com/Jin-s-work/Travel-Agent/blob/main/docs/service-v3/reports/going-design-search-validation.md</a:t>
-            </a:r>
-          </a:p>
-          <a:p xmlns:a="http://schemas.openxmlformats.org/drawingml/2006/main">
-            <a:r>
-              <a:t>https://github.com/Jin-s-work/Travel-Agent/blob/main/src/discovery/restaurant_photos.json</a:t>
-            </a:r>
-          </a:p>
-          <a:p xmlns:a="http://schemas.openxmlformats.org/drawingml/2006/main">
-            <a:r>
-              <a:t>화면은 현재 코드와 합성 계정·메일·예약으로 촬영. 실제 운영 개인 자료를 공개하지 않음.</a:t>
-            </a:r>
-          </a:p>
-          <a:p xmlns:a="http://schemas.openxmlformats.org/drawingml/2006/main">
-            <a:r>
-              <a:t>사진: Javier Lastras, Barra de Casa Lucio, CC BY 2.0 https://commons.wikimedia.org/wiki/File:Barra_de_Casa_Lucio_(4245090907).jpg https://creativecommons.org/licenses/by/2.0/</a:t>
-            </a:r>
-          </a:p>
-          <a:p xmlns:a="http://schemas.openxmlformats.org/drawingml/2006/main">
-            <a:r>
-              <a:t>사진: Tamorlan, Gallina en Pepitoria (Ciriaco), CC BY-SA 3.0 https://commons.wikimedia.org/wiki/File:Gallina_en_Pepitoria_(Ciriaco).JPG https://creativecommons.org/licenses/by-sa/3.0/</a:t>
-            </a:r>
-          </a:p>
-          <a:p xmlns:a="http://schemas.openxmlformats.org/drawingml/2006/main">
-            <a:r>
-              <a:t>사진은 앱 화면 내 크기 조정·크롭. 사진에 대한 원 라이선스를 유지. 상세 CREDITS.md 참조.</a:t>
-            </a:r>
-          </a:p>
-        </p:txBody>
-      </p:sp>
-      <p:sp>
-        <p:nvSpPr>
-          <p:cNvPr id="4" name="Slide Number Placeholder 3"/>
-          <p:cNvSpPr>
-            <a:spLocks xmlns:a="http://schemas.openxmlformats.org/drawingml/2006/main" noGrp="1"/>
-          </p:cNvSpPr>
-          <p:nvPr>
-            <p:ph type="sldNum" idx="5"/>
-          </p:nvPr>
-        </p:nvSpPr>
-        <p:spPr/>
-        <p:txBody>
-          <a:bodyPr xmlns:a="http://schemas.openxmlformats.org/drawingml/2006/main"/>
-          <a:lstStyle xmlns:a="http://schemas.openxmlformats.org/drawingml/2006/main"/>
-          <a:p xmlns:a="http://schemas.openxmlformats.org/drawingml/2006/main"/>
-        </p:txBody>
-      </p:sp>
-    </p:spTree>
-  </p:cSld>
-  <p:clrMapOvr>
-    <a:masterClrMapping xmlns:a="http://schemas.openxmlformats.org/drawingml/2006/main"/>
-  </p:clrMapOvr>
-</p:notes>
+<ns0:notes xmlns:ns0="http://schemas.openxmlformats.org/presentationml/2006/main" xmlns:ns1="http://schemas.openxmlformats.org/drawingml/2006/main">
+  <ns0:cSld>
+    <ns0:spTree>
+      <ns0:nvGrpSpPr>
+        <ns0:cNvPr id="1" name=""/>
+        <ns0:cNvGrpSpPr/>
+        <ns0:nvPr/>
+      </ns0:nvGrpSpPr>
+      <ns0:grpSpPr>
+        <ns1:xfrm/>
+      </ns0:grpSpPr>
+      <ns0:sp>
+        <ns0:nvSpPr>
+          <ns0:cNvPr id="2" name="Slide Image Placeholder 1"/>
+          <ns0:cNvSpPr>
+            <ns1:spLocks noGrp="1"/>
+          </ns0:cNvSpPr>
+          <ns0:nvPr>
+            <ns0:ph type="sldImg" idx="0"/>
+          </ns0:nvPr>
+        </ns0:nvSpPr>
+        <ns0:spPr/>
+      </ns0:sp>
+      <ns0:sp>
+        <ns0:nvSpPr>
+          <ns0:cNvPr id="3" name="Notes Placeholder 2"/>
+          <ns0:cNvSpPr>
+            <ns1:spLocks noGrp="1"/>
+          </ns0:cNvSpPr>
+          <ns0:nvPr>
+            <ns0:ph type="body" idx="1"/>
+          </ns0:nvPr>
+        </ns0:nvSpPr>
+        <ns0:spPr/>
+        <ns0:txBody>
+          <ns1:bodyPr/>
+          <ns1:lstStyle/>
+          <ns1:p>
+            <ns1:r>
+              <ns1:t/>
+            </ns1:r>
+          </ns1:p>
+          <ns1:p>
+            <ns1:r>
+              <ns1:t/>
+            </ns1:r>
+          </ns1:p>
+          <ns1:p>
+            <ns1:r>
+              <ns1:t/>
+            </ns1:r>
+          </ns1:p>
+          <ns1:p>
+            <ns1:r>
+              <ns1:t/>
+            </ns1:r>
+          </ns1:p>
+          <ns1:p>
+            <ns1:r>
+              <ns1:t/>
+            </ns1:r>
+          </ns1:p>
+          <ns1:p>
+            <ns1:r>
+              <ns1:t/>
+            </ns1:r>
+          </ns1:p>
+          <ns1:p>
+            <ns1:r>
+              <ns1:t/>
+            </ns1:r>
+          </ns1:p>
+          <ns1:p>
+            <ns1:r>
+              <ns1:t/>
+            </ns1:r>
+          </ns1:p>
+          <ns1:p>
+            <ns1:r>
+              <ns1:t/>
+            </ns1:r>
+          </ns1:p>
+          <ns1:p>
+            <ns1:r>
+              <ns1:t/>
+            </ns1:r>
+          </ns1:p>
+          <ns1:p>
+            <ns1:r>
+              <ns1:t/>
+            </ns1:r>
+          </ns1:p>
+          <ns1:p>
+            <ns1:r>
+              <ns1:t/>
+            </ns1:r>
+          </ns1:p>
+          <ns1:p>
+            <ns1:r>
+              <ns1:t/>
+            </ns1:r>
+          </ns1:p>
+          <ns1:p>
+            <ns1:r>
+              <ns1:t/>
+            </ns1:r>
+          </ns1:p>
+          <ns1:p>
+            <ns1:r>
+              <ns1:t/>
+            </ns1:r>
+          </ns1:p>
+        </ns0:txBody>
+      </ns0:sp>
+      <ns0:sp>
+        <ns0:nvSpPr>
+          <ns0:cNvPr id="4" name="Slide Number Placeholder 3"/>
+          <ns0:cNvSpPr>
+            <ns1:spLocks noGrp="1"/>
+          </ns0:cNvSpPr>
+          <ns0:nvPr>
+            <ns0:ph type="sldNum" idx="5"/>
+          </ns0:nvPr>
+        </ns0:nvSpPr>
+        <ns0:spPr/>
+        <ns0:txBody>
+          <ns1:bodyPr/>
+          <ns1:lstStyle/>
+          <ns1:p/>
+        </ns0:txBody>
+      </ns0:sp>
+    </ns0:spTree>
+  </ns0:cSld>
+  <ns0:clrMapOvr>
+    <ns1:masterClrMapping/>
+  </ns0:clrMapOvr>
+</ns0:notes>
 </file>
 
 <file path=ppt/notesSlides/notesSlide7.xml><?xml version="1.0" encoding="utf-8"?>
-<p:notes xmlns:p="http://schemas.openxmlformats.org/presentationml/2006/main">
-  <p:cSld>
-    <p:spTree>
-      <p:nvGrpSpPr>
-        <p:cNvPr id="1" name=""/>
-        <p:cNvGrpSpPr/>
-        <p:nvPr/>
-      </p:nvGrpSpPr>
-      <p:grpSpPr>
-        <a:xfrm xmlns:a="http://schemas.openxmlformats.org/drawingml/2006/main"/>
-      </p:grpSpPr>
-      <p:sp>
-        <p:nvSpPr>
-          <p:cNvPr id="2" name="Slide Image Placeholder 1"/>
-          <p:cNvSpPr>
-            <a:spLocks xmlns:a="http://schemas.openxmlformats.org/drawingml/2006/main" noGrp="1"/>
-          </p:cNvSpPr>
-          <p:nvPr>
-            <p:ph type="sldImg" idx="0"/>
-          </p:nvPr>
-        </p:nvSpPr>
-        <p:spPr/>
-      </p:sp>
-      <p:sp>
-        <p:nvSpPr>
-          <p:cNvPr id="3" name="Notes Placeholder 2"/>
-          <p:cNvSpPr>
-            <a:spLocks xmlns:a="http://schemas.openxmlformats.org/drawingml/2006/main" noGrp="1"/>
-          </p:cNvSpPr>
-          <p:nvPr>
-            <p:ph type="body" idx="1"/>
-          </p:nvPr>
-        </p:nvSpPr>
-        <p:spPr/>
-        <p:txBody>
-          <a:bodyPr xmlns:a="http://schemas.openxmlformats.org/drawingml/2006/main"/>
-          <a:lstStyle xmlns:a="http://schemas.openxmlformats.org/drawingml/2006/main"/>
-          <a:p xmlns:a="http://schemas.openxmlformats.org/drawingml/2006/main">
-            <a:r>
-              <a:t>[목표 50초 / 행동: 엄격 리뷰 추천이 OFF인 이유를 말합니다.]</a:t>
-            </a:r>
-          </a:p>
-          <a:p xmlns:a="http://schemas.openxmlformats.org/drawingml/2006/main">
-            <a:r>
-              <a:t/>
-            </a:r>
-          </a:p>
-          <a:p xmlns:a="http://schemas.openxmlformats.org/drawingml/2006/main">
-            <a:r>
-              <a:t>처음에 특히 만들고 싶었던 건, 현지 언어 리뷰가 많고 한국어 리뷰는 적은 장소를 찾는 기능이었습니다.</a:t>
-            </a:r>
-          </a:p>
-          <a:p xmlns:a="http://schemas.openxmlformats.org/drawingml/2006/main">
-            <a:r>
-              <a:t/>
-            </a:r>
-          </a:p>
-          <a:p xmlns:a="http://schemas.openxmlformats.org/drawingml/2006/main">
-            <a:r>
-              <a:t>그런데 일본어 리뷰가 많다고 작성자가 모두 일본 주민이라고 할 수는 없더라고요. 일부 리뷰만 가져와서 전체 리뷰의 비율처럼 보여주는 것도 정확하지 않습니다. 그래서 관측한 기간과 건수, 언어를 판단하지 못한 리뷰를 따로 기록하도록 만들었습니다.</a:t>
-            </a:r>
-          </a:p>
-          <a:p xmlns:a="http://schemas.openxmlformats.org/drawingml/2006/main">
-            <a:r>
-              <a:t/>
-            </a:r>
-          </a:p>
-          <a:p xmlns:a="http://schemas.openxmlformats.org/drawingml/2006/main">
-            <a:r>
-              <a:t>계산 로직과 평가 도구는 구현했지만, 실제 데이터의 이용 범위와 언어 판별 품질을 확인하기 전까지 엄격한 리뷰 추천은 꺼 두었습니다. 아직 확인하지 못한 내용을 추천 근거처럼 보여주지 않는 것이 기준입니다.</a:t>
-            </a:r>
-          </a:p>
-          <a:p xmlns:a="http://schemas.openxmlformats.org/drawingml/2006/main">
-            <a:r>
-              <a:t/>
-            </a:r>
-          </a:p>
-          <a:p xmlns:a="http://schemas.openxmlformats.org/drawingml/2006/main">
-            <a:r>
-              <a:t>[근거·검증 범위 / 낭독하지 않음]</a:t>
-            </a:r>
-          </a:p>
-          <a:p xmlns:a="http://schemas.openxmlformats.org/drawingml/2006/main">
-            <a:r>
-              <a:t>https://github.com/Jin-s-work/Travel-Agent/blob/main/docs/service-v2/REVIEW_DATA_SPEC.md</a:t>
-            </a:r>
-          </a:p>
-        </p:txBody>
-      </p:sp>
-      <p:sp>
-        <p:nvSpPr>
-          <p:cNvPr id="4" name="Slide Number Placeholder 3"/>
-          <p:cNvSpPr>
-            <a:spLocks xmlns:a="http://schemas.openxmlformats.org/drawingml/2006/main" noGrp="1"/>
-          </p:cNvSpPr>
-          <p:nvPr>
-            <p:ph type="sldNum" idx="5"/>
-          </p:nvPr>
-        </p:nvSpPr>
-        <p:spPr/>
-        <p:txBody>
-          <a:bodyPr xmlns:a="http://schemas.openxmlformats.org/drawingml/2006/main"/>
-          <a:lstStyle xmlns:a="http://schemas.openxmlformats.org/drawingml/2006/main"/>
-          <a:p xmlns:a="http://schemas.openxmlformats.org/drawingml/2006/main"/>
-        </p:txBody>
-      </p:sp>
-    </p:spTree>
-  </p:cSld>
-  <p:clrMapOvr>
-    <a:masterClrMapping xmlns:a="http://schemas.openxmlformats.org/drawingml/2006/main"/>
-  </p:clrMapOvr>
-</p:notes>
+<ns0:notes xmlns:ns0="http://schemas.openxmlformats.org/presentationml/2006/main" xmlns:ns1="http://schemas.openxmlformats.org/drawingml/2006/main">
+  <ns0:cSld>
+    <ns0:spTree>
+      <ns0:nvGrpSpPr>
+        <ns0:cNvPr id="1" name=""/>
+        <ns0:cNvGrpSpPr/>
+        <ns0:nvPr/>
+      </ns0:nvGrpSpPr>
+      <ns0:grpSpPr>
+        <ns1:xfrm/>
+      </ns0:grpSpPr>
+      <ns0:sp>
+        <ns0:nvSpPr>
+          <ns0:cNvPr id="2" name="Slide Image Placeholder 1"/>
+          <ns0:cNvSpPr>
+            <ns1:spLocks noGrp="1"/>
+          </ns0:cNvSpPr>
+          <ns0:nvPr>
+            <ns0:ph type="sldImg" idx="0"/>
+          </ns0:nvPr>
+        </ns0:nvSpPr>
+        <ns0:spPr/>
+      </ns0:sp>
+      <ns0:sp>
+        <ns0:nvSpPr>
+          <ns0:cNvPr id="3" name="Notes Placeholder 2"/>
+          <ns0:cNvSpPr>
+            <ns1:spLocks noGrp="1"/>
+          </ns0:cNvSpPr>
+          <ns0:nvPr>
+            <ns0:ph type="body" idx="1"/>
+          </ns0:nvPr>
+        </ns0:nvSpPr>
+        <ns0:spPr/>
+        <ns0:txBody>
+          <ns1:bodyPr/>
+          <ns1:lstStyle/>
+          <ns1:p>
+            <ns1:r>
+              <ns1:t/>
+            </ns1:r>
+          </ns1:p>
+          <ns1:p>
+            <ns1:r>
+              <ns1:t/>
+            </ns1:r>
+          </ns1:p>
+          <ns1:p>
+            <ns1:r>
+              <ns1:t/>
+            </ns1:r>
+          </ns1:p>
+          <ns1:p>
+            <ns1:r>
+              <ns1:t/>
+            </ns1:r>
+          </ns1:p>
+          <ns1:p>
+            <ns1:r>
+              <ns1:t/>
+            </ns1:r>
+          </ns1:p>
+          <ns1:p>
+            <ns1:r>
+              <ns1:t/>
+            </ns1:r>
+          </ns1:p>
+          <ns1:p>
+            <ns1:r>
+              <ns1:t/>
+            </ns1:r>
+          </ns1:p>
+          <ns1:p>
+            <ns1:r>
+              <ns1:t/>
+            </ns1:r>
+          </ns1:p>
+          <ns1:p>
+            <ns1:r>
+              <ns1:t/>
+            </ns1:r>
+          </ns1:p>
+          <ns1:p>
+            <ns1:r>
+              <ns1:t/>
+            </ns1:r>
+          </ns1:p>
+        </ns0:txBody>
+      </ns0:sp>
+      <ns0:sp>
+        <ns0:nvSpPr>
+          <ns0:cNvPr id="4" name="Slide Number Placeholder 3"/>
+          <ns0:cNvSpPr>
+            <ns1:spLocks noGrp="1"/>
+          </ns0:cNvSpPr>
+          <ns0:nvPr>
+            <ns0:ph type="sldNum" idx="5"/>
+          </ns0:nvPr>
+        </ns0:nvSpPr>
+        <ns0:spPr/>
+        <ns0:txBody>
+          <ns1:bodyPr/>
+          <ns1:lstStyle/>
+          <ns1:p/>
+        </ns0:txBody>
+      </ns0:sp>
+    </ns0:spTree>
+  </ns0:cSld>
+  <ns0:clrMapOvr>
+    <ns1:masterClrMapping/>
+  </ns0:clrMapOvr>
+</ns0:notes>
 </file>
 
 <file path=ppt/notesSlides/notesSlide8.xml><?xml version="1.0" encoding="utf-8"?>
-<p:notes xmlns:p="http://schemas.openxmlformats.org/presentationml/2006/main">
-  <p:cSld>
-    <p:spTree>
-      <p:nvGrpSpPr>
-        <p:cNvPr id="1" name=""/>
-        <p:cNvGrpSpPr/>
-        <p:nvPr/>
-      </p:nvGrpSpPr>
-      <p:grpSpPr>
-        <a:xfrm xmlns:a="http://schemas.openxmlformats.org/drawingml/2006/main"/>
-      </p:grpSpPr>
-      <p:sp>
-        <p:nvSpPr>
-          <p:cNvPr id="2" name="Slide Image Placeholder 1"/>
-          <p:cNvSpPr>
-            <a:spLocks xmlns:a="http://schemas.openxmlformats.org/drawingml/2006/main" noGrp="1"/>
-          </p:cNvSpPr>
-          <p:nvPr>
-            <p:ph type="sldImg" idx="0"/>
-          </p:nvPr>
-        </p:nvSpPr>
-        <p:spPr/>
-      </p:sp>
-      <p:sp>
-        <p:nvSpPr>
-          <p:cNvPr id="3" name="Notes Placeholder 2"/>
-          <p:cNvSpPr>
-            <a:spLocks xmlns:a="http://schemas.openxmlformats.org/drawingml/2006/main" noGrp="1"/>
-          </p:cNvSpPr>
-          <p:nvPr>
-            <p:ph type="body" idx="1"/>
-          </p:nvPr>
-        </p:nvSpPr>
-        <p:spPr/>
-        <p:txBody>
-          <a:bodyPr xmlns:a="http://schemas.openxmlformats.org/drawingml/2006/main"/>
-          <a:lstStyle xmlns:a="http://schemas.openxmlformats.org/drawingml/2006/main"/>
-          <a:p xmlns:a="http://schemas.openxmlformats.org/drawingml/2006/main">
-            <a:r>
-              <a:t>[목표 60초 / 행동: 120분과 150분을 비교한 다음 편집 순서로 넘어갑니다.]</a:t>
-            </a:r>
-          </a:p>
-          <a:p xmlns:a="http://schemas.openxmlformats.org/drawingml/2006/main">
-            <a:r>
-              <a:t/>
-            </a:r>
-          </a:p>
-          <a:p xmlns:a="http://schemas.openxmlformats.org/drawingml/2006/main">
-            <a:r>
-              <a:t>일정에서는 이미 확정한 예약을 먼저 보존합니다. 예를 들어 점심이 오후 한 시에 끝나고 다음 예약이 세 시라면, 사이에 두 시간이 있습니다.</a:t>
-            </a:r>
-          </a:p>
-          <a:p xmlns:a="http://schemas.openxmlformats.org/drawingml/2006/main">
-            <a:r>
-              <a:t/>
-            </a:r>
-          </a:p>
-          <a:p xmlns:a="http://schemas.openxmlformats.org/drawingml/2006/main">
-            <a:r>
-              <a:t>그런데 새 장소에서 한 시간 반을 머물고, 오가는 데 각각 삼십 분이 걸리면 총 두 시간 반이 필요합니다. 체류시간만 보면 들어갈 것 같지만 실제로는 넣으면 안 되는 일정입니다. 이런 계산을 서버에서 검사합니다. 이동시간을 모를 때도 영 분으로 처리하지 않습니다.</a:t>
-            </a:r>
-          </a:p>
-          <a:p xmlns:a="http://schemas.openxmlformats.org/drawingml/2006/main">
-            <a:r>
-              <a:t/>
-            </a:r>
-          </a:p>
-          <a:p xmlns:a="http://schemas.openxmlformats.org/drawingml/2006/main">
-            <a:r>
-              <a:t>편집은 미리보기, 적용, 되돌리기 순서입니다. 뒤의 예약에 어떤 영향이 있는지 먼저 보고 적용합니다. 그리고 일정에서 항목을 빼는 것과 외부 예약을 취소하는 것은 별개입니다.</a:t>
-            </a:r>
-          </a:p>
-          <a:p xmlns:a="http://schemas.openxmlformats.org/drawingml/2006/main">
-            <a:r>
-              <a:t/>
-            </a:r>
-          </a:p>
-          <a:p xmlns:a="http://schemas.openxmlformats.org/drawingml/2006/main">
-            <a:r>
-              <a:t>[근거·검증 범위 / 낭독하지 않음]</a:t>
-            </a:r>
-          </a:p>
-          <a:p xmlns:a="http://schemas.openxmlformats.org/drawingml/2006/main">
-            <a:r>
-              <a:t>https://github.com/Jin-s-work/Travel-Agent/blob/main/docs/service-v2/ITINERARY_RUNBOOK.md</a:t>
-            </a:r>
-          </a:p>
-          <a:p xmlns:a="http://schemas.openxmlformats.org/drawingml/2006/main">
-            <a:r>
-              <a:t>화면은 현재 코드와 합성 계정·메일·예약으로 촬영. 실제 운영 개인 자료를 공개하지 않음.</a:t>
-            </a:r>
-          </a:p>
-          <a:p xmlns:a="http://schemas.openxmlformats.org/drawingml/2006/main">
-            <a:r>
-              <a:t>120분 창과150분 필요 시간은 합성 계산 예시. 오른쪽 앱 화면의 측정 경로값이 아님.</a:t>
-            </a:r>
-          </a:p>
-        </p:txBody>
-      </p:sp>
-      <p:sp>
-        <p:nvSpPr>
-          <p:cNvPr id="4" name="Slide Number Placeholder 3"/>
-          <p:cNvSpPr>
-            <a:spLocks xmlns:a="http://schemas.openxmlformats.org/drawingml/2006/main" noGrp="1"/>
-          </p:cNvSpPr>
-          <p:nvPr>
-            <p:ph type="sldNum" idx="5"/>
-          </p:nvPr>
-        </p:nvSpPr>
-        <p:spPr/>
-        <p:txBody>
-          <a:bodyPr xmlns:a="http://schemas.openxmlformats.org/drawingml/2006/main"/>
-          <a:lstStyle xmlns:a="http://schemas.openxmlformats.org/drawingml/2006/main"/>
-          <a:p xmlns:a="http://schemas.openxmlformats.org/drawingml/2006/main"/>
-        </p:txBody>
-      </p:sp>
-    </p:spTree>
-  </p:cSld>
-  <p:clrMapOvr>
-    <a:masterClrMapping xmlns:a="http://schemas.openxmlformats.org/drawingml/2006/main"/>
-  </p:clrMapOvr>
-</p:notes>
+<ns0:notes xmlns:ns0="http://schemas.openxmlformats.org/presentationml/2006/main" xmlns:ns1="http://schemas.openxmlformats.org/drawingml/2006/main">
+  <ns0:cSld>
+    <ns0:spTree>
+      <ns0:nvGrpSpPr>
+        <ns0:cNvPr id="1" name=""/>
+        <ns0:cNvGrpSpPr/>
+        <ns0:nvPr/>
+      </ns0:nvGrpSpPr>
+      <ns0:grpSpPr>
+        <ns1:xfrm/>
+      </ns0:grpSpPr>
+      <ns0:sp>
+        <ns0:nvSpPr>
+          <ns0:cNvPr id="2" name="Slide Image Placeholder 1"/>
+          <ns0:cNvSpPr>
+            <ns1:spLocks noGrp="1"/>
+          </ns0:cNvSpPr>
+          <ns0:nvPr>
+            <ns0:ph type="sldImg" idx="0"/>
+          </ns0:nvPr>
+        </ns0:nvSpPr>
+        <ns0:spPr/>
+      </ns0:sp>
+      <ns0:sp>
+        <ns0:nvSpPr>
+          <ns0:cNvPr id="3" name="Notes Placeholder 2"/>
+          <ns0:cNvSpPr>
+            <ns1:spLocks noGrp="1"/>
+          </ns0:cNvSpPr>
+          <ns0:nvPr>
+            <ns0:ph type="body" idx="1"/>
+          </ns0:nvPr>
+        </ns0:nvSpPr>
+        <ns0:spPr/>
+        <ns0:txBody>
+          <ns1:bodyPr/>
+          <ns1:lstStyle/>
+          <ns1:p>
+            <ns1:r>
+              <ns1:t/>
+            </ns1:r>
+          </ns1:p>
+          <ns1:p>
+            <ns1:r>
+              <ns1:t/>
+            </ns1:r>
+          </ns1:p>
+          <ns1:p>
+            <ns1:r>
+              <ns1:t/>
+            </ns1:r>
+          </ns1:p>
+          <ns1:p>
+            <ns1:r>
+              <ns1:t/>
+            </ns1:r>
+          </ns1:p>
+          <ns1:p>
+            <ns1:r>
+              <ns1:t/>
+            </ns1:r>
+          </ns1:p>
+          <ns1:p>
+            <ns1:r>
+              <ns1:t/>
+            </ns1:r>
+          </ns1:p>
+          <ns1:p>
+            <ns1:r>
+              <ns1:t/>
+            </ns1:r>
+          </ns1:p>
+          <ns1:p>
+            <ns1:r>
+              <ns1:t/>
+            </ns1:r>
+          </ns1:p>
+          <ns1:p>
+            <ns1:r>
+              <ns1:t/>
+            </ns1:r>
+          </ns1:p>
+          <ns1:p>
+            <ns1:r>
+              <ns1:t/>
+            </ns1:r>
+          </ns1:p>
+          <ns1:p>
+            <ns1:r>
+              <ns1:t/>
+            </ns1:r>
+          </ns1:p>
+          <ns1:p>
+            <ns1:r>
+              <ns1:t/>
+            </ns1:r>
+          </ns1:p>
+        </ns0:txBody>
+      </ns0:sp>
+      <ns0:sp>
+        <ns0:nvSpPr>
+          <ns0:cNvPr id="4" name="Slide Number Placeholder 3"/>
+          <ns0:cNvSpPr>
+            <ns1:spLocks noGrp="1"/>
+          </ns0:cNvSpPr>
+          <ns0:nvPr>
+            <ns0:ph type="sldNum" idx="5"/>
+          </ns0:nvPr>
+        </ns0:nvSpPr>
+        <ns0:spPr/>
+        <ns0:txBody>
+          <ns1:bodyPr/>
+          <ns1:lstStyle/>
+          <ns1:p/>
+        </ns0:txBody>
+      </ns0:sp>
+    </ns0:spTree>
+  </ns0:cSld>
+  <ns0:clrMapOvr>
+    <ns1:masterClrMapping/>
+  </ns0:clrMapOvr>
+</ns0:notes>
 </file>
 
 <file path=ppt/notesSlides/notesSlide9.xml><?xml version="1.0" encoding="utf-8"?>
-<p:notes xmlns:p="http://schemas.openxmlformats.org/presentationml/2006/main">
-  <p:cSld>
-    <p:spTree>
-      <p:nvGrpSpPr>
-        <p:cNvPr id="1" name=""/>
-        <p:cNvGrpSpPr/>
-        <p:nvPr/>
-      </p:nvGrpSpPr>
-      <p:grpSpPr>
-        <a:xfrm xmlns:a="http://schemas.openxmlformats.org/drawingml/2006/main"/>
-      </p:grpSpPr>
-      <p:sp>
-        <p:nvSpPr>
-          <p:cNvPr id="2" name="Slide Image Placeholder 1"/>
-          <p:cNvSpPr>
-            <a:spLocks xmlns:a="http://schemas.openxmlformats.org/drawingml/2006/main" noGrp="1"/>
-          </p:cNvSpPr>
-          <p:nvPr>
-            <p:ph type="sldImg" idx="0"/>
-          </p:nvPr>
-        </p:nvSpPr>
-        <p:spPr/>
-      </p:sp>
-      <p:sp>
-        <p:nvSpPr>
-          <p:cNvPr id="3" name="Notes Placeholder 2"/>
-          <p:cNvSpPr>
-            <a:spLocks xmlns:a="http://schemas.openxmlformats.org/drawingml/2006/main" noGrp="1"/>
-          </p:cNvSpPr>
-          <p:nvPr>
-            <p:ph type="body" idx="1"/>
-          </p:nvPr>
-        </p:nvSpPr>
-        <p:spPr/>
-        <p:txBody>
-          <a:bodyPr xmlns:a="http://schemas.openxmlformats.org/drawingml/2006/main"/>
-          <a:lstStyle xmlns:a="http://schemas.openxmlformats.org/drawingml/2006/main"/>
-          <a:p xmlns:a="http://schemas.openxmlformats.org/drawingml/2006/main">
-            <a:r>
-              <a:t>[목표 60초 / 행동: 세 가지 실패 상황과 대응을 짝지어 말합니다.]</a:t>
-            </a:r>
-          </a:p>
-          <a:p xmlns:a="http://schemas.openxmlformats.org/drawingml/2006/main">
-            <a:r>
-              <a:t/>
-            </a:r>
-          </a:p>
-          <a:p xmlns:a="http://schemas.openxmlformats.org/drawingml/2006/main">
-            <a:r>
-              <a:t>사용 중에 실패해도 자료를 계속 볼 수 있게 하는 작업도 필요했습니다. 분석 상태를 화면에만 두면 새로고침했을 때 진행 상황을 잃게 됩니다. 그래서 작업 번호와 상태를 데이터베이스에 저장했습니다.</a:t>
-            </a:r>
-          </a:p>
-          <a:p xmlns:a="http://schemas.openxmlformats.org/drawingml/2006/main">
-            <a:r>
-              <a:t/>
-            </a:r>
-          </a:p>
-          <a:p xmlns:a="http://schemas.openxmlformats.org/drawingml/2006/main">
-            <a:r>
-              <a:t>운영 데이터도 무료 서버의 임시 디스크에만 두지 않고 수파베이스에 보관하도록 바꿨습니다. 메일 원문은 비공개 저장소로 분리했고요.</a:t>
-            </a:r>
-          </a:p>
-          <a:p xmlns:a="http://schemas.openxmlformats.org/drawingml/2006/main">
-            <a:r>
-              <a:t/>
-            </a:r>
-          </a:p>
-          <a:p xmlns:a="http://schemas.openxmlformats.org/drawingml/2006/main">
-            <a:r>
-              <a:t>지도 검색이 계속 실패한 적도 있었습니다. 실제로 확인해 보니 운영 서버에서 기존 지도 서버로 연결이 거절되고 있었습니다. 포톤 검색으로 바꾼 뒤 런던의 실제 지점 자료를 받아 음식점 후보 열두 곳을 표시했고, 같은 조건의 재조회에서는 추가 지도 호출이 없었습니다. 다만 방문 가능 여부까지 검증한 열두 곳이라는 뜻은 아닙니다.</a:t>
-            </a:r>
-          </a:p>
-          <a:p xmlns:a="http://schemas.openxmlformats.org/drawingml/2006/main">
-            <a:r>
-              <a:t/>
-            </a:r>
-          </a:p>
-          <a:p xmlns:a="http://schemas.openxmlformats.org/drawingml/2006/main">
-            <a:r>
-              <a:t>[근거·검증 범위 / 낭독하지 않음]</a:t>
-            </a:r>
-          </a:p>
-          <a:p xmlns:a="http://schemas.openxmlformats.org/drawingml/2006/main">
-            <a:r>
-              <a:t>https://github.com/Jin-s-work/Travel-Agent/blob/main/docs/operations/RENDER_SUPABASE.md</a:t>
-            </a:r>
-          </a:p>
-          <a:p xmlns:a="http://schemas.openxmlformats.org/drawingml/2006/main">
-            <a:r>
-              <a:t>https://github.com/Jin-s-work/Travel-Agent/blob/main/docs/service-v3/reports/going-design-search-validation.md</a:t>
-            </a:r>
-          </a:p>
-        </p:txBody>
-      </p:sp>
-      <p:sp>
-        <p:nvSpPr>
-          <p:cNvPr id="4" name="Slide Number Placeholder 3"/>
-          <p:cNvSpPr>
-            <a:spLocks xmlns:a="http://schemas.openxmlformats.org/drawingml/2006/main" noGrp="1"/>
-          </p:cNvSpPr>
-          <p:nvPr>
-            <p:ph type="sldNum" idx="5"/>
-          </p:nvPr>
-        </p:nvSpPr>
-        <p:spPr/>
-        <p:txBody>
-          <a:bodyPr xmlns:a="http://schemas.openxmlformats.org/drawingml/2006/main"/>
-          <a:lstStyle xmlns:a="http://schemas.openxmlformats.org/drawingml/2006/main"/>
-          <a:p xmlns:a="http://schemas.openxmlformats.org/drawingml/2006/main"/>
-        </p:txBody>
-      </p:sp>
-    </p:spTree>
-  </p:cSld>
-  <p:clrMapOvr>
-    <a:masterClrMapping xmlns:a="http://schemas.openxmlformats.org/drawingml/2006/main"/>
-  </p:clrMapOvr>
-</p:notes>
+<ns0:notes xmlns:ns0="http://schemas.openxmlformats.org/presentationml/2006/main" xmlns:ns1="http://schemas.openxmlformats.org/drawingml/2006/main">
+  <ns0:cSld>
+    <ns0:spTree>
+      <ns0:nvGrpSpPr>
+        <ns0:cNvPr id="1" name=""/>
+        <ns0:cNvGrpSpPr/>
+        <ns0:nvPr/>
+      </ns0:nvGrpSpPr>
+      <ns0:grpSpPr>
+        <ns1:xfrm/>
+      </ns0:grpSpPr>
+      <ns0:sp>
+        <ns0:nvSpPr>
+          <ns0:cNvPr id="2" name="Slide Image Placeholder 1"/>
+          <ns0:cNvSpPr>
+            <ns1:spLocks noGrp="1"/>
+          </ns0:cNvSpPr>
+          <ns0:nvPr>
+            <ns0:ph type="sldImg" idx="0"/>
+          </ns0:nvPr>
+        </ns0:nvSpPr>
+        <ns0:spPr/>
+      </ns0:sp>
+      <ns0:sp>
+        <ns0:nvSpPr>
+          <ns0:cNvPr id="3" name="Notes Placeholder 2"/>
+          <ns0:cNvSpPr>
+            <ns1:spLocks noGrp="1"/>
+          </ns0:cNvSpPr>
+          <ns0:nvPr>
+            <ns0:ph type="body" idx="1"/>
+          </ns0:nvPr>
+        </ns0:nvSpPr>
+        <ns0:spPr/>
+        <ns0:txBody>
+          <ns1:bodyPr/>
+          <ns1:lstStyle/>
+          <ns1:p>
+            <ns1:r>
+              <ns1:t/>
+            </ns1:r>
+          </ns1:p>
+          <ns1:p>
+            <ns1:r>
+              <ns1:t/>
+            </ns1:r>
+          </ns1:p>
+          <ns1:p>
+            <ns1:r>
+              <ns1:t/>
+            </ns1:r>
+          </ns1:p>
+          <ns1:p>
+            <ns1:r>
+              <ns1:t/>
+            </ns1:r>
+          </ns1:p>
+          <ns1:p>
+            <ns1:r>
+              <ns1:t/>
+            </ns1:r>
+          </ns1:p>
+          <ns1:p>
+            <ns1:r>
+              <ns1:t/>
+            </ns1:r>
+          </ns1:p>
+          <ns1:p>
+            <ns1:r>
+              <ns1:t/>
+            </ns1:r>
+          </ns1:p>
+          <ns1:p>
+            <ns1:r>
+              <ns1:t/>
+            </ns1:r>
+          </ns1:p>
+          <ns1:p>
+            <ns1:r>
+              <ns1:t/>
+            </ns1:r>
+          </ns1:p>
+          <ns1:p>
+            <ns1:r>
+              <ns1:t/>
+            </ns1:r>
+          </ns1:p>
+          <ns1:p>
+            <ns1:r>
+              <ns1:t/>
+            </ns1:r>
+          </ns1:p>
+        </ns0:txBody>
+      </ns0:sp>
+      <ns0:sp>
+        <ns0:nvSpPr>
+          <ns0:cNvPr id="4" name="Slide Number Placeholder 3"/>
+          <ns0:cNvSpPr>
+            <ns1:spLocks noGrp="1"/>
+          </ns0:cNvSpPr>
+          <ns0:nvPr>
+            <ns0:ph type="sldNum" idx="5"/>
+          </ns0:nvPr>
+        </ns0:nvSpPr>
+        <ns0:spPr/>
+        <ns0:txBody>
+          <ns1:bodyPr/>
+          <ns1:lstStyle/>
+          <ns1:p/>
+        </ns0:txBody>
+      </ns0:sp>
+    </ns0:spTree>
+  </ns0:cSld>
+  <ns0:clrMapOvr>
+    <ns1:masterClrMapping/>
+  </ns0:clrMapOvr>
+</ns0:notes>
 </file>
 
 <file path=ppt/slideLayouts/slideLayout1.xml><?xml version="1.0" encoding="utf-8"?>

</xml_diff>